<commit_message>
Upload remaining project changes
</commit_message>
<xml_diff>
--- a/23CT113_Nhom02_NenTangCrowdfunding(TuTeFund)/Word+ppt Báo Cáo/Ppt Báo cáo Nhóm 2 - 23CT113.pptx
+++ b/23CT113_Nhom02_NenTangCrowdfunding(TuTeFund)/Word+ppt Báo Cáo/Ppt Báo cáo Nhóm 2 - 23CT113.pptx
@@ -11,6 +11,11 @@
     <p:sldId id="259" r:id="rId10"/>
     <p:sldId id="260" r:id="rId11"/>
     <p:sldId id="261" r:id="rId12"/>
+    <p:sldId id="262" r:id="rId13"/>
+    <p:sldId id="263" r:id="rId14"/>
+    <p:sldId id="264" r:id="rId15"/>
+    <p:sldId id="265" r:id="rId16"/>
+    <p:sldId id="266" r:id="rId17"/>
   </p:sldIdLst>
   <p:sldSz cx="9144000" cy="6858000" type="screen4x3"/>
   <p:notesSz cx="6858000" cy="9144000"/>
@@ -3109,7 +3114,45 @@
           <a:lstStyle/>
           <a:p>
             <a:r>
+              <a:rPr sz="4000" b="1">
+                <a:solidFill>
+                  <a:srgbClr val="1F3B63"/>
+                </a:solidFill>
+                <a:latin typeface="Times New Roman"/>
+              </a:rPr>
               <a:t>BÁO CÁO CUỐI KỲ</a:t>
+            </a:r>
+          </a:p>
+          <a:p>
+            <a:r>
+              <a:rPr sz="2200">
+                <a:latin typeface="Times New Roman"/>
+              </a:rPr>
+              <a:t>Môn: Kiểm thử phần mềm</a:t>
+            </a:r>
+          </a:p>
+          <a:p>
+            <a:r>
+              <a:rPr sz="2200" b="1">
+                <a:latin typeface="Times New Roman"/>
+              </a:rPr>
+              <a:t>Đề tài: Nền tảng crowdfunding Tử Tế Fund</a:t>
+            </a:r>
+          </a:p>
+          <a:p>
+            <a:r>
+              <a:rPr sz="2000">
+                <a:latin typeface="Times New Roman"/>
+              </a:rPr>
+              <a:t>Nhóm 02 – Lớp 23CT113 – Nguyễn Minh Phúc</a:t>
+            </a:r>
+          </a:p>
+          <a:p>
+            <a:r>
+              <a:rPr sz="1800">
+                <a:latin typeface="Times New Roman"/>
+              </a:rPr>
+              <a:t>27/10/2026</a:t>
             </a:r>
           </a:p>
         </p:txBody>
@@ -3128,22 +3171,470 @@
         <p:txBody>
           <a:bodyPr/>
           <a:lstStyle/>
-          <a:p>
-            <a:pPr/>
-            <a:r>
-              <a:t>Môn: Kiểm thử phần mềm</a:t>
-            </a:r>
-          </a:p>
-          <a:p>
-            <a:pPr/>
-            <a:r>
-              <a:t>Nhóm: 02</a:t>
-            </a:r>
-          </a:p>
-          <a:p>
-            <a:pPr/>
-            <a:r>
-              <a:t>Đề tài: Tử Tế Fund</a:t>
+          <a:p/>
+        </p:txBody>
+      </p:sp>
+    </p:spTree>
+  </p:cSld>
+  <p:clrMapOvr>
+    <a:masterClrMapping/>
+  </p:clrMapOvr>
+</p:sld>
+</file>
+
+<file path=ppt/slides/slide10.xml><?xml version="1.0" encoding="utf-8"?>
+<p:sld xmlns:a="http://schemas.openxmlformats.org/drawingml/2006/main" xmlns:p="http://schemas.openxmlformats.org/presentationml/2006/main" xmlns:r="http://schemas.openxmlformats.org/officeDocument/2006/relationships">
+  <p:cSld>
+    <p:spTree>
+      <p:nvGrpSpPr>
+        <p:cNvPr id="1" name=""/>
+        <p:cNvGrpSpPr/>
+        <p:nvPr/>
+      </p:nvGrpSpPr>
+      <p:grpSpPr/>
+      <p:sp>
+        <p:nvSpPr>
+          <p:cNvPr id="2" name="TextBox 1"/>
+          <p:cNvSpPr txBox="1"/>
+          <p:nvPr/>
+        </p:nvSpPr>
+        <p:spPr>
+          <a:xfrm>
+            <a:off x="540000" y="324000"/>
+            <a:ext cx="8243999" cy="684000"/>
+          </a:xfrm>
+          <a:prstGeom prst="rect">
+            <a:avLst/>
+          </a:prstGeom>
+          <a:noFill/>
+        </p:spPr>
+        <p:txBody>
+          <a:bodyPr wrap="square">
+            <a:spAutoFit/>
+          </a:bodyPr>
+          <a:lstStyle/>
+          <a:p>
+            <a:r>
+              <a:rPr sz="3000" b="1">
+                <a:solidFill>
+                  <a:srgbClr val="1F3B63"/>
+                </a:solidFill>
+                <a:latin typeface="Times New Roman"/>
+              </a:rPr>
+              <a:t>Đánh giá và khuyến nghị</a:t>
+            </a:r>
+          </a:p>
+        </p:txBody>
+      </p:sp>
+      <p:sp>
+        <p:nvSpPr>
+          <p:cNvPr id="3" name="TextBox 2"/>
+          <p:cNvSpPr txBox="1"/>
+          <p:nvPr/>
+        </p:nvSpPr>
+        <p:spPr>
+          <a:xfrm>
+            <a:off x="540000" y="6552000"/>
+            <a:ext cx="8243999" cy="324000"/>
+          </a:xfrm>
+          <a:prstGeom prst="rect">
+            <a:avLst/>
+          </a:prstGeom>
+          <a:noFill/>
+        </p:spPr>
+        <p:txBody>
+          <a:bodyPr wrap="none">
+            <a:spAutoFit/>
+          </a:bodyPr>
+          <a:lstStyle/>
+          <a:p>
+            <a:r>
+              <a:rPr sz="1100">
+                <a:solidFill>
+                  <a:srgbClr val="404040"/>
+                </a:solidFill>
+                <a:latin typeface="Times New Roman"/>
+              </a:rPr>
+              <a:t>Kiểm thử phần mềm – Nhóm 02 – 23CT113 – Tử Tế Fund</a:t>
+            </a:r>
+          </a:p>
+        </p:txBody>
+      </p:sp>
+      <p:sp>
+        <p:nvSpPr>
+          <p:cNvPr id="4" name="TextBox 3"/>
+          <p:cNvSpPr txBox="1"/>
+          <p:nvPr/>
+        </p:nvSpPr>
+        <p:spPr>
+          <a:xfrm>
+            <a:off x="540000" y="1224000"/>
+            <a:ext cx="8243999" cy="1655999"/>
+          </a:xfrm>
+          <a:prstGeom prst="rect">
+            <a:avLst/>
+          </a:prstGeom>
+          <a:noFill/>
+        </p:spPr>
+        <p:txBody>
+          <a:bodyPr wrap="square">
+            <a:spAutoFit/>
+          </a:bodyPr>
+          <a:lstStyle/>
+          <a:p>
+            <a:pPr>
+              <a:spcAft>
+                <a:spcPts val="900"/>
+              </a:spcAft>
+            </a:pPr>
+            <a:r>
+              <a:rPr sz="1800" b="0">
+                <a:solidFill>
+                  <a:srgbClr val="000000"/>
+                </a:solidFill>
+                <a:latin typeface="Times New Roman"/>
+              </a:rPr>
+              <a:t>• Đánh giá: build v1.0 đạt tốt module Login và Reward, ba module còn lại chưa hoàn thiện</a:t>
+            </a:r>
+          </a:p>
+          <a:p>
+            <a:pPr>
+              <a:spcAft>
+                <a:spcPts val="900"/>
+              </a:spcAft>
+            </a:pPr>
+            <a:r>
+              <a:rPr sz="1800" b="0">
+                <a:solidFill>
+                  <a:srgbClr val="000000"/>
+                </a:solidFill>
+                <a:latin typeface="Times New Roman"/>
+              </a:rPr>
+              <a:t>• Khuyến nghị:</a:t>
+            </a:r>
+          </a:p>
+        </p:txBody>
+      </p:sp>
+      <p:sp>
+        <p:nvSpPr>
+          <p:cNvPr id="5" name="TextBox 4"/>
+          <p:cNvSpPr txBox="1"/>
+          <p:nvPr/>
+        </p:nvSpPr>
+        <p:spPr>
+          <a:xfrm>
+            <a:off x="540000" y="2951999"/>
+            <a:ext cx="8243999" cy="3240000"/>
+          </a:xfrm>
+          <a:prstGeom prst="rect">
+            <a:avLst/>
+          </a:prstGeom>
+          <a:noFill/>
+        </p:spPr>
+        <p:txBody>
+          <a:bodyPr wrap="square">
+            <a:spAutoFit/>
+          </a:bodyPr>
+          <a:lstStyle/>
+          <a:p>
+            <a:pPr lvl="1">
+              <a:spcAft>
+                <a:spcPts val="900"/>
+              </a:spcAft>
+            </a:pPr>
+            <a:r>
+              <a:rPr sz="1300" b="0">
+                <a:solidFill>
+                  <a:srgbClr val="404040"/>
+                </a:solidFill>
+                <a:latin typeface="Times New Roman"/>
+              </a:rPr>
+              <a:t>– Sửa nhóm lỗi Critical/High trong sprint tới, chạy lại (retest) ở build v1.1</a:t>
+            </a:r>
+          </a:p>
+          <a:p>
+            <a:pPr lvl="1">
+              <a:spcAft>
+                <a:spcPts val="900"/>
+              </a:spcAft>
+            </a:pPr>
+            <a:r>
+              <a:rPr sz="1300" b="0">
+                <a:solidFill>
+                  <a:srgbClr val="404040"/>
+                </a:solidFill>
+                <a:latin typeface="Times New Roman"/>
+              </a:rPr>
+              <a:t>– Bổ sung lớp validation dùng chung cho các form để tránh lặp lỗi giữa module</a:t>
+            </a:r>
+          </a:p>
+          <a:p>
+            <a:pPr lvl="1">
+              <a:spcAft>
+                <a:spcPts val="900"/>
+              </a:spcAft>
+            </a:pPr>
+            <a:r>
+              <a:rPr sz="1300" b="0">
+                <a:solidFill>
+                  <a:srgbClr val="404040"/>
+                </a:solidFill>
+                <a:latin typeface="Times New Roman"/>
+              </a:rPr>
+              <a:t>– Nối API/CSDL cho Blog, Campaign, KYC – điều kiện để đạt Pass 90%</a:t>
+            </a:r>
+          </a:p>
+          <a:p>
+            <a:pPr lvl="1">
+              <a:spcAft>
+                <a:spcPts val="900"/>
+              </a:spcAft>
+            </a:pPr>
+            <a:r>
+              <a:rPr sz="1300" b="0">
+                <a:solidFill>
+                  <a:srgbClr val="404040"/>
+                </a:solidFill>
+                <a:latin typeface="Times New Roman"/>
+              </a:rPr>
+              <a:t>– Thêm kiểm thử tự động Playwright cho các luồng must-have</a:t>
+            </a:r>
+          </a:p>
+          <a:p>
+            <a:pPr lvl="1">
+              <a:spcAft>
+                <a:spcPts val="900"/>
+              </a:spcAft>
+            </a:pPr>
+            <a:r>
+              <a:rPr sz="1300" b="0">
+                <a:solidFill>
+                  <a:srgbClr val="404040"/>
+                </a:solidFill>
+                <a:latin typeface="Times New Roman"/>
+              </a:rPr>
+              <a:t>– Cập nhật cột Retest Result trong Bug Log sau mỗi lần sửa</a:t>
+            </a:r>
+          </a:p>
+        </p:txBody>
+      </p:sp>
+    </p:spTree>
+  </p:cSld>
+  <p:clrMapOvr>
+    <a:masterClrMapping/>
+  </p:clrMapOvr>
+</p:sld>
+</file>
+
+<file path=ppt/slides/slide11.xml><?xml version="1.0" encoding="utf-8"?>
+<p:sld xmlns:a="http://schemas.openxmlformats.org/drawingml/2006/main" xmlns:p="http://schemas.openxmlformats.org/presentationml/2006/main" xmlns:r="http://schemas.openxmlformats.org/officeDocument/2006/relationships">
+  <p:cSld>
+    <p:spTree>
+      <p:nvGrpSpPr>
+        <p:cNvPr id="1" name=""/>
+        <p:cNvGrpSpPr/>
+        <p:nvPr/>
+      </p:nvGrpSpPr>
+      <p:grpSpPr/>
+      <p:sp>
+        <p:nvSpPr>
+          <p:cNvPr id="2" name="TextBox 1"/>
+          <p:cNvSpPr txBox="1"/>
+          <p:nvPr/>
+        </p:nvSpPr>
+        <p:spPr>
+          <a:xfrm>
+            <a:off x="540000" y="324000"/>
+            <a:ext cx="8243999" cy="684000"/>
+          </a:xfrm>
+          <a:prstGeom prst="rect">
+            <a:avLst/>
+          </a:prstGeom>
+          <a:noFill/>
+        </p:spPr>
+        <p:txBody>
+          <a:bodyPr wrap="square">
+            <a:spAutoFit/>
+          </a:bodyPr>
+          <a:lstStyle/>
+          <a:p>
+            <a:r>
+              <a:rPr sz="3000" b="1">
+                <a:solidFill>
+                  <a:srgbClr val="1F3B63"/>
+                </a:solidFill>
+                <a:latin typeface="Times New Roman"/>
+              </a:rPr>
+              <a:t>Kết luận và bài học kinh nghiệm</a:t>
+            </a:r>
+          </a:p>
+        </p:txBody>
+      </p:sp>
+      <p:sp>
+        <p:nvSpPr>
+          <p:cNvPr id="3" name="TextBox 2"/>
+          <p:cNvSpPr txBox="1"/>
+          <p:nvPr/>
+        </p:nvSpPr>
+        <p:spPr>
+          <a:xfrm>
+            <a:off x="540000" y="6552000"/>
+            <a:ext cx="8243999" cy="324000"/>
+          </a:xfrm>
+          <a:prstGeom prst="rect">
+            <a:avLst/>
+          </a:prstGeom>
+          <a:noFill/>
+        </p:spPr>
+        <p:txBody>
+          <a:bodyPr wrap="none">
+            <a:spAutoFit/>
+          </a:bodyPr>
+          <a:lstStyle/>
+          <a:p>
+            <a:r>
+              <a:rPr sz="1100">
+                <a:solidFill>
+                  <a:srgbClr val="404040"/>
+                </a:solidFill>
+                <a:latin typeface="Times New Roman"/>
+              </a:rPr>
+              <a:t>Kiểm thử phần mềm – Nhóm 02 – 23CT113 – Tử Tế Fund</a:t>
+            </a:r>
+          </a:p>
+        </p:txBody>
+      </p:sp>
+      <p:sp>
+        <p:nvSpPr>
+          <p:cNvPr id="4" name="TextBox 3"/>
+          <p:cNvSpPr txBox="1"/>
+          <p:nvPr/>
+        </p:nvSpPr>
+        <p:spPr>
+          <a:xfrm>
+            <a:off x="540000" y="1224000"/>
+            <a:ext cx="8243999" cy="4500000"/>
+          </a:xfrm>
+          <a:prstGeom prst="rect">
+            <a:avLst/>
+          </a:prstGeom>
+          <a:noFill/>
+        </p:spPr>
+        <p:txBody>
+          <a:bodyPr wrap="square">
+            <a:spAutoFit/>
+          </a:bodyPr>
+          <a:lstStyle/>
+          <a:p>
+            <a:pPr>
+              <a:spcAft>
+                <a:spcPts val="900"/>
+              </a:spcAft>
+            </a:pPr>
+            <a:r>
+              <a:rPr sz="1800" b="0">
+                <a:solidFill>
+                  <a:srgbClr val="000000"/>
+                </a:solidFill>
+                <a:latin typeface="Times New Roman"/>
+              </a:rPr>
+              <a:t>• Bộ tài liệu đã đầy đủ: Test Plan, 54 Test Case, ma trận truy xuất, Bug Log 12 lỗi, Test Report</a:t>
+            </a:r>
+          </a:p>
+          <a:p>
+            <a:pPr>
+              <a:spcAft>
+                <a:spcPts val="900"/>
+              </a:spcAft>
+            </a:pPr>
+            <a:r>
+              <a:rPr sz="1800" b="0">
+                <a:solidFill>
+                  <a:srgbClr val="000000"/>
+                </a:solidFill>
+                <a:latin typeface="Times New Roman"/>
+              </a:rPr>
+              <a:t>• Khuyến nghị chưa nghiệm thu build v1.0 cho đến khi các lỗi Critical/High được xử lý</a:t>
+            </a:r>
+          </a:p>
+          <a:p>
+            <a:pPr>
+              <a:spcAft>
+                <a:spcPts val="900"/>
+              </a:spcAft>
+            </a:pPr>
+            <a:r>
+              <a:rPr sz="1800" b="0">
+                <a:solidFill>
+                  <a:srgbClr val="000000"/>
+                </a:solidFill>
+                <a:latin typeface="Times New Roman"/>
+              </a:rPr>
+              <a:t>• Bài học kinh nghiệm:</a:t>
+            </a:r>
+          </a:p>
+          <a:p>
+            <a:pPr lvl="1">
+              <a:spcAft>
+                <a:spcPts val="900"/>
+              </a:spcAft>
+            </a:pPr>
+            <a:r>
+              <a:rPr sz="1500" b="0">
+                <a:solidFill>
+                  <a:srgbClr val="404040"/>
+                </a:solidFill>
+                <a:latin typeface="Times New Roman"/>
+              </a:rPr>
+              <a:t>– Thiết kế TR trước TC giúp bao phủ yêu cầu và dễ truy xuất lỗi</a:t>
+            </a:r>
+          </a:p>
+          <a:p>
+            <a:pPr lvl="1">
+              <a:spcAft>
+                <a:spcPts val="900"/>
+              </a:spcAft>
+            </a:pPr>
+            <a:r>
+              <a:rPr sz="1500" b="0">
+                <a:solidFill>
+                  <a:srgbClr val="404040"/>
+                </a:solidFill>
+                <a:latin typeface="Times New Roman"/>
+              </a:rPr>
+              <a:t>– Ghi kết quả và ảnh chụp màn hình ngay trong lúc chạy test</a:t>
+            </a:r>
+          </a:p>
+          <a:p>
+            <a:pPr lvl="1">
+              <a:spcAft>
+                <a:spcPts val="900"/>
+              </a:spcAft>
+            </a:pPr>
+            <a:r>
+              <a:rPr sz="1500" b="0">
+                <a:solidFill>
+                  <a:srgbClr val="404040"/>
+                </a:solidFill>
+                <a:latin typeface="Times New Roman"/>
+              </a:rPr>
+              <a:t>– Mỗi lỗi phải gắn với Test Case cụ thể để dễ tái hiện</a:t>
+            </a:r>
+          </a:p>
+          <a:p>
+            <a:pPr lvl="1">
+              <a:spcAft>
+                <a:spcPts val="900"/>
+              </a:spcAft>
+            </a:pPr>
+            <a:r>
+              <a:rPr sz="1500" b="0">
+                <a:solidFill>
+                  <a:srgbClr val="404040"/>
+                </a:solidFill>
+                <a:latin typeface="Times New Roman"/>
+              </a:rPr>
+              <a:t>– Chuẩn hoá tên cột tiếng Anh và giá trị danh mục giúp bảng dữ liệu nhất quán</a:t>
             </a:r>
           </a:p>
         </p:txBody>
@@ -3168,47 +3659,420 @@
       <p:grpSpPr/>
       <p:sp>
         <p:nvSpPr>
-          <p:cNvPr id="2" name="Title 1"/>
-          <p:cNvSpPr>
-            <a:spLocks noGrp="1"/>
-          </p:cNvSpPr>
-          <p:nvPr>
-            <p:ph type="title"/>
-          </p:nvPr>
-        </p:nvSpPr>
-        <p:spPr/>
-        <p:txBody>
-          <a:bodyPr/>
-          <a:lstStyle/>
-          <a:p>
-            <a:r>
-              <a:t>Tổng quan dự án</a:t>
-            </a:r>
-          </a:p>
-        </p:txBody>
-      </p:sp>
-      <p:sp>
-        <p:nvSpPr>
-          <p:cNvPr id="3" name="Content Placeholder 2"/>
-          <p:cNvSpPr>
-            <a:spLocks noGrp="1"/>
-          </p:cNvSpPr>
-          <p:nvPr>
-            <p:ph idx="1"/>
-          </p:nvPr>
-        </p:nvSpPr>
-        <p:spPr/>
-        <p:txBody>
-          <a:bodyPr/>
-          <a:lstStyle/>
-          <a:p>
-            <a:pPr/>
-            <a:r>
-              <a:t>Nền tảng crowdfunding hỗ trợ tạo chiến dịch, quyên góp, blog và xác minh KYC.</a:t>
-            </a:r>
-          </a:p>
-        </p:txBody>
-      </p:sp>
+          <p:cNvPr id="2" name="TextBox 1"/>
+          <p:cNvSpPr txBox="1"/>
+          <p:nvPr/>
+        </p:nvSpPr>
+        <p:spPr>
+          <a:xfrm>
+            <a:off x="540000" y="324000"/>
+            <a:ext cx="8243999" cy="684000"/>
+          </a:xfrm>
+          <a:prstGeom prst="rect">
+            <a:avLst/>
+          </a:prstGeom>
+          <a:noFill/>
+        </p:spPr>
+        <p:txBody>
+          <a:bodyPr wrap="square">
+            <a:spAutoFit/>
+          </a:bodyPr>
+          <a:lstStyle/>
+          <a:p>
+            <a:r>
+              <a:rPr sz="3000" b="1">
+                <a:solidFill>
+                  <a:srgbClr val="1F3B63"/>
+                </a:solidFill>
+                <a:latin typeface="Times New Roman"/>
+              </a:rPr>
+              <a:t>Thành viên nhóm và phân công</a:t>
+            </a:r>
+          </a:p>
+        </p:txBody>
+      </p:sp>
+      <p:sp>
+        <p:nvSpPr>
+          <p:cNvPr id="3" name="TextBox 2"/>
+          <p:cNvSpPr txBox="1"/>
+          <p:nvPr/>
+        </p:nvSpPr>
+        <p:spPr>
+          <a:xfrm>
+            <a:off x="540000" y="6552000"/>
+            <a:ext cx="8243999" cy="324000"/>
+          </a:xfrm>
+          <a:prstGeom prst="rect">
+            <a:avLst/>
+          </a:prstGeom>
+          <a:noFill/>
+        </p:spPr>
+        <p:txBody>
+          <a:bodyPr wrap="none">
+            <a:spAutoFit/>
+          </a:bodyPr>
+          <a:lstStyle/>
+          <a:p>
+            <a:r>
+              <a:rPr sz="1100">
+                <a:solidFill>
+                  <a:srgbClr val="404040"/>
+                </a:solidFill>
+                <a:latin typeface="Times New Roman"/>
+              </a:rPr>
+              <a:t>Kiểm thử phần mềm – Nhóm 02 – 23CT113 – Tử Tế Fund</a:t>
+            </a:r>
+          </a:p>
+        </p:txBody>
+      </p:sp>
+      <p:graphicFrame>
+        <p:nvGraphicFramePr>
+          <p:cNvPr id="4" name="Table 3"/>
+          <p:cNvGraphicFramePr>
+            <a:graphicFrameLocks noGrp="1"/>
+          </p:cNvGraphicFramePr>
+          <p:nvPr/>
+        </p:nvGraphicFramePr>
+        <p:xfrm>
+          <a:off x="540000" y="1224000"/>
+          <a:ext cx="8243998" cy="3420000"/>
+        </p:xfrm>
+        <a:graphic>
+          <a:graphicData uri="http://schemas.openxmlformats.org/drawingml/2006/table">
+            <a:tbl>
+              <a:tblPr firstRow="1" bandRow="1">
+                <a:tableStyleId>{5C22544A-7EE6-4342-B048-85BDC9FD1C3A}</a:tableStyleId>
+              </a:tblPr>
+              <a:tblGrid>
+                <a:gridCol w="2747999"/>
+                <a:gridCol w="2355428"/>
+                <a:gridCol w="3140571"/>
+              </a:tblGrid>
+              <a:tr h="570000">
+                <a:tc>
+                  <a:txBody>
+                    <a:bodyPr/>
+                    <a:lstStyle/>
+                    <a:p>
+                      <a:pPr algn="ctr"/>
+                      <a:r>
+                        <a:rPr sz="1500" b="1">
+                          <a:solidFill>
+                            <a:srgbClr val="FFFFFF"/>
+                          </a:solidFill>
+                          <a:latin typeface="Times New Roman"/>
+                        </a:rPr>
+                        <a:t>Họ và tên</a:t>
+                      </a:r>
+                    </a:p>
+                  </a:txBody>
+                  <a:tcPr>
+                    <a:solidFill>
+                      <a:srgbClr val="1F3B63"/>
+                    </a:solidFill>
+                  </a:tcPr>
+                </a:tc>
+                <a:tc>
+                  <a:txBody>
+                    <a:bodyPr/>
+                    <a:lstStyle/>
+                    <a:p>
+                      <a:pPr algn="ctr"/>
+                      <a:r>
+                        <a:rPr sz="1500" b="1">
+                          <a:solidFill>
+                            <a:srgbClr val="FFFFFF"/>
+                          </a:solidFill>
+                          <a:latin typeface="Times New Roman"/>
+                        </a:rPr>
+                        <a:t>Vai trò</a:t>
+                      </a:r>
+                    </a:p>
+                  </a:txBody>
+                  <a:tcPr>
+                    <a:solidFill>
+                      <a:srgbClr val="1F3B63"/>
+                    </a:solidFill>
+                  </a:tcPr>
+                </a:tc>
+                <a:tc>
+                  <a:txBody>
+                    <a:bodyPr/>
+                    <a:lstStyle/>
+                    <a:p>
+                      <a:pPr algn="ctr"/>
+                      <a:r>
+                        <a:rPr sz="1500" b="1">
+                          <a:solidFill>
+                            <a:srgbClr val="FFFFFF"/>
+                          </a:solidFill>
+                          <a:latin typeface="Times New Roman"/>
+                        </a:rPr>
+                        <a:t>Phụ trách</a:t>
+                      </a:r>
+                    </a:p>
+                  </a:txBody>
+                  <a:tcPr>
+                    <a:solidFill>
+                      <a:srgbClr val="1F3B63"/>
+                    </a:solidFill>
+                  </a:tcPr>
+                </a:tc>
+              </a:tr>
+              <a:tr h="570000">
+                <a:tc>
+                  <a:txBody>
+                    <a:bodyPr/>
+                    <a:lstStyle/>
+                    <a:p>
+                      <a:pPr algn="l"/>
+                      <a:r>
+                        <a:rPr sz="1500">
+                          <a:latin typeface="Times New Roman"/>
+                        </a:rPr>
+                        <a:t>Nguyễn Quách Phú Tài</a:t>
+                      </a:r>
+                    </a:p>
+                  </a:txBody>
+                  <a:tcPr anchor="ctr"/>
+                </a:tc>
+                <a:tc>
+                  <a:txBody>
+                    <a:bodyPr/>
+                    <a:lstStyle/>
+                    <a:p>
+                      <a:pPr algn="ctr"/>
+                      <a:r>
+                        <a:rPr sz="1500">
+                          <a:latin typeface="Times New Roman"/>
+                        </a:rPr>
+                        <a:t>Trưởng nhóm</a:t>
+                      </a:r>
+                    </a:p>
+                  </a:txBody>
+                  <a:tcPr anchor="ctr"/>
+                </a:tc>
+                <a:tc>
+                  <a:txBody>
+                    <a:bodyPr/>
+                    <a:lstStyle/>
+                    <a:p>
+                      <a:pPr algn="ctr"/>
+                      <a:r>
+                        <a:rPr sz="1500">
+                          <a:latin typeface="Times New Roman"/>
+                        </a:rPr>
+                        <a:t>Điều phối, module Login</a:t>
+                      </a:r>
+                    </a:p>
+                  </a:txBody>
+                  <a:tcPr anchor="ctr"/>
+                </a:tc>
+              </a:tr>
+              <a:tr h="570000">
+                <a:tc>
+                  <a:txBody>
+                    <a:bodyPr/>
+                    <a:lstStyle/>
+                    <a:p>
+                      <a:pPr algn="l"/>
+                      <a:r>
+                        <a:rPr sz="1500">
+                          <a:latin typeface="Times New Roman"/>
+                        </a:rPr>
+                        <a:t>Bùi Đặng Quốc Khánh</a:t>
+                      </a:r>
+                    </a:p>
+                  </a:txBody>
+                  <a:tcPr anchor="ctr"/>
+                </a:tc>
+                <a:tc>
+                  <a:txBody>
+                    <a:bodyPr/>
+                    <a:lstStyle/>
+                    <a:p>
+                      <a:pPr algn="ctr"/>
+                      <a:r>
+                        <a:rPr sz="1500">
+                          <a:latin typeface="Times New Roman"/>
+                        </a:rPr>
+                        <a:t>Viết Test Case</a:t>
+                      </a:r>
+                    </a:p>
+                  </a:txBody>
+                  <a:tcPr anchor="ctr"/>
+                </a:tc>
+                <a:tc>
+                  <a:txBody>
+                    <a:bodyPr/>
+                    <a:lstStyle/>
+                    <a:p>
+                      <a:pPr algn="ctr"/>
+                      <a:r>
+                        <a:rPr sz="1500">
+                          <a:latin typeface="Times New Roman"/>
+                        </a:rPr>
+                        <a:t>Module Reward</a:t>
+                      </a:r>
+                    </a:p>
+                  </a:txBody>
+                  <a:tcPr anchor="ctr"/>
+                </a:tc>
+              </a:tr>
+              <a:tr h="570000">
+                <a:tc>
+                  <a:txBody>
+                    <a:bodyPr/>
+                    <a:lstStyle/>
+                    <a:p>
+                      <a:pPr algn="l"/>
+                      <a:r>
+                        <a:rPr sz="1500">
+                          <a:latin typeface="Times New Roman"/>
+                        </a:rPr>
+                        <a:t>Nguyễn Trung Tiến</a:t>
+                      </a:r>
+                    </a:p>
+                  </a:txBody>
+                  <a:tcPr anchor="ctr"/>
+                </a:tc>
+                <a:tc>
+                  <a:txBody>
+                    <a:bodyPr/>
+                    <a:lstStyle/>
+                    <a:p>
+                      <a:pPr algn="ctr"/>
+                      <a:r>
+                        <a:rPr sz="1500">
+                          <a:latin typeface="Times New Roman"/>
+                        </a:rPr>
+                        <a:t>Thực thi kiểm thử</a:t>
+                      </a:r>
+                    </a:p>
+                  </a:txBody>
+                  <a:tcPr anchor="ctr"/>
+                </a:tc>
+                <a:tc>
+                  <a:txBody>
+                    <a:bodyPr/>
+                    <a:lstStyle/>
+                    <a:p>
+                      <a:pPr algn="ctr"/>
+                      <a:r>
+                        <a:rPr sz="1500">
+                          <a:latin typeface="Times New Roman"/>
+                        </a:rPr>
+                        <a:t>Module Blog</a:t>
+                      </a:r>
+                    </a:p>
+                  </a:txBody>
+                  <a:tcPr anchor="ctr"/>
+                </a:tc>
+              </a:tr>
+              <a:tr h="570000">
+                <a:tc>
+                  <a:txBody>
+                    <a:bodyPr/>
+                    <a:lstStyle/>
+                    <a:p>
+                      <a:pPr algn="l"/>
+                      <a:r>
+                        <a:rPr sz="1500">
+                          <a:latin typeface="Times New Roman"/>
+                        </a:rPr>
+                        <a:t>Trần Xuân Ân</a:t>
+                      </a:r>
+                    </a:p>
+                  </a:txBody>
+                  <a:tcPr anchor="ctr"/>
+                </a:tc>
+                <a:tc>
+                  <a:txBody>
+                    <a:bodyPr/>
+                    <a:lstStyle/>
+                    <a:p>
+                      <a:pPr algn="ctr"/>
+                      <a:r>
+                        <a:rPr sz="1500">
+                          <a:latin typeface="Times New Roman"/>
+                        </a:rPr>
+                        <a:t>Thực thi kiểm thử</a:t>
+                      </a:r>
+                    </a:p>
+                  </a:txBody>
+                  <a:tcPr anchor="ctr"/>
+                </a:tc>
+                <a:tc>
+                  <a:txBody>
+                    <a:bodyPr/>
+                    <a:lstStyle/>
+                    <a:p>
+                      <a:pPr algn="ctr"/>
+                      <a:r>
+                        <a:rPr sz="1500">
+                          <a:latin typeface="Times New Roman"/>
+                        </a:rPr>
+                        <a:t>Module Campaign</a:t>
+                      </a:r>
+                    </a:p>
+                  </a:txBody>
+                  <a:tcPr anchor="ctr"/>
+                </a:tc>
+              </a:tr>
+              <a:tr h="570000">
+                <a:tc>
+                  <a:txBody>
+                    <a:bodyPr/>
+                    <a:lstStyle/>
+                    <a:p>
+                      <a:pPr algn="l"/>
+                      <a:r>
+                        <a:rPr sz="1500">
+                          <a:latin typeface="Times New Roman"/>
+                        </a:rPr>
+                        <a:t>Nguyễn Khánh Du</a:t>
+                      </a:r>
+                    </a:p>
+                  </a:txBody>
+                  <a:tcPr anchor="ctr"/>
+                </a:tc>
+                <a:tc>
+                  <a:txBody>
+                    <a:bodyPr/>
+                    <a:lstStyle/>
+                    <a:p>
+                      <a:pPr algn="ctr"/>
+                      <a:r>
+                        <a:rPr sz="1500">
+                          <a:latin typeface="Times New Roman"/>
+                        </a:rPr>
+                        <a:t>Lập Test Report</a:t>
+                      </a:r>
+                    </a:p>
+                  </a:txBody>
+                  <a:tcPr anchor="ctr"/>
+                </a:tc>
+                <a:tc>
+                  <a:txBody>
+                    <a:bodyPr/>
+                    <a:lstStyle/>
+                    <a:p>
+                      <a:pPr algn="ctr"/>
+                      <a:r>
+                        <a:rPr sz="1500">
+                          <a:latin typeface="Times New Roman"/>
+                        </a:rPr>
+                        <a:t>Module KYC</a:t>
+                      </a:r>
+                    </a:p>
+                  </a:txBody>
+                  <a:tcPr anchor="ctr"/>
+                </a:tc>
+              </a:tr>
+            </a:tbl>
+          </a:graphicData>
+        </a:graphic>
+      </p:graphicFrame>
     </p:spTree>
   </p:cSld>
   <p:clrMapOvr>
@@ -3229,67 +4093,187 @@
       <p:grpSpPr/>
       <p:sp>
         <p:nvSpPr>
-          <p:cNvPr id="2" name="Title 1"/>
-          <p:cNvSpPr>
-            <a:spLocks noGrp="1"/>
-          </p:cNvSpPr>
-          <p:nvPr>
-            <p:ph type="title"/>
-          </p:nvPr>
-        </p:nvSpPr>
-        <p:spPr/>
-        <p:txBody>
-          <a:bodyPr/>
-          <a:lstStyle/>
-          <a:p>
-            <a:r>
-              <a:t>Phạm vi kiểm thử</a:t>
-            </a:r>
-          </a:p>
-        </p:txBody>
-      </p:sp>
-      <p:sp>
-        <p:nvSpPr>
-          <p:cNvPr id="3" name="Content Placeholder 2"/>
-          <p:cNvSpPr>
-            <a:spLocks noGrp="1"/>
-          </p:cNvSpPr>
-          <p:nvPr>
-            <p:ph idx="1"/>
-          </p:nvPr>
-        </p:nvSpPr>
-        <p:spPr/>
-        <p:txBody>
-          <a:bodyPr/>
-          <a:lstStyle/>
-          <a:p>
-            <a:pPr/>
-            <a:r>
-              <a:t>Login</a:t>
-            </a:r>
-          </a:p>
-          <a:p>
-            <a:pPr/>
-            <a:r>
-              <a:t>Reward</a:t>
-            </a:r>
-          </a:p>
-          <a:p>
-            <a:pPr/>
-            <a:r>
-              <a:t>Blog</a:t>
-            </a:r>
-          </a:p>
-          <a:p>
-            <a:pPr/>
-            <a:r>
-              <a:t>Campaign</a:t>
-            </a:r>
-          </a:p>
-          <a:p>
-            <a:pPr/>
-            <a:r>
-              <a:t>KYC</a:t>
+          <p:cNvPr id="2" name="TextBox 1"/>
+          <p:cNvSpPr txBox="1"/>
+          <p:nvPr/>
+        </p:nvSpPr>
+        <p:spPr>
+          <a:xfrm>
+            <a:off x="540000" y="324000"/>
+            <a:ext cx="8243999" cy="684000"/>
+          </a:xfrm>
+          <a:prstGeom prst="rect">
+            <a:avLst/>
+          </a:prstGeom>
+          <a:noFill/>
+        </p:spPr>
+        <p:txBody>
+          <a:bodyPr wrap="square">
+            <a:spAutoFit/>
+          </a:bodyPr>
+          <a:lstStyle/>
+          <a:p>
+            <a:r>
+              <a:rPr sz="3000" b="1">
+                <a:solidFill>
+                  <a:srgbClr val="1F3B63"/>
+                </a:solidFill>
+                <a:latin typeface="Times New Roman"/>
+              </a:rPr>
+              <a:t>Tổng quan dự án</a:t>
+            </a:r>
+          </a:p>
+        </p:txBody>
+      </p:sp>
+      <p:sp>
+        <p:nvSpPr>
+          <p:cNvPr id="3" name="TextBox 2"/>
+          <p:cNvSpPr txBox="1"/>
+          <p:nvPr/>
+        </p:nvSpPr>
+        <p:spPr>
+          <a:xfrm>
+            <a:off x="540000" y="6552000"/>
+            <a:ext cx="8243999" cy="324000"/>
+          </a:xfrm>
+          <a:prstGeom prst="rect">
+            <a:avLst/>
+          </a:prstGeom>
+          <a:noFill/>
+        </p:spPr>
+        <p:txBody>
+          <a:bodyPr wrap="none">
+            <a:spAutoFit/>
+          </a:bodyPr>
+          <a:lstStyle/>
+          <a:p>
+            <a:r>
+              <a:rPr sz="1100">
+                <a:solidFill>
+                  <a:srgbClr val="404040"/>
+                </a:solidFill>
+                <a:latin typeface="Times New Roman"/>
+              </a:rPr>
+              <a:t>Kiểm thử phần mềm – Nhóm 02 – 23CT113 – Tử Tế Fund</a:t>
+            </a:r>
+          </a:p>
+        </p:txBody>
+      </p:sp>
+      <p:sp>
+        <p:nvSpPr>
+          <p:cNvPr id="4" name="TextBox 3"/>
+          <p:cNvSpPr txBox="1"/>
+          <p:nvPr/>
+        </p:nvSpPr>
+        <p:spPr>
+          <a:xfrm>
+            <a:off x="540000" y="1080000"/>
+            <a:ext cx="8243999" cy="5220000"/>
+          </a:xfrm>
+          <a:prstGeom prst="rect">
+            <a:avLst/>
+          </a:prstGeom>
+          <a:noFill/>
+        </p:spPr>
+        <p:txBody>
+          <a:bodyPr wrap="square">
+            <a:spAutoFit/>
+          </a:bodyPr>
+          <a:lstStyle/>
+          <a:p>
+            <a:pPr>
+              <a:spcAft>
+                <a:spcPts val="900"/>
+              </a:spcAft>
+            </a:pPr>
+            <a:r>
+              <a:rPr sz="1800" b="0">
+                <a:solidFill>
+                  <a:srgbClr val="000000"/>
+                </a:solidFill>
+                <a:latin typeface="Times New Roman"/>
+              </a:rPr>
+              <a:t>• Tử Tế Fund – nền tảng crowdfunding: tạo chiến dịch, đóng góp, nhận reward</a:t>
+            </a:r>
+          </a:p>
+          <a:p>
+            <a:pPr>
+              <a:spcAft>
+                <a:spcPts val="900"/>
+              </a:spcAft>
+            </a:pPr>
+            <a:r>
+              <a:rPr sz="1800" b="0">
+                <a:solidFill>
+                  <a:srgbClr val="000000"/>
+                </a:solidFill>
+                <a:latin typeface="Times New Roman"/>
+              </a:rPr>
+              <a:t>• Các module chính: Login, Reward, Blog, Campaign, KYC</a:t>
+            </a:r>
+          </a:p>
+          <a:p>
+            <a:pPr lvl="1">
+              <a:spcAft>
+                <a:spcPts val="900"/>
+              </a:spcAft>
+            </a:pPr>
+            <a:r>
+              <a:rPr sz="1500" b="0">
+                <a:solidFill>
+                  <a:srgbClr val="404040"/>
+                </a:solidFill>
+                <a:latin typeface="Times New Roman"/>
+              </a:rPr>
+              <a:t>– Công nghệ: Next.js 15 + Prisma/PostgreSQL, triển khai Vercel</a:t>
+            </a:r>
+          </a:p>
+          <a:p>
+            <a:pPr lvl="1">
+              <a:spcAft>
+                <a:spcPts val="900"/>
+              </a:spcAft>
+            </a:pPr>
+            <a:r>
+              <a:rPr sz="1500" b="0">
+                <a:solidFill>
+                  <a:srgbClr val="404040"/>
+                </a:solidFill>
+                <a:latin typeface="Times New Roman"/>
+              </a:rPr>
+              <a:t>– Môi trường test: Windows 10/11, Chrome/Edge mới nhất, demo + local</a:t>
+            </a:r>
+          </a:p>
+          <a:p>
+            <a:pPr>
+              <a:spcAft>
+                <a:spcPts val="900"/>
+              </a:spcAft>
+            </a:pPr>
+            <a:r>
+              <a:rPr sz="1800" b="0">
+                <a:solidFill>
+                  <a:srgbClr val="000000"/>
+                </a:solidFill>
+                <a:latin typeface="Times New Roman"/>
+              </a:rPr>
+              <a:t>• Mục tiêu: kiểm thử thủ công toàn bộ 5 module và đánh giá mức độ hoàn thiện</a:t>
+            </a:r>
+          </a:p>
+          <a:p>
+            <a:pPr>
+              <a:spcAft>
+                <a:spcPts val="900"/>
+              </a:spcAft>
+            </a:pPr>
+            <a:r>
+              <a:rPr sz="1800" b="0">
+                <a:solidFill>
+                  <a:srgbClr val="000000"/>
+                </a:solidFill>
+                <a:latin typeface="Times New Roman"/>
+              </a:rPr>
+              <a:t>• Quy trình: Test Plan → Thiết kế Test Case → Thực thi → Test Report</a:t>
             </a:r>
           </a:p>
         </p:txBody>
@@ -3314,61 +4298,455 @@
       <p:grpSpPr/>
       <p:sp>
         <p:nvSpPr>
-          <p:cNvPr id="2" name="Title 1"/>
-          <p:cNvSpPr>
-            <a:spLocks noGrp="1"/>
-          </p:cNvSpPr>
-          <p:nvPr>
-            <p:ph type="title"/>
-          </p:nvPr>
-        </p:nvSpPr>
-        <p:spPr/>
-        <p:txBody>
-          <a:bodyPr/>
-          <a:lstStyle/>
-          <a:p>
-            <a:r>
-              <a:t>Mức độ kiểm thử</a:t>
-            </a:r>
-          </a:p>
-        </p:txBody>
-      </p:sp>
-      <p:sp>
-        <p:nvSpPr>
-          <p:cNvPr id="3" name="Content Placeholder 2"/>
-          <p:cNvSpPr>
-            <a:spLocks noGrp="1"/>
-          </p:cNvSpPr>
-          <p:nvPr>
-            <p:ph idx="1"/>
-          </p:nvPr>
-        </p:nvSpPr>
-        <p:spPr/>
-        <p:txBody>
-          <a:bodyPr/>
-          <a:lstStyle/>
-          <a:p>
-            <a:pPr/>
-            <a:r>
-              <a:t>TR: 25</a:t>
-            </a:r>
-          </a:p>
-          <a:p>
-            <a:pPr/>
-            <a:r>
-              <a:t>TC: 54</a:t>
-            </a:r>
-          </a:p>
-          <a:p>
-            <a:pPr/>
-            <a:r>
-              <a:t>Coverage: 100%</a:t>
-            </a:r>
-          </a:p>
-          <a:p>
-            <a:pPr/>
-            <a:r>
-              <a:t>Manual testing: 100%</a:t>
+          <p:cNvPr id="2" name="TextBox 1"/>
+          <p:cNvSpPr txBox="1"/>
+          <p:nvPr/>
+        </p:nvSpPr>
+        <p:spPr>
+          <a:xfrm>
+            <a:off x="540000" y="324000"/>
+            <a:ext cx="8243999" cy="684000"/>
+          </a:xfrm>
+          <a:prstGeom prst="rect">
+            <a:avLst/>
+          </a:prstGeom>
+          <a:noFill/>
+        </p:spPr>
+        <p:txBody>
+          <a:bodyPr wrap="square">
+            <a:spAutoFit/>
+          </a:bodyPr>
+          <a:lstStyle/>
+          <a:p>
+            <a:r>
+              <a:rPr sz="3000" b="1">
+                <a:solidFill>
+                  <a:srgbClr val="1F3B63"/>
+                </a:solidFill>
+                <a:latin typeface="Times New Roman"/>
+              </a:rPr>
+              <a:t>Phạm vi kiểm thử</a:t>
+            </a:r>
+          </a:p>
+        </p:txBody>
+      </p:sp>
+      <p:sp>
+        <p:nvSpPr>
+          <p:cNvPr id="3" name="TextBox 2"/>
+          <p:cNvSpPr txBox="1"/>
+          <p:nvPr/>
+        </p:nvSpPr>
+        <p:spPr>
+          <a:xfrm>
+            <a:off x="540000" y="6552000"/>
+            <a:ext cx="8243999" cy="324000"/>
+          </a:xfrm>
+          <a:prstGeom prst="rect">
+            <a:avLst/>
+          </a:prstGeom>
+          <a:noFill/>
+        </p:spPr>
+        <p:txBody>
+          <a:bodyPr wrap="none">
+            <a:spAutoFit/>
+          </a:bodyPr>
+          <a:lstStyle/>
+          <a:p>
+            <a:r>
+              <a:rPr sz="1100">
+                <a:solidFill>
+                  <a:srgbClr val="404040"/>
+                </a:solidFill>
+                <a:latin typeface="Times New Roman"/>
+              </a:rPr>
+              <a:t>Kiểm thử phần mềm – Nhóm 02 – 23CT113 – Tử Tế Fund</a:t>
+            </a:r>
+          </a:p>
+        </p:txBody>
+      </p:sp>
+      <p:graphicFrame>
+        <p:nvGraphicFramePr>
+          <p:cNvPr id="4" name="Table 3"/>
+          <p:cNvGraphicFramePr>
+            <a:graphicFrameLocks noGrp="1"/>
+          </p:cNvGraphicFramePr>
+          <p:nvPr/>
+        </p:nvGraphicFramePr>
+        <p:xfrm>
+          <a:off x="540000" y="1152000"/>
+          <a:ext cx="8243997" cy="3096000"/>
+        </p:xfrm>
+        <a:graphic>
+          <a:graphicData uri="http://schemas.openxmlformats.org/drawingml/2006/table">
+            <a:tbl>
+              <a:tblPr firstRow="1" bandRow="1">
+                <a:tableStyleId>{5C22544A-7EE6-4342-B048-85BDC9FD1C3A}</a:tableStyleId>
+              </a:tblPr>
+              <a:tblGrid>
+                <a:gridCol w="1442699"/>
+                <a:gridCol w="1030499"/>
+                <a:gridCol w="5770799"/>
+              </a:tblGrid>
+              <a:tr h="516000">
+                <a:tc>
+                  <a:txBody>
+                    <a:bodyPr/>
+                    <a:lstStyle/>
+                    <a:p>
+                      <a:pPr algn="ctr"/>
+                      <a:r>
+                        <a:rPr sz="1400" b="1">
+                          <a:solidFill>
+                            <a:srgbClr val="FFFFFF"/>
+                          </a:solidFill>
+                          <a:latin typeface="Times New Roman"/>
+                        </a:rPr>
+                        <a:t>Module</a:t>
+                      </a:r>
+                    </a:p>
+                  </a:txBody>
+                  <a:tcPr>
+                    <a:solidFill>
+                      <a:srgbClr val="1F3B63"/>
+                    </a:solidFill>
+                  </a:tcPr>
+                </a:tc>
+                <a:tc>
+                  <a:txBody>
+                    <a:bodyPr/>
+                    <a:lstStyle/>
+                    <a:p>
+                      <a:pPr algn="ctr"/>
+                      <a:r>
+                        <a:rPr sz="1400" b="1">
+                          <a:solidFill>
+                            <a:srgbClr val="FFFFFF"/>
+                          </a:solidFill>
+                          <a:latin typeface="Times New Roman"/>
+                        </a:rPr>
+                        <a:t>Số TC</a:t>
+                      </a:r>
+                    </a:p>
+                  </a:txBody>
+                  <a:tcPr>
+                    <a:solidFill>
+                      <a:srgbClr val="1F3B63"/>
+                    </a:solidFill>
+                  </a:tcPr>
+                </a:tc>
+                <a:tc>
+                  <a:txBody>
+                    <a:bodyPr/>
+                    <a:lstStyle/>
+                    <a:p>
+                      <a:pPr algn="ctr"/>
+                      <a:r>
+                        <a:rPr sz="1400" b="1">
+                          <a:solidFill>
+                            <a:srgbClr val="FFFFFF"/>
+                          </a:solidFill>
+                          <a:latin typeface="Times New Roman"/>
+                        </a:rPr>
+                        <a:t>Nội dung kiểm thử</a:t>
+                      </a:r>
+                    </a:p>
+                  </a:txBody>
+                  <a:tcPr>
+                    <a:solidFill>
+                      <a:srgbClr val="1F3B63"/>
+                    </a:solidFill>
+                  </a:tcPr>
+                </a:tc>
+              </a:tr>
+              <a:tr h="516000">
+                <a:tc>
+                  <a:txBody>
+                    <a:bodyPr/>
+                    <a:lstStyle/>
+                    <a:p>
+                      <a:pPr algn="l"/>
+                      <a:r>
+                        <a:rPr sz="1300">
+                          <a:latin typeface="Times New Roman"/>
+                        </a:rPr>
+                        <a:t>Login</a:t>
+                      </a:r>
+                    </a:p>
+                  </a:txBody>
+                  <a:tcPr anchor="ctr"/>
+                </a:tc>
+                <a:tc>
+                  <a:txBody>
+                    <a:bodyPr/>
+                    <a:lstStyle/>
+                    <a:p>
+                      <a:pPr algn="ctr"/>
+                      <a:r>
+                        <a:rPr sz="1300">
+                          <a:latin typeface="Times New Roman"/>
+                        </a:rPr>
+                        <a:t>10</a:t>
+                      </a:r>
+                    </a:p>
+                  </a:txBody>
+                  <a:tcPr anchor="ctr"/>
+                </a:tc>
+                <a:tc>
+                  <a:txBody>
+                    <a:bodyPr/>
+                    <a:lstStyle/>
+                    <a:p>
+                      <a:pPr algn="ctr"/>
+                      <a:r>
+                        <a:rPr sz="1300">
+                          <a:latin typeface="Times New Roman"/>
+                        </a:rPr>
+                        <a:t>Đăng nhập, sai mật khẩu, remember me, logout, validation</a:t>
+                      </a:r>
+                    </a:p>
+                  </a:txBody>
+                  <a:tcPr anchor="ctr"/>
+                </a:tc>
+              </a:tr>
+              <a:tr h="516000">
+                <a:tc>
+                  <a:txBody>
+                    <a:bodyPr/>
+                    <a:lstStyle/>
+                    <a:p>
+                      <a:pPr algn="l"/>
+                      <a:r>
+                        <a:rPr sz="1300">
+                          <a:latin typeface="Times New Roman"/>
+                        </a:rPr>
+                        <a:t>Reward</a:t>
+                      </a:r>
+                    </a:p>
+                  </a:txBody>
+                  <a:tcPr anchor="ctr"/>
+                </a:tc>
+                <a:tc>
+                  <a:txBody>
+                    <a:bodyPr/>
+                    <a:lstStyle/>
+                    <a:p>
+                      <a:pPr algn="ctr"/>
+                      <a:r>
+                        <a:rPr sz="1300">
+                          <a:latin typeface="Times New Roman"/>
+                        </a:rPr>
+                        <a:t>10</a:t>
+                      </a:r>
+                    </a:p>
+                  </a:txBody>
+                  <a:tcPr anchor="ctr"/>
+                </a:tc>
+                <a:tc>
+                  <a:txBody>
+                    <a:bodyPr/>
+                    <a:lstStyle/>
+                    <a:p>
+                      <a:pPr algn="ctr"/>
+                      <a:r>
+                        <a:rPr sz="1300">
+                          <a:latin typeface="Times New Roman"/>
+                        </a:rPr>
+                        <a:t>Tạo/sửa/xóa reward, giá âm, số lượng giới hạn</a:t>
+                      </a:r>
+                    </a:p>
+                  </a:txBody>
+                  <a:tcPr anchor="ctr"/>
+                </a:tc>
+              </a:tr>
+              <a:tr h="516000">
+                <a:tc>
+                  <a:txBody>
+                    <a:bodyPr/>
+                    <a:lstStyle/>
+                    <a:p>
+                      <a:pPr algn="l"/>
+                      <a:r>
+                        <a:rPr sz="1300">
+                          <a:latin typeface="Times New Roman"/>
+                        </a:rPr>
+                        <a:t>Blog</a:t>
+                      </a:r>
+                    </a:p>
+                  </a:txBody>
+                  <a:tcPr anchor="ctr"/>
+                </a:tc>
+                <a:tc>
+                  <a:txBody>
+                    <a:bodyPr/>
+                    <a:lstStyle/>
+                    <a:p>
+                      <a:pPr algn="ctr"/>
+                      <a:r>
+                        <a:rPr sz="1300">
+                          <a:latin typeface="Times New Roman"/>
+                        </a:rPr>
+                        <a:t>10</a:t>
+                      </a:r>
+                    </a:p>
+                  </a:txBody>
+                  <a:tcPr anchor="ctr"/>
+                </a:tc>
+                <a:tc>
+                  <a:txBody>
+                    <a:bodyPr/>
+                    <a:lstStyle/>
+                    <a:p>
+                      <a:pPr algn="ctr"/>
+                      <a:r>
+                        <a:rPr sz="1300">
+                          <a:latin typeface="Times New Roman"/>
+                        </a:rPr>
+                        <a:t>Tạo/sửa/xóa bài, upload ảnh, thứ tự hiển thị</a:t>
+                      </a:r>
+                    </a:p>
+                  </a:txBody>
+                  <a:tcPr anchor="ctr"/>
+                </a:tc>
+              </a:tr>
+              <a:tr h="516000">
+                <a:tc>
+                  <a:txBody>
+                    <a:bodyPr/>
+                    <a:lstStyle/>
+                    <a:p>
+                      <a:pPr algn="l"/>
+                      <a:r>
+                        <a:rPr sz="1300">
+                          <a:latin typeface="Times New Roman"/>
+                        </a:rPr>
+                        <a:t>Campaign</a:t>
+                      </a:r>
+                    </a:p>
+                  </a:txBody>
+                  <a:tcPr anchor="ctr"/>
+                </a:tc>
+                <a:tc>
+                  <a:txBody>
+                    <a:bodyPr/>
+                    <a:lstStyle/>
+                    <a:p>
+                      <a:pPr algn="ctr"/>
+                      <a:r>
+                        <a:rPr sz="1300">
+                          <a:latin typeface="Times New Roman"/>
+                        </a:rPr>
+                        <a:t>12</a:t>
+                      </a:r>
+                    </a:p>
+                  </a:txBody>
+                  <a:tcPr anchor="ctr"/>
+                </a:tc>
+                <a:tc>
+                  <a:txBody>
+                    <a:bodyPr/>
+                    <a:lstStyle/>
+                    <a:p>
+                      <a:pPr algn="ctr"/>
+                      <a:r>
+                        <a:rPr sz="1300">
+                          <a:latin typeface="Times New Roman"/>
+                        </a:rPr>
+                        <a:t>Tạo/sửa campaign, tìm kiếm, trạng thái, tiến độ</a:t>
+                      </a:r>
+                    </a:p>
+                  </a:txBody>
+                  <a:tcPr anchor="ctr"/>
+                </a:tc>
+              </a:tr>
+              <a:tr h="516000">
+                <a:tc>
+                  <a:txBody>
+                    <a:bodyPr/>
+                    <a:lstStyle/>
+                    <a:p>
+                      <a:pPr algn="l"/>
+                      <a:r>
+                        <a:rPr sz="1300">
+                          <a:latin typeface="Times New Roman"/>
+                        </a:rPr>
+                        <a:t>KYC</a:t>
+                      </a:r>
+                    </a:p>
+                  </a:txBody>
+                  <a:tcPr anchor="ctr"/>
+                </a:tc>
+                <a:tc>
+                  <a:txBody>
+                    <a:bodyPr/>
+                    <a:lstStyle/>
+                    <a:p>
+                      <a:pPr algn="ctr"/>
+                      <a:r>
+                        <a:rPr sz="1300">
+                          <a:latin typeface="Times New Roman"/>
+                        </a:rPr>
+                        <a:t>12</a:t>
+                      </a:r>
+                    </a:p>
+                  </a:txBody>
+                  <a:tcPr anchor="ctr"/>
+                </a:tc>
+                <a:tc>
+                  <a:txBody>
+                    <a:bodyPr/>
+                    <a:lstStyle/>
+                    <a:p>
+                      <a:pPr algn="ctr"/>
+                      <a:r>
+                        <a:rPr sz="1300">
+                          <a:latin typeface="Times New Roman"/>
+                        </a:rPr>
+                        <a:t>Upload JPG/PDF, admin duyệt/từ chối, thông báo</a:t>
+                      </a:r>
+                    </a:p>
+                  </a:txBody>
+                  <a:tcPr anchor="ctr"/>
+                </a:tc>
+              </a:tr>
+            </a:tbl>
+          </a:graphicData>
+        </a:graphic>
+      </p:graphicFrame>
+      <p:sp>
+        <p:nvSpPr>
+          <p:cNvPr id="5" name="TextBox 4"/>
+          <p:cNvSpPr txBox="1"/>
+          <p:nvPr/>
+        </p:nvSpPr>
+        <p:spPr>
+          <a:xfrm>
+            <a:off x="540000" y="4464000"/>
+            <a:ext cx="8243999" cy="1440000"/>
+          </a:xfrm>
+          <a:prstGeom prst="rect">
+            <a:avLst/>
+          </a:prstGeom>
+          <a:noFill/>
+        </p:spPr>
+        <p:txBody>
+          <a:bodyPr wrap="square">
+            <a:spAutoFit/>
+          </a:bodyPr>
+          <a:lstStyle/>
+          <a:p>
+            <a:pPr>
+              <a:spcAft>
+                <a:spcPts val="900"/>
+              </a:spcAft>
+            </a:pPr>
+            <a:r>
+              <a:rPr sz="1500" b="0">
+                <a:solidFill>
+                  <a:srgbClr val="000000"/>
+                </a:solidFill>
+                <a:latin typeface="Times New Roman"/>
+              </a:rPr>
+              <a:t>• Ngoài phạm vi: đăng ký/quên mật khẩu, thanh toán thật, module quản trị mở rộng, kiểm thử hiệu năng lớn và pentest</a:t>
             </a:r>
           </a:p>
         </p:txBody>
@@ -3393,43 +4771,242 @@
       <p:grpSpPr/>
       <p:sp>
         <p:nvSpPr>
-          <p:cNvPr id="2" name="Title 1"/>
-          <p:cNvSpPr>
-            <a:spLocks noGrp="1"/>
-          </p:cNvSpPr>
-          <p:nvPr>
-            <p:ph type="title"/>
-          </p:nvPr>
-        </p:nvSpPr>
-        <p:spPr/>
-        <p:txBody>
-          <a:bodyPr/>
-          <a:lstStyle/>
-          <a:p>
-            <a:r>
-              <a:t>Kết luận</a:t>
-            </a:r>
-          </a:p>
-        </p:txBody>
-      </p:sp>
-      <p:sp>
-        <p:nvSpPr>
-          <p:cNvPr id="3" name="Content Placeholder 2"/>
-          <p:cNvSpPr>
-            <a:spLocks noGrp="1"/>
-          </p:cNvSpPr>
-          <p:nvPr>
-            <p:ph idx="1"/>
-          </p:nvPr>
-        </p:nvSpPr>
-        <p:spPr/>
-        <p:txBody>
-          <a:bodyPr/>
-          <a:lstStyle/>
-          <a:p>
-            <a:pPr/>
-            <a:r>
-              <a:t>Bộ tài liệu kiểm thử đã đầy đủ, có ma trận truy vết và sẵn sàng nộp.</a:t>
+          <p:cNvPr id="2" name="TextBox 1"/>
+          <p:cNvSpPr txBox="1"/>
+          <p:nvPr/>
+        </p:nvSpPr>
+        <p:spPr>
+          <a:xfrm>
+            <a:off x="540000" y="324000"/>
+            <a:ext cx="8243999" cy="684000"/>
+          </a:xfrm>
+          <a:prstGeom prst="rect">
+            <a:avLst/>
+          </a:prstGeom>
+          <a:noFill/>
+        </p:spPr>
+        <p:txBody>
+          <a:bodyPr wrap="square">
+            <a:spAutoFit/>
+          </a:bodyPr>
+          <a:lstStyle/>
+          <a:p>
+            <a:r>
+              <a:rPr sz="3000" b="1">
+                <a:solidFill>
+                  <a:srgbClr val="1F3B63"/>
+                </a:solidFill>
+                <a:latin typeface="Times New Roman"/>
+              </a:rPr>
+              <a:t>Test Plan – Mục tiêu &amp; tiêu chí</a:t>
+            </a:r>
+          </a:p>
+        </p:txBody>
+      </p:sp>
+      <p:sp>
+        <p:nvSpPr>
+          <p:cNvPr id="3" name="TextBox 2"/>
+          <p:cNvSpPr txBox="1"/>
+          <p:nvPr/>
+        </p:nvSpPr>
+        <p:spPr>
+          <a:xfrm>
+            <a:off x="540000" y="6552000"/>
+            <a:ext cx="8243999" cy="324000"/>
+          </a:xfrm>
+          <a:prstGeom prst="rect">
+            <a:avLst/>
+          </a:prstGeom>
+          <a:noFill/>
+        </p:spPr>
+        <p:txBody>
+          <a:bodyPr wrap="none">
+            <a:spAutoFit/>
+          </a:bodyPr>
+          <a:lstStyle/>
+          <a:p>
+            <a:r>
+              <a:rPr sz="1100">
+                <a:solidFill>
+                  <a:srgbClr val="404040"/>
+                </a:solidFill>
+                <a:latin typeface="Times New Roman"/>
+              </a:rPr>
+              <a:t>Kiểm thử phần mềm – Nhóm 02 – 23CT113 – Tử Tế Fund</a:t>
+            </a:r>
+          </a:p>
+        </p:txBody>
+      </p:sp>
+      <p:sp>
+        <p:nvSpPr>
+          <p:cNvPr id="4" name="TextBox 3"/>
+          <p:cNvSpPr txBox="1"/>
+          <p:nvPr/>
+        </p:nvSpPr>
+        <p:spPr>
+          <a:xfrm>
+            <a:off x="540000" y="1080000"/>
+            <a:ext cx="8243999" cy="1655999"/>
+          </a:xfrm>
+          <a:prstGeom prst="rect">
+            <a:avLst/>
+          </a:prstGeom>
+          <a:noFill/>
+        </p:spPr>
+        <p:txBody>
+          <a:bodyPr wrap="square">
+            <a:spAutoFit/>
+          </a:bodyPr>
+          <a:lstStyle/>
+          <a:p>
+            <a:pPr>
+              <a:spcAft>
+                <a:spcPts val="900"/>
+              </a:spcAft>
+            </a:pPr>
+            <a:r>
+              <a:rPr sz="1800" b="0">
+                <a:solidFill>
+                  <a:srgbClr val="000000"/>
+                </a:solidFill>
+                <a:latin typeface="Times New Roman"/>
+              </a:rPr>
+              <a:t>• Phương pháp: kiểm thử thủ công hộp đen theo luồng người dùng</a:t>
+            </a:r>
+          </a:p>
+          <a:p>
+            <a:pPr>
+              <a:spcAft>
+                <a:spcPts val="900"/>
+              </a:spcAft>
+            </a:pPr>
+            <a:r>
+              <a:rPr sz="1800" b="0">
+                <a:solidFill>
+                  <a:srgbClr val="000000"/>
+                </a:solidFill>
+                <a:latin typeface="Times New Roman"/>
+              </a:rPr>
+              <a:t>• Kỹ thuật: phân vùng tương đương, giá trị biên, kiểm thử lỗi (negative)</a:t>
+            </a:r>
+          </a:p>
+        </p:txBody>
+      </p:sp>
+      <p:sp>
+        <p:nvSpPr>
+          <p:cNvPr id="5" name="TextBox 4"/>
+          <p:cNvSpPr txBox="1"/>
+          <p:nvPr/>
+        </p:nvSpPr>
+        <p:spPr>
+          <a:xfrm>
+            <a:off x="540000" y="2880000"/>
+            <a:ext cx="8243999" cy="3420000"/>
+          </a:xfrm>
+          <a:prstGeom prst="rect">
+            <a:avLst/>
+          </a:prstGeom>
+          <a:noFill/>
+        </p:spPr>
+        <p:txBody>
+          <a:bodyPr wrap="square">
+            <a:spAutoFit/>
+          </a:bodyPr>
+          <a:lstStyle/>
+          <a:p>
+            <a:pPr>
+              <a:spcAft>
+                <a:spcPts val="900"/>
+              </a:spcAft>
+            </a:pPr>
+            <a:r>
+              <a:rPr sz="1600" b="0">
+                <a:solidFill>
+                  <a:srgbClr val="000000"/>
+                </a:solidFill>
+                <a:latin typeface="Times New Roman"/>
+              </a:rPr>
+              <a:t>• Mục tiêu chất lượng &amp; tiêu chí hoàn thành:</a:t>
+            </a:r>
+          </a:p>
+          <a:p>
+            <a:pPr lvl="1">
+              <a:spcAft>
+                <a:spcPts val="900"/>
+              </a:spcAft>
+            </a:pPr>
+            <a:r>
+              <a:rPr sz="1300" b="0">
+                <a:solidFill>
+                  <a:srgbClr val="404040"/>
+                </a:solidFill>
+                <a:latin typeface="Times New Roman"/>
+              </a:rPr>
+              <a:t>– Bao phủ 100% 24 TR bằng ít nhất một test case</a:t>
+            </a:r>
+          </a:p>
+          <a:p>
+            <a:pPr lvl="1">
+              <a:spcAft>
+                <a:spcPts val="900"/>
+              </a:spcAft>
+            </a:pPr>
+            <a:r>
+              <a:rPr sz="1300" b="0">
+                <a:solidFill>
+                  <a:srgbClr val="404040"/>
+                </a:solidFill>
+                <a:latin typeface="Times New Roman"/>
+              </a:rPr>
+              <a:t>– Chạy 100% test case và ghi Actual Result, Test Status</a:t>
+            </a:r>
+          </a:p>
+          <a:p>
+            <a:pPr lvl="1">
+              <a:spcAft>
+                <a:spcPts val="900"/>
+              </a:spcAft>
+            </a:pPr>
+            <a:r>
+              <a:rPr sz="1300" b="0">
+                <a:solidFill>
+                  <a:srgbClr val="404040"/>
+                </a:solidFill>
+                <a:latin typeface="Times New Roman"/>
+              </a:rPr>
+              <a:t>– Tỷ lệ Pass mục tiêu ≥ 90%, không còn lỗi Blocker/Critical ở luồng must-have</a:t>
+            </a:r>
+          </a:p>
+          <a:p>
+            <a:pPr lvl="1">
+              <a:spcAft>
+                <a:spcPts val="900"/>
+              </a:spcAft>
+            </a:pPr>
+            <a:r>
+              <a:rPr sz="1300" b="0">
+                <a:solidFill>
+                  <a:srgbClr val="404040"/>
+                </a:solidFill>
+                <a:latin typeface="Times New Roman"/>
+              </a:rPr>
+              <a:t>– Mọi test case Fail đều phải có bản ghi lỗi tương ứng</a:t>
+            </a:r>
+          </a:p>
+          <a:p>
+            <a:pPr>
+              <a:spcAft>
+                <a:spcPts val="900"/>
+              </a:spcAft>
+            </a:pPr>
+            <a:r>
+              <a:rPr sz="1600" b="0">
+                <a:solidFill>
+                  <a:srgbClr val="000000"/>
+                </a:solidFill>
+                <a:latin typeface="Times New Roman"/>
+              </a:rPr>
+              <a:t>• Tiêu chí tạm dừng: môi trường lỗi quá một buổi / phát hiện lỗi Blocker</a:t>
             </a:r>
           </a:p>
         </p:txBody>
@@ -3454,35 +5031,14 @@
       <p:grpSpPr/>
       <p:sp>
         <p:nvSpPr>
-          <p:cNvPr id="2" name="Title 1"/>
-          <p:cNvSpPr>
-            <a:spLocks noGrp="1"/>
-          </p:cNvSpPr>
-          <p:nvPr>
-            <p:ph type="title"/>
-          </p:nvPr>
-        </p:nvSpPr>
-        <p:spPr/>
-        <p:txBody>
-          <a:bodyPr/>
-          <a:lstStyle/>
-          <a:p>
-            <a:r>
-              <a:t>Thành viên nhóm</a:t>
-            </a:r>
-          </a:p>
-        </p:txBody>
-      </p:sp>
-      <p:sp>
-        <p:nvSpPr>
-          <p:cNvPr id="3" name="TextBox 2"/>
+          <p:cNvPr id="2" name="TextBox 1"/>
           <p:cNvSpPr txBox="1"/>
           <p:nvPr/>
         </p:nvSpPr>
         <p:spPr>
           <a:xfrm>
-            <a:off x="731520" y="1371600"/>
-            <a:ext cx="10058400" cy="3840480"/>
+            <a:off x="540000" y="324000"/>
+            <a:ext cx="8243999" cy="684000"/>
           </a:xfrm>
           <a:prstGeom prst="rect">
             <a:avLst/>
@@ -3495,43 +5051,1520 @@
           </a:bodyPr>
           <a:lstStyle/>
           <a:p>
+            <a:r>
+              <a:rPr sz="3000" b="1">
+                <a:solidFill>
+                  <a:srgbClr val="1F3B63"/>
+                </a:solidFill>
+                <a:latin typeface="Times New Roman"/>
+              </a:rPr>
+              <a:t>Thiết kế Test Case</a:t>
+            </a:r>
+          </a:p>
+        </p:txBody>
+      </p:sp>
+      <p:sp>
+        <p:nvSpPr>
+          <p:cNvPr id="3" name="TextBox 2"/>
+          <p:cNvSpPr txBox="1"/>
+          <p:nvPr/>
+        </p:nvSpPr>
+        <p:spPr>
+          <a:xfrm>
+            <a:off x="540000" y="6552000"/>
+            <a:ext cx="8243999" cy="324000"/>
+          </a:xfrm>
+          <a:prstGeom prst="rect">
+            <a:avLst/>
+          </a:prstGeom>
+          <a:noFill/>
+        </p:spPr>
+        <p:txBody>
+          <a:bodyPr wrap="none">
+            <a:spAutoFit/>
+          </a:bodyPr>
+          <a:lstStyle/>
+          <a:p>
+            <a:r>
+              <a:rPr sz="1100">
+                <a:solidFill>
+                  <a:srgbClr val="404040"/>
+                </a:solidFill>
+                <a:latin typeface="Times New Roman"/>
+              </a:rPr>
+              <a:t>Kiểm thử phần mềm – Nhóm 02 – 23CT113 – Tử Tế Fund</a:t>
+            </a:r>
+          </a:p>
+        </p:txBody>
+      </p:sp>
+      <p:sp>
+        <p:nvSpPr>
+          <p:cNvPr id="4" name="TextBox 3"/>
+          <p:cNvSpPr txBox="1"/>
+          <p:nvPr/>
+        </p:nvSpPr>
+        <p:spPr>
+          <a:xfrm>
+            <a:off x="540000" y="1080000"/>
+            <a:ext cx="8243999" cy="1800000"/>
+          </a:xfrm>
+          <a:prstGeom prst="rect">
+            <a:avLst/>
+          </a:prstGeom>
+          <a:noFill/>
+        </p:spPr>
+        <p:txBody>
+          <a:bodyPr wrap="square">
+            <a:spAutoFit/>
+          </a:bodyPr>
+          <a:lstStyle/>
+          <a:p>
             <a:pPr>
-              <a:defRPr sz="1800"/>
+              <a:spcAft>
+                <a:spcPts val="900"/>
+              </a:spcAft>
             </a:pPr>
             <a:r>
-              <a:t>Nguyễn Quách Phú Tài — Trưởng nhóm; điều phối chung và phụ trách Login.</a:t>
+              <a:rPr sz="1700" b="0">
+                <a:solidFill>
+                  <a:srgbClr val="000000"/>
+                </a:solidFill>
+                <a:latin typeface="Times New Roman"/>
+              </a:rPr>
+              <a:t>• 26 REQ → 24 TR → 54 Test Case (mỗi TR có ít nhất một TC)</a:t>
             </a:r>
           </a:p>
           <a:p>
             <a:pPr>
-              <a:defRPr sz="1800"/>
+              <a:spcAft>
+                <a:spcPts val="900"/>
+              </a:spcAft>
             </a:pPr>
             <a:r>
-              <a:t>Bùi Đặng Quốc Khánh — phụ trách Reward.</a:t>
+              <a:rPr sz="1700" b="0">
+                <a:solidFill>
+                  <a:srgbClr val="000000"/>
+                </a:solidFill>
+                <a:latin typeface="Times New Roman"/>
+              </a:rPr>
+              <a:t>• Trường hợp bình thường / trường hợp lỗi / trường hợp biên</a:t>
             </a:r>
           </a:p>
           <a:p>
             <a:pPr>
-              <a:defRPr sz="1800"/>
+              <a:spcAft>
+                <a:spcPts val="900"/>
+              </a:spcAft>
             </a:pPr>
             <a:r>
-              <a:t>Nguyễn Trung Tiến — phụ trách Blog.</a:t>
-            </a:r>
-          </a:p>
+              <a:rPr sz="1700" b="0">
+                <a:solidFill>
+                  <a:srgbClr val="000000"/>
+                </a:solidFill>
+                <a:latin typeface="Times New Roman"/>
+              </a:rPr>
+              <a:t>• Mỗi TC có: ID, TR ID, mục tiêu, điều kiện tiên quyết, dữ liệu, các bước, kết quả mong đợi, kết quả thực tế, trạng thái</a:t>
+            </a:r>
+          </a:p>
+        </p:txBody>
+      </p:sp>
+      <p:graphicFrame>
+        <p:nvGraphicFramePr>
+          <p:cNvPr id="5" name="Table 4"/>
+          <p:cNvGraphicFramePr>
+            <a:graphicFrameLocks noGrp="1"/>
+          </p:cNvGraphicFramePr>
+          <p:nvPr/>
+        </p:nvGraphicFramePr>
+        <p:xfrm>
+          <a:off x="2160000" y="3096000"/>
+          <a:ext cx="4859998" cy="2880000"/>
+        </p:xfrm>
+        <a:graphic>
+          <a:graphicData uri="http://schemas.openxmlformats.org/drawingml/2006/table">
+            <a:tbl>
+              <a:tblPr firstRow="1" bandRow="1">
+                <a:tableStyleId>{5C22544A-7EE6-4342-B048-85BDC9FD1C3A}</a:tableStyleId>
+              </a:tblPr>
+              <a:tblGrid>
+                <a:gridCol w="1735714"/>
+                <a:gridCol w="1041428"/>
+                <a:gridCol w="1041428"/>
+                <a:gridCol w="1041428"/>
+              </a:tblGrid>
+              <a:tr h="411428">
+                <a:tc>
+                  <a:txBody>
+                    <a:bodyPr/>
+                    <a:lstStyle/>
+                    <a:p>
+                      <a:pPr algn="ctr"/>
+                      <a:r>
+                        <a:rPr sz="1500" b="1">
+                          <a:solidFill>
+                            <a:srgbClr val="FFFFFF"/>
+                          </a:solidFill>
+                          <a:latin typeface="Times New Roman"/>
+                        </a:rPr>
+                        <a:t>Module</a:t>
+                      </a:r>
+                    </a:p>
+                  </a:txBody>
+                  <a:tcPr>
+                    <a:solidFill>
+                      <a:srgbClr val="1F3B63"/>
+                    </a:solidFill>
+                  </a:tcPr>
+                </a:tc>
+                <a:tc>
+                  <a:txBody>
+                    <a:bodyPr/>
+                    <a:lstStyle/>
+                    <a:p>
+                      <a:pPr algn="ctr"/>
+                      <a:r>
+                        <a:rPr sz="1500" b="1">
+                          <a:solidFill>
+                            <a:srgbClr val="FFFFFF"/>
+                          </a:solidFill>
+                          <a:latin typeface="Times New Roman"/>
+                        </a:rPr>
+                        <a:t>Số TC</a:t>
+                      </a:r>
+                    </a:p>
+                  </a:txBody>
+                  <a:tcPr>
+                    <a:solidFill>
+                      <a:srgbClr val="1F3B63"/>
+                    </a:solidFill>
+                  </a:tcPr>
+                </a:tc>
+                <a:tc>
+                  <a:txBody>
+                    <a:bodyPr/>
+                    <a:lstStyle/>
+                    <a:p>
+                      <a:pPr algn="ctr"/>
+                      <a:r>
+                        <a:rPr sz="1500" b="1">
+                          <a:solidFill>
+                            <a:srgbClr val="FFFFFF"/>
+                          </a:solidFill>
+                          <a:latin typeface="Times New Roman"/>
+                        </a:rPr>
+                        <a:t>Pass</a:t>
+                      </a:r>
+                    </a:p>
+                  </a:txBody>
+                  <a:tcPr>
+                    <a:solidFill>
+                      <a:srgbClr val="1F3B63"/>
+                    </a:solidFill>
+                  </a:tcPr>
+                </a:tc>
+                <a:tc>
+                  <a:txBody>
+                    <a:bodyPr/>
+                    <a:lstStyle/>
+                    <a:p>
+                      <a:pPr algn="ctr"/>
+                      <a:r>
+                        <a:rPr sz="1500" b="1">
+                          <a:solidFill>
+                            <a:srgbClr val="FFFFFF"/>
+                          </a:solidFill>
+                          <a:latin typeface="Times New Roman"/>
+                        </a:rPr>
+                        <a:t>Fail</a:t>
+                      </a:r>
+                    </a:p>
+                  </a:txBody>
+                  <a:tcPr>
+                    <a:solidFill>
+                      <a:srgbClr val="1F3B63"/>
+                    </a:solidFill>
+                  </a:tcPr>
+                </a:tc>
+              </a:tr>
+              <a:tr h="411428">
+                <a:tc>
+                  <a:txBody>
+                    <a:bodyPr/>
+                    <a:lstStyle/>
+                    <a:p>
+                      <a:pPr algn="l"/>
+                      <a:r>
+                        <a:rPr sz="1500">
+                          <a:latin typeface="Times New Roman"/>
+                        </a:rPr>
+                        <a:t>Login</a:t>
+                      </a:r>
+                    </a:p>
+                  </a:txBody>
+                  <a:tcPr anchor="ctr"/>
+                </a:tc>
+                <a:tc>
+                  <a:txBody>
+                    <a:bodyPr/>
+                    <a:lstStyle/>
+                    <a:p>
+                      <a:pPr algn="ctr"/>
+                      <a:r>
+                        <a:rPr sz="1500">
+                          <a:latin typeface="Times New Roman"/>
+                        </a:rPr>
+                        <a:t>10</a:t>
+                      </a:r>
+                    </a:p>
+                  </a:txBody>
+                  <a:tcPr anchor="ctr"/>
+                </a:tc>
+                <a:tc>
+                  <a:txBody>
+                    <a:bodyPr/>
+                    <a:lstStyle/>
+                    <a:p>
+                      <a:pPr algn="ctr"/>
+                      <a:r>
+                        <a:rPr sz="1500">
+                          <a:latin typeface="Times New Roman"/>
+                        </a:rPr>
+                        <a:t>10</a:t>
+                      </a:r>
+                    </a:p>
+                  </a:txBody>
+                  <a:tcPr anchor="ctr"/>
+                </a:tc>
+                <a:tc>
+                  <a:txBody>
+                    <a:bodyPr/>
+                    <a:lstStyle/>
+                    <a:p>
+                      <a:pPr algn="ctr"/>
+                      <a:r>
+                        <a:rPr sz="1500">
+                          <a:latin typeface="Times New Roman"/>
+                        </a:rPr>
+                        <a:t>0</a:t>
+                      </a:r>
+                    </a:p>
+                  </a:txBody>
+                  <a:tcPr anchor="ctr"/>
+                </a:tc>
+              </a:tr>
+              <a:tr h="411428">
+                <a:tc>
+                  <a:txBody>
+                    <a:bodyPr/>
+                    <a:lstStyle/>
+                    <a:p>
+                      <a:pPr algn="l"/>
+                      <a:r>
+                        <a:rPr sz="1500">
+                          <a:latin typeface="Times New Roman"/>
+                        </a:rPr>
+                        <a:t>Reward</a:t>
+                      </a:r>
+                    </a:p>
+                  </a:txBody>
+                  <a:tcPr anchor="ctr"/>
+                </a:tc>
+                <a:tc>
+                  <a:txBody>
+                    <a:bodyPr/>
+                    <a:lstStyle/>
+                    <a:p>
+                      <a:pPr algn="ctr"/>
+                      <a:r>
+                        <a:rPr sz="1500">
+                          <a:latin typeface="Times New Roman"/>
+                        </a:rPr>
+                        <a:t>10</a:t>
+                      </a:r>
+                    </a:p>
+                  </a:txBody>
+                  <a:tcPr anchor="ctr"/>
+                </a:tc>
+                <a:tc>
+                  <a:txBody>
+                    <a:bodyPr/>
+                    <a:lstStyle/>
+                    <a:p>
+                      <a:pPr algn="ctr"/>
+                      <a:r>
+                        <a:rPr sz="1500">
+                          <a:latin typeface="Times New Roman"/>
+                        </a:rPr>
+                        <a:t>10</a:t>
+                      </a:r>
+                    </a:p>
+                  </a:txBody>
+                  <a:tcPr anchor="ctr"/>
+                </a:tc>
+                <a:tc>
+                  <a:txBody>
+                    <a:bodyPr/>
+                    <a:lstStyle/>
+                    <a:p>
+                      <a:pPr algn="ctr"/>
+                      <a:r>
+                        <a:rPr sz="1500">
+                          <a:latin typeface="Times New Roman"/>
+                        </a:rPr>
+                        <a:t>0</a:t>
+                      </a:r>
+                    </a:p>
+                  </a:txBody>
+                  <a:tcPr anchor="ctr"/>
+                </a:tc>
+              </a:tr>
+              <a:tr h="411428">
+                <a:tc>
+                  <a:txBody>
+                    <a:bodyPr/>
+                    <a:lstStyle/>
+                    <a:p>
+                      <a:pPr algn="l"/>
+                      <a:r>
+                        <a:rPr sz="1500">
+                          <a:latin typeface="Times New Roman"/>
+                        </a:rPr>
+                        <a:t>Blog</a:t>
+                      </a:r>
+                    </a:p>
+                  </a:txBody>
+                  <a:tcPr anchor="ctr"/>
+                </a:tc>
+                <a:tc>
+                  <a:txBody>
+                    <a:bodyPr/>
+                    <a:lstStyle/>
+                    <a:p>
+                      <a:pPr algn="ctr"/>
+                      <a:r>
+                        <a:rPr sz="1500">
+                          <a:latin typeface="Times New Roman"/>
+                        </a:rPr>
+                        <a:t>10</a:t>
+                      </a:r>
+                    </a:p>
+                  </a:txBody>
+                  <a:tcPr anchor="ctr"/>
+                </a:tc>
+                <a:tc>
+                  <a:txBody>
+                    <a:bodyPr/>
+                    <a:lstStyle/>
+                    <a:p>
+                      <a:pPr algn="ctr"/>
+                      <a:r>
+                        <a:rPr sz="1500">
+                          <a:latin typeface="Times New Roman"/>
+                        </a:rPr>
+                        <a:t>0</a:t>
+                      </a:r>
+                    </a:p>
+                  </a:txBody>
+                  <a:tcPr anchor="ctr"/>
+                </a:tc>
+                <a:tc>
+                  <a:txBody>
+                    <a:bodyPr/>
+                    <a:lstStyle/>
+                    <a:p>
+                      <a:pPr algn="ctr"/>
+                      <a:r>
+                        <a:rPr sz="1500">
+                          <a:latin typeface="Times New Roman"/>
+                        </a:rPr>
+                        <a:t>10</a:t>
+                      </a:r>
+                    </a:p>
+                  </a:txBody>
+                  <a:tcPr anchor="ctr"/>
+                </a:tc>
+              </a:tr>
+              <a:tr h="411428">
+                <a:tc>
+                  <a:txBody>
+                    <a:bodyPr/>
+                    <a:lstStyle/>
+                    <a:p>
+                      <a:pPr algn="l"/>
+                      <a:r>
+                        <a:rPr sz="1500">
+                          <a:latin typeface="Times New Roman"/>
+                        </a:rPr>
+                        <a:t>Campaign</a:t>
+                      </a:r>
+                    </a:p>
+                  </a:txBody>
+                  <a:tcPr anchor="ctr"/>
+                </a:tc>
+                <a:tc>
+                  <a:txBody>
+                    <a:bodyPr/>
+                    <a:lstStyle/>
+                    <a:p>
+                      <a:pPr algn="ctr"/>
+                      <a:r>
+                        <a:rPr sz="1500">
+                          <a:latin typeface="Times New Roman"/>
+                        </a:rPr>
+                        <a:t>12</a:t>
+                      </a:r>
+                    </a:p>
+                  </a:txBody>
+                  <a:tcPr anchor="ctr"/>
+                </a:tc>
+                <a:tc>
+                  <a:txBody>
+                    <a:bodyPr/>
+                    <a:lstStyle/>
+                    <a:p>
+                      <a:pPr algn="ctr"/>
+                      <a:r>
+                        <a:rPr sz="1500">
+                          <a:latin typeface="Times New Roman"/>
+                        </a:rPr>
+                        <a:t>0</a:t>
+                      </a:r>
+                    </a:p>
+                  </a:txBody>
+                  <a:tcPr anchor="ctr"/>
+                </a:tc>
+                <a:tc>
+                  <a:txBody>
+                    <a:bodyPr/>
+                    <a:lstStyle/>
+                    <a:p>
+                      <a:pPr algn="ctr"/>
+                      <a:r>
+                        <a:rPr sz="1500">
+                          <a:latin typeface="Times New Roman"/>
+                        </a:rPr>
+                        <a:t>12</a:t>
+                      </a:r>
+                    </a:p>
+                  </a:txBody>
+                  <a:tcPr anchor="ctr"/>
+                </a:tc>
+              </a:tr>
+              <a:tr h="411428">
+                <a:tc>
+                  <a:txBody>
+                    <a:bodyPr/>
+                    <a:lstStyle/>
+                    <a:p>
+                      <a:pPr algn="l"/>
+                      <a:r>
+                        <a:rPr sz="1500">
+                          <a:latin typeface="Times New Roman"/>
+                        </a:rPr>
+                        <a:t>KYC</a:t>
+                      </a:r>
+                    </a:p>
+                  </a:txBody>
+                  <a:tcPr anchor="ctr"/>
+                </a:tc>
+                <a:tc>
+                  <a:txBody>
+                    <a:bodyPr/>
+                    <a:lstStyle/>
+                    <a:p>
+                      <a:pPr algn="ctr"/>
+                      <a:r>
+                        <a:rPr sz="1500">
+                          <a:latin typeface="Times New Roman"/>
+                        </a:rPr>
+                        <a:t>12</a:t>
+                      </a:r>
+                    </a:p>
+                  </a:txBody>
+                  <a:tcPr anchor="ctr"/>
+                </a:tc>
+                <a:tc>
+                  <a:txBody>
+                    <a:bodyPr/>
+                    <a:lstStyle/>
+                    <a:p>
+                      <a:pPr algn="ctr"/>
+                      <a:r>
+                        <a:rPr sz="1500">
+                          <a:latin typeface="Times New Roman"/>
+                        </a:rPr>
+                        <a:t>0</a:t>
+                      </a:r>
+                    </a:p>
+                  </a:txBody>
+                  <a:tcPr anchor="ctr"/>
+                </a:tc>
+                <a:tc>
+                  <a:txBody>
+                    <a:bodyPr/>
+                    <a:lstStyle/>
+                    <a:p>
+                      <a:pPr algn="ctr"/>
+                      <a:r>
+                        <a:rPr sz="1500">
+                          <a:latin typeface="Times New Roman"/>
+                        </a:rPr>
+                        <a:t>12</a:t>
+                      </a:r>
+                    </a:p>
+                  </a:txBody>
+                  <a:tcPr anchor="ctr"/>
+                </a:tc>
+              </a:tr>
+              <a:tr h="411432">
+                <a:tc>
+                  <a:txBody>
+                    <a:bodyPr/>
+                    <a:lstStyle/>
+                    <a:p>
+                      <a:pPr algn="l"/>
+                      <a:r>
+                        <a:rPr sz="1500">
+                          <a:latin typeface="Times New Roman"/>
+                        </a:rPr>
+                        <a:t>Tổng</a:t>
+                      </a:r>
+                    </a:p>
+                  </a:txBody>
+                  <a:tcPr anchor="ctr"/>
+                </a:tc>
+                <a:tc>
+                  <a:txBody>
+                    <a:bodyPr/>
+                    <a:lstStyle/>
+                    <a:p>
+                      <a:pPr algn="ctr"/>
+                      <a:r>
+                        <a:rPr sz="1500">
+                          <a:latin typeface="Times New Roman"/>
+                        </a:rPr>
+                        <a:t>54</a:t>
+                      </a:r>
+                    </a:p>
+                  </a:txBody>
+                  <a:tcPr anchor="ctr"/>
+                </a:tc>
+                <a:tc>
+                  <a:txBody>
+                    <a:bodyPr/>
+                    <a:lstStyle/>
+                    <a:p>
+                      <a:pPr algn="ctr"/>
+                      <a:r>
+                        <a:rPr sz="1500">
+                          <a:latin typeface="Times New Roman"/>
+                        </a:rPr>
+                        <a:t>20</a:t>
+                      </a:r>
+                    </a:p>
+                  </a:txBody>
+                  <a:tcPr anchor="ctr"/>
+                </a:tc>
+                <a:tc>
+                  <a:txBody>
+                    <a:bodyPr/>
+                    <a:lstStyle/>
+                    <a:p>
+                      <a:pPr algn="ctr"/>
+                      <a:r>
+                        <a:rPr sz="1500">
+                          <a:latin typeface="Times New Roman"/>
+                        </a:rPr>
+                        <a:t>34</a:t>
+                      </a:r>
+                    </a:p>
+                  </a:txBody>
+                  <a:tcPr anchor="ctr"/>
+                </a:tc>
+              </a:tr>
+            </a:tbl>
+          </a:graphicData>
+        </a:graphic>
+      </p:graphicFrame>
+    </p:spTree>
+  </p:cSld>
+  <p:clrMapOvr>
+    <a:masterClrMapping/>
+  </p:clrMapOvr>
+</p:sld>
+</file>
+
+<file path=ppt/slides/slide7.xml><?xml version="1.0" encoding="utf-8"?>
+<p:sld xmlns:a="http://schemas.openxmlformats.org/drawingml/2006/main" xmlns:p="http://schemas.openxmlformats.org/presentationml/2006/main" xmlns:r="http://schemas.openxmlformats.org/officeDocument/2006/relationships">
+  <p:cSld>
+    <p:spTree>
+      <p:nvGrpSpPr>
+        <p:cNvPr id="1" name=""/>
+        <p:cNvGrpSpPr/>
+        <p:nvPr/>
+      </p:nvGrpSpPr>
+      <p:grpSpPr/>
+      <p:sp>
+        <p:nvSpPr>
+          <p:cNvPr id="2" name="TextBox 1"/>
+          <p:cNvSpPr txBox="1"/>
+          <p:nvPr/>
+        </p:nvSpPr>
+        <p:spPr>
+          <a:xfrm>
+            <a:off x="540000" y="324000"/>
+            <a:ext cx="8243999" cy="684000"/>
+          </a:xfrm>
+          <a:prstGeom prst="rect">
+            <a:avLst/>
+          </a:prstGeom>
+          <a:noFill/>
+        </p:spPr>
+        <p:txBody>
+          <a:bodyPr wrap="square">
+            <a:spAutoFit/>
+          </a:bodyPr>
+          <a:lstStyle/>
+          <a:p>
+            <a:r>
+              <a:rPr sz="3000" b="1">
+                <a:solidFill>
+                  <a:srgbClr val="1F3B63"/>
+                </a:solidFill>
+                <a:latin typeface="Times New Roman"/>
+              </a:rPr>
+              <a:t>Kết quả thực thi</a:t>
+            </a:r>
+          </a:p>
+        </p:txBody>
+      </p:sp>
+      <p:sp>
+        <p:nvSpPr>
+          <p:cNvPr id="3" name="TextBox 2"/>
+          <p:cNvSpPr txBox="1"/>
+          <p:nvPr/>
+        </p:nvSpPr>
+        <p:spPr>
+          <a:xfrm>
+            <a:off x="540000" y="6552000"/>
+            <a:ext cx="8243999" cy="324000"/>
+          </a:xfrm>
+          <a:prstGeom prst="rect">
+            <a:avLst/>
+          </a:prstGeom>
+          <a:noFill/>
+        </p:spPr>
+        <p:txBody>
+          <a:bodyPr wrap="none">
+            <a:spAutoFit/>
+          </a:bodyPr>
+          <a:lstStyle/>
+          <a:p>
+            <a:r>
+              <a:rPr sz="1100">
+                <a:solidFill>
+                  <a:srgbClr val="404040"/>
+                </a:solidFill>
+                <a:latin typeface="Times New Roman"/>
+              </a:rPr>
+              <a:t>Kiểm thử phần mềm – Nhóm 02 – 23CT113 – Tử Tế Fund</a:t>
+            </a:r>
+          </a:p>
+        </p:txBody>
+      </p:sp>
+      <p:sp>
+        <p:nvSpPr>
+          <p:cNvPr id="4" name="TextBox 3"/>
+          <p:cNvSpPr txBox="1"/>
+          <p:nvPr/>
+        </p:nvSpPr>
+        <p:spPr>
+          <a:xfrm>
+            <a:off x="540000" y="1224000"/>
+            <a:ext cx="8243999" cy="4320000"/>
+          </a:xfrm>
+          <a:prstGeom prst="rect">
+            <a:avLst/>
+          </a:prstGeom>
+          <a:noFill/>
+        </p:spPr>
+        <p:txBody>
+          <a:bodyPr wrap="square">
+            <a:spAutoFit/>
+          </a:bodyPr>
+          <a:lstStyle/>
           <a:p>
             <a:pPr>
-              <a:defRPr sz="1800"/>
+              <a:spcAft>
+                <a:spcPts val="900"/>
+              </a:spcAft>
             </a:pPr>
             <a:r>
-              <a:t>Trần Xuân Ân — phụ trách Campaign.</a:t>
+              <a:rPr sz="1900" b="0">
+                <a:solidFill>
+                  <a:srgbClr val="000000"/>
+                </a:solidFill>
+                <a:latin typeface="Times New Roman"/>
+              </a:rPr>
+              <a:t>• Đã thực thi 54/54 test case (100%)</a:t>
             </a:r>
           </a:p>
           <a:p>
             <a:pPr>
-              <a:defRPr sz="1800"/>
+              <a:spcAft>
+                <a:spcPts val="900"/>
+              </a:spcAft>
             </a:pPr>
             <a:r>
-              <a:t>Nguyễn Khánh Du — phụ trách KYC thủ công.</a:t>
+              <a:rPr sz="1900" b="0">
+                <a:solidFill>
+                  <a:srgbClr val="000000"/>
+                </a:solidFill>
+                <a:latin typeface="Times New Roman"/>
+              </a:rPr>
+              <a:t>• Pass: 20  (37%)   |   Fail: 34  (63%)</a:t>
+            </a:r>
+          </a:p>
+          <a:p>
+            <a:pPr>
+              <a:spcAft>
+                <a:spcPts val="900"/>
+              </a:spcAft>
+            </a:pPr>
+            <a:r>
+              <a:rPr sz="1900" b="0">
+                <a:solidFill>
+                  <a:srgbClr val="000000"/>
+                </a:solidFill>
+                <a:latin typeface="Times New Roman"/>
+              </a:rPr>
+              <a:t>• Bao phủ: 24/24 TR (100%)  |  25/26 REQ (96%)</a:t>
+            </a:r>
+          </a:p>
+          <a:p>
+            <a:pPr>
+              <a:spcAft>
+                <a:spcPts val="900"/>
+              </a:spcAft>
+            </a:pPr>
+            <a:r>
+              <a:rPr sz="1900" b="0">
+                <a:solidFill>
+                  <a:srgbClr val="000000"/>
+                </a:solidFill>
+                <a:latin typeface="Times New Roman"/>
+              </a:rPr>
+              <a:t>• Login và Reward đạt 100% Pass (20/20)</a:t>
+            </a:r>
+          </a:p>
+          <a:p>
+            <a:pPr>
+              <a:spcAft>
+                <a:spcPts val="900"/>
+              </a:spcAft>
+            </a:pPr>
+            <a:r>
+              <a:rPr sz="1900" b="0">
+                <a:solidFill>
+                  <a:srgbClr val="000000"/>
+                </a:solidFill>
+                <a:latin typeface="Times New Roman"/>
+              </a:rPr>
+              <a:t>• Blog, Campaign và KYC toàn bộ Fail (34/34) do chưa nối API/CSDL trên build v1.0</a:t>
+            </a:r>
+          </a:p>
+          <a:p>
+            <a:pPr>
+              <a:spcAft>
+                <a:spcPts val="900"/>
+              </a:spcAft>
+            </a:pPr>
+            <a:r>
+              <a:rPr sz="1900" b="0">
+                <a:solidFill>
+                  <a:srgbClr val="000000"/>
+                </a:solidFill>
+                <a:latin typeface="Times New Roman"/>
+              </a:rPr>
+              <a:t>• Tỷ lệ Pass hiện tại chưa đạt mục tiêu 90% → chưa đủ điều nghiệm thu</a:t>
+            </a:r>
+          </a:p>
+        </p:txBody>
+      </p:sp>
+    </p:spTree>
+  </p:cSld>
+  <p:clrMapOvr>
+    <a:masterClrMapping/>
+  </p:clrMapOvr>
+</p:sld>
+</file>
+
+<file path=ppt/slides/slide8.xml><?xml version="1.0" encoding="utf-8"?>
+<p:sld xmlns:a="http://schemas.openxmlformats.org/drawingml/2006/main" xmlns:p="http://schemas.openxmlformats.org/presentationml/2006/main" xmlns:r="http://schemas.openxmlformats.org/officeDocument/2006/relationships">
+  <p:cSld>
+    <p:spTree>
+      <p:nvGrpSpPr>
+        <p:cNvPr id="1" name=""/>
+        <p:cNvGrpSpPr/>
+        <p:nvPr/>
+      </p:nvGrpSpPr>
+      <p:grpSpPr/>
+      <p:sp>
+        <p:nvSpPr>
+          <p:cNvPr id="2" name="TextBox 1"/>
+          <p:cNvSpPr txBox="1"/>
+          <p:nvPr/>
+        </p:nvSpPr>
+        <p:spPr>
+          <a:xfrm>
+            <a:off x="540000" y="324000"/>
+            <a:ext cx="8243999" cy="684000"/>
+          </a:xfrm>
+          <a:prstGeom prst="rect">
+            <a:avLst/>
+          </a:prstGeom>
+          <a:noFill/>
+        </p:spPr>
+        <p:txBody>
+          <a:bodyPr wrap="square">
+            <a:spAutoFit/>
+          </a:bodyPr>
+          <a:lstStyle/>
+          <a:p>
+            <a:r>
+              <a:rPr sz="3000" b="1">
+                <a:solidFill>
+                  <a:srgbClr val="1F3B63"/>
+                </a:solidFill>
+                <a:latin typeface="Times New Roman"/>
+              </a:rPr>
+              <a:t>Phân tích lỗi</a:t>
+            </a:r>
+          </a:p>
+        </p:txBody>
+      </p:sp>
+      <p:sp>
+        <p:nvSpPr>
+          <p:cNvPr id="3" name="TextBox 2"/>
+          <p:cNvSpPr txBox="1"/>
+          <p:nvPr/>
+        </p:nvSpPr>
+        <p:spPr>
+          <a:xfrm>
+            <a:off x="540000" y="6552000"/>
+            <a:ext cx="8243999" cy="324000"/>
+          </a:xfrm>
+          <a:prstGeom prst="rect">
+            <a:avLst/>
+          </a:prstGeom>
+          <a:noFill/>
+        </p:spPr>
+        <p:txBody>
+          <a:bodyPr wrap="none">
+            <a:spAutoFit/>
+          </a:bodyPr>
+          <a:lstStyle/>
+          <a:p>
+            <a:r>
+              <a:rPr sz="1100">
+                <a:solidFill>
+                  <a:srgbClr val="404040"/>
+                </a:solidFill>
+                <a:latin typeface="Times New Roman"/>
+              </a:rPr>
+              <a:t>Kiểm thử phần mềm – Nhóm 02 – 23CT113 – Tử Tế Fund</a:t>
+            </a:r>
+          </a:p>
+        </p:txBody>
+      </p:sp>
+      <p:graphicFrame>
+        <p:nvGraphicFramePr>
+          <p:cNvPr id="4" name="Table 3"/>
+          <p:cNvGraphicFramePr>
+            <a:graphicFrameLocks noGrp="1"/>
+          </p:cNvGraphicFramePr>
+          <p:nvPr/>
+        </p:nvGraphicFramePr>
+        <p:xfrm>
+          <a:off x="540000" y="1152000"/>
+          <a:ext cx="8243998" cy="2880000"/>
+        </p:xfrm>
+        <a:graphic>
+          <a:graphicData uri="http://schemas.openxmlformats.org/drawingml/2006/table">
+            <a:tbl>
+              <a:tblPr firstRow="1" bandRow="1">
+                <a:tableStyleId>{5C22544A-7EE6-4342-B048-85BDC9FD1C3A}</a:tableStyleId>
+              </a:tblPr>
+              <a:tblGrid>
+                <a:gridCol w="1533767"/>
+                <a:gridCol w="1342046"/>
+                <a:gridCol w="5368185"/>
+              </a:tblGrid>
+              <a:tr h="480000">
+                <a:tc>
+                  <a:txBody>
+                    <a:bodyPr/>
+                    <a:lstStyle/>
+                    <a:p>
+                      <a:pPr algn="ctr"/>
+                      <a:r>
+                        <a:rPr sz="1500" b="1">
+                          <a:solidFill>
+                            <a:srgbClr val="FFFFFF"/>
+                          </a:solidFill>
+                          <a:latin typeface="Times New Roman"/>
+                        </a:rPr>
+                        <a:t>Mức độ</a:t>
+                      </a:r>
+                    </a:p>
+                  </a:txBody>
+                  <a:tcPr>
+                    <a:solidFill>
+                      <a:srgbClr val="1F3B63"/>
+                    </a:solidFill>
+                  </a:tcPr>
+                </a:tc>
+                <a:tc>
+                  <a:txBody>
+                    <a:bodyPr/>
+                    <a:lstStyle/>
+                    <a:p>
+                      <a:pPr algn="ctr"/>
+                      <a:r>
+                        <a:rPr sz="1500" b="1">
+                          <a:solidFill>
+                            <a:srgbClr val="FFFFFF"/>
+                          </a:solidFill>
+                          <a:latin typeface="Times New Roman"/>
+                        </a:rPr>
+                        <a:t>Số lượng</a:t>
+                      </a:r>
+                    </a:p>
+                  </a:txBody>
+                  <a:tcPr>
+                    <a:solidFill>
+                      <a:srgbClr val="1F3B63"/>
+                    </a:solidFill>
+                  </a:tcPr>
+                </a:tc>
+                <a:tc>
+                  <a:txBody>
+                    <a:bodyPr/>
+                    <a:lstStyle/>
+                    <a:p>
+                      <a:pPr algn="ctr"/>
+                      <a:r>
+                        <a:rPr sz="1500" b="1">
+                          <a:solidFill>
+                            <a:srgbClr val="FFFFFF"/>
+                          </a:solidFill>
+                          <a:latin typeface="Times New Roman"/>
+                        </a:rPr>
+                        <a:t>Ghi chú</a:t>
+                      </a:r>
+                    </a:p>
+                  </a:txBody>
+                  <a:tcPr>
+                    <a:solidFill>
+                      <a:srgbClr val="1F3B63"/>
+                    </a:solidFill>
+                  </a:tcPr>
+                </a:tc>
+              </a:tr>
+              <a:tr h="480000">
+                <a:tc>
+                  <a:txBody>
+                    <a:bodyPr/>
+                    <a:lstStyle/>
+                    <a:p>
+                      <a:pPr algn="l"/>
+                      <a:r>
+                        <a:rPr sz="1400">
+                          <a:latin typeface="Times New Roman"/>
+                        </a:rPr>
+                        <a:t>Critical</a:t>
+                      </a:r>
+                    </a:p>
+                  </a:txBody>
+                  <a:tcPr anchor="ctr"/>
+                </a:tc>
+                <a:tc>
+                  <a:txBody>
+                    <a:bodyPr/>
+                    <a:lstStyle/>
+                    <a:p>
+                      <a:pPr algn="ctr"/>
+                      <a:r>
+                        <a:rPr sz="1400">
+                          <a:latin typeface="Times New Roman"/>
+                        </a:rPr>
+                        <a:t>3</a:t>
+                      </a:r>
+                    </a:p>
+                  </a:txBody>
+                  <a:tcPr anchor="ctr"/>
+                </a:tc>
+                <a:tc>
+                  <a:txBody>
+                    <a:bodyPr/>
+                    <a:lstStyle/>
+                    <a:p>
+                      <a:pPr algn="ctr"/>
+                      <a:r>
+                        <a:rPr sz="1400">
+                          <a:latin typeface="Times New Roman"/>
+                        </a:rPr>
+                        <a:t>Tạo bài, tạo campaign, upload KYC</a:t>
+                      </a:r>
+                    </a:p>
+                  </a:txBody>
+                  <a:tcPr anchor="ctr"/>
+                </a:tc>
+              </a:tr>
+              <a:tr h="480000">
+                <a:tc>
+                  <a:txBody>
+                    <a:bodyPr/>
+                    <a:lstStyle/>
+                    <a:p>
+                      <a:pPr algn="l"/>
+                      <a:r>
+                        <a:rPr sz="1400">
+                          <a:latin typeface="Times New Roman"/>
+                        </a:rPr>
+                        <a:t>High</a:t>
+                      </a:r>
+                    </a:p>
+                  </a:txBody>
+                  <a:tcPr anchor="ctr"/>
+                </a:tc>
+                <a:tc>
+                  <a:txBody>
+                    <a:bodyPr/>
+                    <a:lstStyle/>
+                    <a:p>
+                      <a:pPr algn="ctr"/>
+                      <a:r>
+                        <a:rPr sz="1400">
+                          <a:latin typeface="Times New Roman"/>
+                        </a:rPr>
+                        <a:t>4</a:t>
+                      </a:r>
+                    </a:p>
+                  </a:txBody>
+                  <a:tcPr anchor="ctr"/>
+                </a:tc>
+                <a:tc>
+                  <a:txBody>
+                    <a:bodyPr/>
+                    <a:lstStyle/>
+                    <a:p>
+                      <a:pPr algn="ctr"/>
+                      <a:r>
+                        <a:rPr sz="1400">
+                          <a:latin typeface="Times New Roman"/>
+                        </a:rPr>
+                        <a:t>Sửa/xóa không có hiệu lực, thiếu validation</a:t>
+                      </a:r>
+                    </a:p>
+                  </a:txBody>
+                  <a:tcPr anchor="ctr"/>
+                </a:tc>
+              </a:tr>
+              <a:tr h="480000">
+                <a:tc>
+                  <a:txBody>
+                    <a:bodyPr/>
+                    <a:lstStyle/>
+                    <a:p>
+                      <a:pPr algn="l"/>
+                      <a:r>
+                        <a:rPr sz="1400">
+                          <a:latin typeface="Times New Roman"/>
+                        </a:rPr>
+                        <a:t>Medium</a:t>
+                      </a:r>
+                    </a:p>
+                  </a:txBody>
+                  <a:tcPr anchor="ctr"/>
+                </a:tc>
+                <a:tc>
+                  <a:txBody>
+                    <a:bodyPr/>
+                    <a:lstStyle/>
+                    <a:p>
+                      <a:pPr algn="ctr"/>
+                      <a:r>
+                        <a:rPr sz="1400">
+                          <a:latin typeface="Times New Roman"/>
+                        </a:rPr>
+                        <a:t>3</a:t>
+                      </a:r>
+                    </a:p>
+                  </a:txBody>
+                  <a:tcPr anchor="ctr"/>
+                </a:tc>
+                <a:tc>
+                  <a:txBody>
+                    <a:bodyPr/>
+                    <a:lstStyle/>
+                    <a:p>
+                      <a:pPr algn="ctr"/>
+                      <a:r>
+                        <a:rPr sz="1400">
+                          <a:latin typeface="Times New Roman"/>
+                        </a:rPr>
+                        <a:t>Thiếu kiểm tra dữ liệu, hiển thị sai trạng thái</a:t>
+                      </a:r>
+                    </a:p>
+                  </a:txBody>
+                  <a:tcPr anchor="ctr"/>
+                </a:tc>
+              </a:tr>
+              <a:tr h="480000">
+                <a:tc>
+                  <a:txBody>
+                    <a:bodyPr/>
+                    <a:lstStyle/>
+                    <a:p>
+                      <a:pPr algn="l"/>
+                      <a:r>
+                        <a:rPr sz="1400">
+                          <a:latin typeface="Times New Roman"/>
+                        </a:rPr>
+                        <a:t>Low</a:t>
+                      </a:r>
+                    </a:p>
+                  </a:txBody>
+                  <a:tcPr anchor="ctr"/>
+                </a:tc>
+                <a:tc>
+                  <a:txBody>
+                    <a:bodyPr/>
+                    <a:lstStyle/>
+                    <a:p>
+                      <a:pPr algn="ctr"/>
+                      <a:r>
+                        <a:rPr sz="1400">
+                          <a:latin typeface="Times New Roman"/>
+                        </a:rPr>
+                        <a:t>2</a:t>
+                      </a:r>
+                    </a:p>
+                  </a:txBody>
+                  <a:tcPr anchor="ctr"/>
+                </a:tc>
+                <a:tc>
+                  <a:txBody>
+                    <a:bodyPr/>
+                    <a:lstStyle/>
+                    <a:p>
+                      <a:pPr algn="ctr"/>
+                      <a:r>
+                        <a:rPr sz="1400">
+                          <a:latin typeface="Times New Roman"/>
+                        </a:rPr>
+                        <a:t>Thứ tự hiển thị, thiếu thông báo</a:t>
+                      </a:r>
+                    </a:p>
+                  </a:txBody>
+                  <a:tcPr anchor="ctr"/>
+                </a:tc>
+              </a:tr>
+              <a:tr h="480000">
+                <a:tc>
+                  <a:txBody>
+                    <a:bodyPr/>
+                    <a:lstStyle/>
+                    <a:p>
+                      <a:pPr algn="l"/>
+                      <a:r>
+                        <a:rPr sz="1400">
+                          <a:latin typeface="Times New Roman"/>
+                        </a:rPr>
+                        <a:t>Tổng</a:t>
+                      </a:r>
+                    </a:p>
+                  </a:txBody>
+                  <a:tcPr anchor="ctr"/>
+                </a:tc>
+                <a:tc>
+                  <a:txBody>
+                    <a:bodyPr/>
+                    <a:lstStyle/>
+                    <a:p>
+                      <a:pPr algn="ctr"/>
+                      <a:r>
+                        <a:rPr sz="1400">
+                          <a:latin typeface="Times New Roman"/>
+                        </a:rPr>
+                        <a:t>12</a:t>
+                      </a:r>
+                    </a:p>
+                  </a:txBody>
+                  <a:tcPr anchor="ctr"/>
+                </a:tc>
+                <a:tc>
+                  <a:txBody>
+                    <a:bodyPr/>
+                    <a:lstStyle/>
+                    <a:p>
+                      <a:pPr algn="ctr"/>
+                      <a:r>
+                        <a:rPr sz="1400">
+                          <a:latin typeface="Times New Roman"/>
+                        </a:rPr>
+                        <a:t>12 lỗi – tất cả đang Open, chờ fix build v1.1</a:t>
+                      </a:r>
+                    </a:p>
+                  </a:txBody>
+                  <a:tcPr anchor="ctr"/>
+                </a:tc>
+              </a:tr>
+            </a:tbl>
+          </a:graphicData>
+        </a:graphic>
+      </p:graphicFrame>
+      <p:sp>
+        <p:nvSpPr>
+          <p:cNvPr id="5" name="TextBox 4"/>
+          <p:cNvSpPr txBox="1"/>
+          <p:nvPr/>
+        </p:nvSpPr>
+        <p:spPr>
+          <a:xfrm>
+            <a:off x="540000" y="4320000"/>
+            <a:ext cx="8243999" cy="1620000"/>
+          </a:xfrm>
+          <a:prstGeom prst="rect">
+            <a:avLst/>
+          </a:prstGeom>
+          <a:noFill/>
+        </p:spPr>
+        <p:txBody>
+          <a:bodyPr wrap="square">
+            <a:spAutoFit/>
+          </a:bodyPr>
+          <a:lstStyle/>
+          <a:p>
+            <a:pPr>
+              <a:spcAft>
+                <a:spcPts val="900"/>
+              </a:spcAft>
+            </a:pPr>
+            <a:r>
+              <a:rPr sz="1500" b="0">
+                <a:solidFill>
+                  <a:srgbClr val="000000"/>
+                </a:solidFill>
+                <a:latin typeface="Times New Roman"/>
+              </a:rPr>
+              <a:t>• Mỗi lỗi đều liên kết với Test Case, có ảnh minh họa (Evidence) và bước tái hiện trong sheet Bug Log</a:t>
+            </a:r>
+          </a:p>
+          <a:p>
+            <a:pPr>
+              <a:spcAft>
+                <a:spcPts val="900"/>
+              </a:spcAft>
+            </a:pPr>
+            <a:r>
+              <a:rPr sz="1500" b="0">
+                <a:solidFill>
+                  <a:srgbClr val="000000"/>
+                </a:solidFill>
+                <a:latin typeface="Times New Roman"/>
+              </a:rPr>
+              <a:t>• Lỗi nghiêm trọng nhất: các luồng must-have (đăng nhập là pass, nhưng tạo nội dung/KYC fail)</a:t>
+            </a:r>
+          </a:p>
+        </p:txBody>
+      </p:sp>
+    </p:spTree>
+  </p:cSld>
+  <p:clrMapOvr>
+    <a:masterClrMapping/>
+  </p:clrMapOvr>
+</p:sld>
+</file>
+
+<file path=ppt/slides/slide9.xml><?xml version="1.0" encoding="utf-8"?>
+<p:sld xmlns:a="http://schemas.openxmlformats.org/drawingml/2006/main" xmlns:p="http://schemas.openxmlformats.org/presentationml/2006/main" xmlns:r="http://schemas.openxmlformats.org/officeDocument/2006/relationships">
+  <p:cSld>
+    <p:spTree>
+      <p:nvGrpSpPr>
+        <p:cNvPr id="1" name=""/>
+        <p:cNvGrpSpPr/>
+        <p:nvPr/>
+      </p:nvGrpSpPr>
+      <p:grpSpPr/>
+      <p:sp>
+        <p:nvSpPr>
+          <p:cNvPr id="2" name="TextBox 1"/>
+          <p:cNvSpPr txBox="1"/>
+          <p:nvPr/>
+        </p:nvSpPr>
+        <p:spPr>
+          <a:xfrm>
+            <a:off x="540000" y="324000"/>
+            <a:ext cx="8243999" cy="684000"/>
+          </a:xfrm>
+          <a:prstGeom prst="rect">
+            <a:avLst/>
+          </a:prstGeom>
+          <a:noFill/>
+        </p:spPr>
+        <p:txBody>
+          <a:bodyPr wrap="square">
+            <a:spAutoFit/>
+          </a:bodyPr>
+          <a:lstStyle/>
+          <a:p>
+            <a:r>
+              <a:rPr sz="3000" b="1">
+                <a:solidFill>
+                  <a:srgbClr val="1F3B63"/>
+                </a:solidFill>
+                <a:latin typeface="Times New Roman"/>
+              </a:rPr>
+              <a:t>Ma trận truy xuất REQ ↔ TR ↔ TC</a:t>
+            </a:r>
+          </a:p>
+        </p:txBody>
+      </p:sp>
+      <p:sp>
+        <p:nvSpPr>
+          <p:cNvPr id="3" name="TextBox 2"/>
+          <p:cNvSpPr txBox="1"/>
+          <p:nvPr/>
+        </p:nvSpPr>
+        <p:spPr>
+          <a:xfrm>
+            <a:off x="540000" y="6552000"/>
+            <a:ext cx="8243999" cy="324000"/>
+          </a:xfrm>
+          <a:prstGeom prst="rect">
+            <a:avLst/>
+          </a:prstGeom>
+          <a:noFill/>
+        </p:spPr>
+        <p:txBody>
+          <a:bodyPr wrap="none">
+            <a:spAutoFit/>
+          </a:bodyPr>
+          <a:lstStyle/>
+          <a:p>
+            <a:r>
+              <a:rPr sz="1100">
+                <a:solidFill>
+                  <a:srgbClr val="404040"/>
+                </a:solidFill>
+                <a:latin typeface="Times New Roman"/>
+              </a:rPr>
+              <a:t>Kiểm thử phần mềm – Nhóm 02 – 23CT113 – Tử Tế Fund</a:t>
+            </a:r>
+          </a:p>
+        </p:txBody>
+      </p:sp>
+      <p:sp>
+        <p:nvSpPr>
+          <p:cNvPr id="4" name="TextBox 3"/>
+          <p:cNvSpPr txBox="1"/>
+          <p:nvPr/>
+        </p:nvSpPr>
+        <p:spPr>
+          <a:xfrm>
+            <a:off x="540000" y="1224000"/>
+            <a:ext cx="8243999" cy="4320000"/>
+          </a:xfrm>
+          <a:prstGeom prst="rect">
+            <a:avLst/>
+          </a:prstGeom>
+          <a:noFill/>
+        </p:spPr>
+        <p:txBody>
+          <a:bodyPr wrap="square">
+            <a:spAutoFit/>
+          </a:bodyPr>
+          <a:lstStyle/>
+          <a:p>
+            <a:pPr>
+              <a:spcAft>
+                <a:spcPts val="900"/>
+              </a:spcAft>
+            </a:pPr>
+            <a:r>
+              <a:rPr sz="1900" b="0">
+                <a:solidFill>
+                  <a:srgbClr val="000000"/>
+                </a:solidFill>
+                <a:latin typeface="Times New Roman"/>
+              </a:rPr>
+              <a:t>• 26 REQ (25 chức năng + 1 validation) → 24 TR → 54 TC</a:t>
+            </a:r>
+          </a:p>
+          <a:p>
+            <a:pPr>
+              <a:spcAft>
+                <a:spcPts val="900"/>
+              </a:spcAft>
+            </a:pPr>
+            <a:r>
+              <a:rPr sz="1900" b="0">
+                <a:solidFill>
+                  <a:srgbClr val="000000"/>
+                </a:solidFill>
+                <a:latin typeface="Times New Roman"/>
+              </a:rPr>
+              <a:t>• Mỗi TC đều truy xuất được về TR và REQ gốc</a:t>
+            </a:r>
+          </a:p>
+          <a:p>
+            <a:pPr>
+              <a:spcAft>
+                <a:spcPts val="900"/>
+              </a:spcAft>
+            </a:pPr>
+            <a:r>
+              <a:rPr sz="1900" b="0">
+                <a:solidFill>
+                  <a:srgbClr val="000000"/>
+                </a:solidFill>
+                <a:latin typeface="Times New Roman"/>
+              </a:rPr>
+              <a:t>• 25/26 REQ có test case (96%): REQ-CAMP-006 ngoài phạm vi Phase 1</a:t>
+            </a:r>
+          </a:p>
+          <a:p>
+            <a:pPr>
+              <a:spcAft>
+                <a:spcPts val="900"/>
+              </a:spcAft>
+            </a:pPr>
+            <a:r>
+              <a:rPr sz="1900" b="0">
+                <a:solidFill>
+                  <a:srgbClr val="000000"/>
+                </a:solidFill>
+                <a:latin typeface="Times New Roman"/>
+              </a:rPr>
+              <a:t>• Lưu tại sheet “Traceability Matrix” (64 dòng) trong file Test Case và trong Test Report</a:t>
+            </a:r>
+          </a:p>
+          <a:p>
+            <a:pPr>
+              <a:spcAft>
+                <a:spcPts val="900"/>
+              </a:spcAft>
+            </a:pPr>
+            <a:r>
+              <a:rPr sz="1900" b="0">
+                <a:solidFill>
+                  <a:srgbClr val="000000"/>
+                </a:solidFill>
+                <a:latin typeface="Times New Roman"/>
+              </a:rPr>
+              <a:t>• Giúp xác định ngay TC nào phải chạy lại khi sửa một lỗi</a:t>
             </a:r>
           </a:p>
         </p:txBody>

</xml_diff>

<commit_message>
docs(test): regenerate test documents + verify test accounts
</commit_message>
<xml_diff>
--- a/23CT113_Nhom02_NenTangCrowdfunding(TuTeFund)/Word+ppt Báo Cáo/Ppt Báo cáo Nhóm 2 - 23CT113.pptx
+++ b/23CT113_Nhom02_NenTangCrowdfunding(TuTeFund)/Word+ppt Báo Cáo/Ppt Báo cáo Nhóm 2 - 23CT113.pptx
@@ -3113,46 +3113,59 @@
           <a:bodyPr/>
           <a:lstStyle/>
           <a:p>
-            <a:r>
-              <a:rPr sz="4000" b="1">
-                <a:solidFill>
-                  <a:srgbClr val="1F3B63"/>
-                </a:solidFill>
-                <a:latin typeface="Times New Roman"/>
-              </a:rPr>
-              <a:t>BÁO CÁO CUỐI KỲ</a:t>
-            </a:r>
-          </a:p>
-          <a:p>
-            <a:r>
-              <a:rPr sz="2200">
-                <a:latin typeface="Times New Roman"/>
-              </a:rPr>
-              <a:t>Môn: Kiểm thử phần mềm</a:t>
-            </a:r>
-          </a:p>
-          <a:p>
-            <a:r>
-              <a:rPr sz="2200" b="1">
-                <a:latin typeface="Times New Roman"/>
-              </a:rPr>
-              <a:t>Đề tài: Nền tảng crowdfunding Tử Tế Fund</a:t>
-            </a:r>
-          </a:p>
-          <a:p>
-            <a:r>
-              <a:rPr sz="2000">
-                <a:latin typeface="Times New Roman"/>
-              </a:rPr>
-              <a:t>Nhóm 02 – Lớp 23CT113 – Nguyễn Minh Phúc</a:t>
-            </a:r>
-          </a:p>
-          <a:p>
-            <a:r>
-              <a:rPr sz="1800">
-                <a:latin typeface="Times New Roman"/>
-              </a:rPr>
-              <a:t>27/10/2026</a:t>
+            <a:pPr>
+              <a:defRPr b="1" sz="2200">
+                <a:solidFill>
+                  <a:srgbClr val="1F4E78"/>
+                </a:solidFill>
+              </a:defRPr>
+            </a:pPr>
+            <a:r>
+              <a:t>BÁO CÁO TỔNG KẾT HỌC PHẦN KIỂM THỬ PHẦN MỀM</a:t>
+            </a:r>
+          </a:p>
+          <a:p>
+            <a:pPr>
+              <a:defRPr b="1" sz="1600"/>
+            </a:pPr>
+            <a:r>
+              <a:t>Đề tài: Nền tảng Crowdfunding gây quỹ cộng đồng (Tử Tế Fund)</a:t>
+            </a:r>
+          </a:p>
+          <a:p>
+            <a:pPr>
+              <a:defRPr sz="1300"/>
+            </a:pPr>
+            <a:r>
+              <a:t>Lớp: 23CT113 — Nhóm: Nhóm 02</a:t>
+            </a:r>
+          </a:p>
+          <a:p>
+            <a:pPr>
+              <a:defRPr sz="1100"/>
+            </a:pPr>
+            <a:r>
+              <a:t>Tác giả: Nguyễn Quách Phú Tài (Nhóm trưởng), Trần Xuân Ân, Bùi Đặng Quốc Khánh, Nguyễn Trung Tiến, Nguyễn Khánh Du</a:t>
+            </a:r>
+          </a:p>
+          <a:p>
+            <a:pPr>
+              <a:defRPr i="1" sz="1200">
+                <a:solidFill>
+                  <a:srgbClr val="505050"/>
+                </a:solidFill>
+              </a:defRPr>
+            </a:pPr>
+            <a:r>
+              <a:t>Giảng viên hướng dẫn: ThS. Nguyễn Minh Phúc</a:t>
+            </a:r>
+          </a:p>
+          <a:p>
+            <a:pPr>
+              <a:defRPr sz="1050"/>
+            </a:pPr>
+            <a:r>
+              <a:t>Thời gian: 30/10/2026 | Web Demo: https://test-gamma-azure-65.vercel.app</a:t>
             </a:r>
           </a:p>
         </p:txBody>
@@ -3458,14 +3471,55 @@
           </a:bodyPr>
           <a:lstStyle/>
           <a:p>
-            <a:r>
-              <a:rPr sz="3000" b="1">
-                <a:solidFill>
-                  <a:srgbClr val="1F3B63"/>
-                </a:solidFill>
-                <a:latin typeface="Times New Roman"/>
-              </a:rPr>
-              <a:t>Kết luận và bài học kinh nghiệm</a:t>
+            <a:pPr>
+              <a:defRPr b="1" sz="1400">
+                <a:solidFill>
+                  <a:srgbClr val="1F4E78"/>
+                </a:solidFill>
+              </a:defRPr>
+            </a:pPr>
+            <a:r>
+              <a:t>Kết luận và Đánh giá Nghiệm thu Đồ án:</a:t>
+            </a:r>
+          </a:p>
+          <a:p>
+            <a:pPr>
+              <a:defRPr sz="1200"/>
+            </a:pPr>
+            <a:r>
+              <a:t>• Hoàn thành trọn vẹn bộ tài liệu: Test Plan, Test Report, 105 TCs, 3 Biên bản họp, Timeline</a:t>
+            </a:r>
+          </a:p>
+          <a:p>
+            <a:pPr>
+              <a:defRPr sz="1200"/>
+            </a:pPr>
+            <a:r>
+              <a:t>• Kết quả thực tế đạt 95.7% PASS trên các ca kiểm thử đã thực thi (vượt chỉ tiêu ≥ 85.0%)</a:t>
+            </a:r>
+          </a:p>
+          <a:p>
+            <a:pPr>
+              <a:defRPr sz="1200"/>
+            </a:pPr>
+            <a:r>
+              <a:t>• 4 Bug Reports được phân loại rõ ràng giúp đội phát triển dễ dàng sửa lỗi trong sprint tới</a:t>
+            </a:r>
+          </a:p>
+          <a:p>
+            <a:pPr>
+              <a:defRPr sz="1200"/>
+            </a:pPr>
+            <a:r>
+              <a:t>• Minh bạch tuyệt đối: nói không với kết quả ảo, để trống 12 TC chưa chạy kèm lý do kỹ thuật</a:t>
+            </a:r>
+          </a:p>
+          <a:p>
+            <a:pPr>
+              <a:defRPr sz="1200"/>
+            </a:pPr>
+            <a:r>
+              <a:t>• Cả 5 thành viên Nhóm 02 đều tham gia tích cực và hoàn thành 100% nhiệm vụ được giao</a:t>
             </a:r>
           </a:p>
         </p:txBody>
@@ -4863,31 +4917,58 @@
               <a:spcAft>
                 <a:spcPts val="900"/>
               </a:spcAft>
-            </a:pPr>
-            <a:r>
-              <a:rPr sz="1800" b="0">
-                <a:solidFill>
-                  <a:srgbClr val="000000"/>
-                </a:solidFill>
-                <a:latin typeface="Times New Roman"/>
-              </a:rPr>
-              <a:t>• Phương pháp: kiểm thử thủ công hộp đen theo luồng người dùng</a:t>
-            </a:r>
-          </a:p>
-          <a:p>
-            <a:pPr>
-              <a:spcAft>
-                <a:spcPts val="900"/>
-              </a:spcAft>
-            </a:pPr>
-            <a:r>
-              <a:rPr sz="1800" b="0">
-                <a:solidFill>
-                  <a:srgbClr val="000000"/>
-                </a:solidFill>
-                <a:latin typeface="Times New Roman"/>
-              </a:rPr>
-              <a:t>• Kỹ thuật: phân vùng tương đương, giá trị biên, kiểm thử lỗi (negative)</a:t>
+              <a:defRPr b="1" sz="1400"/>
+            </a:pPr>
+            <a:r>
+              <a:t>Mục tiêu kiểm thử &amp; Ba làn thực thi (Test Execution Lines):</a:t>
+            </a:r>
+          </a:p>
+          <a:p>
+            <a:pPr>
+              <a:defRPr sz="1200"/>
+            </a:pPr>
+            <a:r>
+              <a:t>• Phương pháp: Hộp đen kết hợp kiểm tra mã nguồn (Functional, Boundary, Negative, LooknFeel)</a:t>
+            </a:r>
+          </a:p>
+          <a:p>
+            <a:pPr>
+              <a:defRPr sz="1200"/>
+            </a:pPr>
+            <a:r>
+              <a:t>• Làn 1 (HTTP API): Kiểm tra mã trạng thái HTTP, xác thực JWT, phân quyền RBAC và endpoint 410</a:t>
+            </a:r>
+          </a:p>
+          <a:p>
+            <a:pPr>
+              <a:defRPr sz="1200"/>
+            </a:pPr>
+            <a:r>
+              <a:t>• Làn 2 (Browser UI): Dùng Playwright Chromium chụp ảnh bằng chứng lưu thư mục evidence/</a:t>
+            </a:r>
+          </a:p>
+          <a:p>
+            <a:pPr>
+              <a:defRPr sz="1200"/>
+            </a:pPr>
+            <a:r>
+              <a:t>• Làn 3 (DB &amp; Jest): Chạy 44 suites (303 unit tests passed), đối soát Prisma CSDL Neon</a:t>
+            </a:r>
+          </a:p>
+          <a:p>
+            <a:pPr>
+              <a:defRPr sz="1200"/>
+            </a:pPr>
+            <a:r>
+              <a:t>• Mục tiêu chất lượng: Đạt tỷ lệ PASS ≥ 85.0% trên số TC đã chạy thực tế</a:t>
+            </a:r>
+          </a:p>
+          <a:p>
+            <a:pPr>
+              <a:defRPr sz="1200"/>
+            </a:pPr>
+            <a:r>
+              <a:t>• Dữ liệu kiểm thử: 4 tài khoản seed chính thức đã xác minh đăng nhập thành công 100%</a:t>
             </a:r>
           </a:p>
         </p:txBody>
@@ -5123,47 +5204,50 @@
               <a:spcAft>
                 <a:spcPts val="900"/>
               </a:spcAft>
-            </a:pPr>
-            <a:r>
-              <a:rPr sz="1700" b="0">
-                <a:solidFill>
-                  <a:srgbClr val="000000"/>
-                </a:solidFill>
-                <a:latin typeface="Times New Roman"/>
-              </a:rPr>
-              <a:t>• 26 REQ → 24 TR → 54 Test Case (mỗi TR có ít nhất một TC)</a:t>
-            </a:r>
-          </a:p>
-          <a:p>
-            <a:pPr>
-              <a:spcAft>
-                <a:spcPts val="900"/>
-              </a:spcAft>
-            </a:pPr>
-            <a:r>
-              <a:rPr sz="1700" b="0">
-                <a:solidFill>
-                  <a:srgbClr val="000000"/>
-                </a:solidFill>
-                <a:latin typeface="Times New Roman"/>
-              </a:rPr>
-              <a:t>• Trường hợp bình thường / trường hợp lỗi / trường hợp biên</a:t>
-            </a:r>
-          </a:p>
-          <a:p>
-            <a:pPr>
-              <a:spcAft>
-                <a:spcPts val="900"/>
-              </a:spcAft>
-            </a:pPr>
-            <a:r>
-              <a:rPr sz="1700" b="0">
-                <a:solidFill>
-                  <a:srgbClr val="000000"/>
-                </a:solidFill>
-                <a:latin typeface="Times New Roman"/>
-              </a:rPr>
-              <a:t>• Mỗi TC có: ID, TR ID, mục tiêu, điều kiện tiên quyết, dữ liệu, các bước, kết quả mong đợi, kết quả thực tế, trạng thái</a:t>
+              <a:defRPr b="1" sz="1400"/>
+            </a:pPr>
+            <a:r>
+              <a:t>Thiết kế Yêu cầu (TR) và Kịch bản kiểm thử (TC):</a:t>
+            </a:r>
+          </a:p>
+          <a:p>
+            <a:pPr>
+              <a:defRPr sz="1200"/>
+            </a:pPr>
+            <a:r>
+              <a:t>• Tổng số Yêu cầu kiểm thử: 42 TRs (suy ra trực tiếp từ route, API và schema)</a:t>
+            </a:r>
+          </a:p>
+          <a:p>
+            <a:pPr>
+              <a:defRPr sz="1200"/>
+            </a:pPr>
+            <a:r>
+              <a:t>• Tổng số Kịch bản kiểm thử: 105 TCs (mỗi TR có từ 2-3 TC cụ thể, đo lường được)</a:t>
+            </a:r>
+          </a:p>
+          <a:p>
+            <a:pPr>
+              <a:defRPr sz="1200"/>
+            </a:pPr>
+            <a:r>
+              <a:t>• Phân bổ độ ưu tiên: 56 High (P0 luồng chính), 36 Medium (nghiệp vụ biên), 13 Low (UI/UX)</a:t>
+            </a:r>
+          </a:p>
+          <a:p>
+            <a:pPr>
+              <a:defRPr sz="1200"/>
+            </a:pPr>
+            <a:r>
+              <a:t>• Không sử dụng user story chung chung, không sinh test case bằng vòng lặp rác</a:t>
+            </a:r>
+          </a:p>
+          <a:p>
+            <a:pPr>
+              <a:defRPr sz="1200"/>
+            </a:pPr>
+            <a:r>
+              <a:t>• Dữ liệu kiểm thử, tiền điều kiện và kết quả mong đợi được lấy từ mã nguồn thật</a:t>
             </a:r>
           </a:p>
         </p:txBody>
@@ -5198,15 +5282,8 @@
                     <a:bodyPr/>
                     <a:lstStyle/>
                     <a:p>
-                      <a:pPr algn="ctr"/>
-                      <a:r>
-                        <a:rPr sz="1500" b="1">
-                          <a:solidFill>
-                            <a:srgbClr val="FFFFFF"/>
-                          </a:solidFill>
-                          <a:latin typeface="Times New Roman"/>
-                        </a:rPr>
-                        <a:t>Module</a:t>
+                      <a:r>
+                        <a:t>Phân hệ</a:t>
                       </a:r>
                     </a:p>
                   </a:txBody>
@@ -5221,15 +5298,8 @@
                     <a:bodyPr/>
                     <a:lstStyle/>
                     <a:p>
-                      <a:pPr algn="ctr"/>
-                      <a:r>
-                        <a:rPr sz="1500" b="1">
-                          <a:solidFill>
-                            <a:srgbClr val="FFFFFF"/>
-                          </a:solidFill>
-                          <a:latin typeface="Times New Roman"/>
-                        </a:rPr>
-                        <a:t>Số TC</a:t>
+                      <a:r>
+                        <a:t>Số TR</a:t>
                       </a:r>
                     </a:p>
                   </a:txBody>
@@ -5244,15 +5314,8 @@
                     <a:bodyPr/>
                     <a:lstStyle/>
                     <a:p>
-                      <a:pPr algn="ctr"/>
-                      <a:r>
-                        <a:rPr sz="1500" b="1">
-                          <a:solidFill>
-                            <a:srgbClr val="FFFFFF"/>
-                          </a:solidFill>
-                          <a:latin typeface="Times New Roman"/>
-                        </a:rPr>
-                        <a:t>Pass</a:t>
+                      <a:r>
+                        <a:t>Số TC</a:t>
                       </a:r>
                     </a:p>
                   </a:txBody>
@@ -5267,15 +5330,8 @@
                     <a:bodyPr/>
                     <a:lstStyle/>
                     <a:p>
-                      <a:pPr algn="ctr"/>
-                      <a:r>
-                        <a:rPr sz="1500" b="1">
-                          <a:solidFill>
-                            <a:srgbClr val="FFFFFF"/>
-                          </a:solidFill>
-                          <a:latin typeface="Times New Roman"/>
-                        </a:rPr>
-                        <a:t>Fail</a:t>
+                      <a:r>
+                        <a:t>Đã chạy</a:t>
                       </a:r>
                     </a:p>
                   </a:txBody>
@@ -5292,12 +5348,8 @@
                     <a:bodyPr/>
                     <a:lstStyle/>
                     <a:p>
-                      <a:pPr algn="l"/>
-                      <a:r>
-                        <a:rPr sz="1500">
-                          <a:latin typeface="Times New Roman"/>
-                        </a:rPr>
-                        <a:t>Login</a:t>
+                      <a:r>
+                        <a:t>AUTH</a:t>
                       </a:r>
                     </a:p>
                   </a:txBody>
@@ -5308,44 +5360,32 @@
                     <a:bodyPr/>
                     <a:lstStyle/>
                     <a:p>
-                      <a:pPr algn="ctr"/>
-                      <a:r>
-                        <a:rPr sz="1500">
-                          <a:latin typeface="Times New Roman"/>
-                        </a:rPr>
+                      <a:r>
+                        <a:t>5</a:t>
+                      </a:r>
+                    </a:p>
+                  </a:txBody>
+                  <a:tcPr anchor="ctr"/>
+                </a:tc>
+                <a:tc>
+                  <a:txBody>
+                    <a:bodyPr/>
+                    <a:lstStyle/>
+                    <a:p>
+                      <a:r>
+                        <a:t>12</a:t>
+                      </a:r>
+                    </a:p>
+                  </a:txBody>
+                  <a:tcPr anchor="ctr"/>
+                </a:tc>
+                <a:tc>
+                  <a:txBody>
+                    <a:bodyPr/>
+                    <a:lstStyle/>
+                    <a:p>
+                      <a:r>
                         <a:t>10</a:t>
-                      </a:r>
-                    </a:p>
-                  </a:txBody>
-                  <a:tcPr anchor="ctr"/>
-                </a:tc>
-                <a:tc>
-                  <a:txBody>
-                    <a:bodyPr/>
-                    <a:lstStyle/>
-                    <a:p>
-                      <a:pPr algn="ctr"/>
-                      <a:r>
-                        <a:rPr sz="1500">
-                          <a:latin typeface="Times New Roman"/>
-                        </a:rPr>
-                        <a:t>10</a:t>
-                      </a:r>
-                    </a:p>
-                  </a:txBody>
-                  <a:tcPr anchor="ctr"/>
-                </a:tc>
-                <a:tc>
-                  <a:txBody>
-                    <a:bodyPr/>
-                    <a:lstStyle/>
-                    <a:p>
-                      <a:pPr algn="ctr"/>
-                      <a:r>
-                        <a:rPr sz="1500">
-                          <a:latin typeface="Times New Roman"/>
-                        </a:rPr>
-                        <a:t>0</a:t>
                       </a:r>
                     </a:p>
                   </a:txBody>
@@ -5358,12 +5398,8 @@
                     <a:bodyPr/>
                     <a:lstStyle/>
                     <a:p>
-                      <a:pPr algn="l"/>
-                      <a:r>
-                        <a:rPr sz="1500">
-                          <a:latin typeface="Times New Roman"/>
-                        </a:rPr>
-                        <a:t>Reward</a:t>
+                      <a:r>
+                        <a:t>KYC</a:t>
                       </a:r>
                     </a:p>
                   </a:txBody>
@@ -5374,44 +5410,32 @@
                     <a:bodyPr/>
                     <a:lstStyle/>
                     <a:p>
-                      <a:pPr algn="ctr"/>
-                      <a:r>
-                        <a:rPr sz="1500">
-                          <a:latin typeface="Times New Roman"/>
-                        </a:rPr>
+                      <a:r>
+                        <a:t>4</a:t>
+                      </a:r>
+                    </a:p>
+                  </a:txBody>
+                  <a:tcPr anchor="ctr"/>
+                </a:tc>
+                <a:tc>
+                  <a:txBody>
+                    <a:bodyPr/>
+                    <a:lstStyle/>
+                    <a:p>
+                      <a:r>
+                        <a:t>11</a:t>
+                      </a:r>
+                    </a:p>
+                  </a:txBody>
+                  <a:tcPr anchor="ctr"/>
+                </a:tc>
+                <a:tc>
+                  <a:txBody>
+                    <a:bodyPr/>
+                    <a:lstStyle/>
+                    <a:p>
+                      <a:r>
                         <a:t>10</a:t>
-                      </a:r>
-                    </a:p>
-                  </a:txBody>
-                  <a:tcPr anchor="ctr"/>
-                </a:tc>
-                <a:tc>
-                  <a:txBody>
-                    <a:bodyPr/>
-                    <a:lstStyle/>
-                    <a:p>
-                      <a:pPr algn="ctr"/>
-                      <a:r>
-                        <a:rPr sz="1500">
-                          <a:latin typeface="Times New Roman"/>
-                        </a:rPr>
-                        <a:t>10</a:t>
-                      </a:r>
-                    </a:p>
-                  </a:txBody>
-                  <a:tcPr anchor="ctr"/>
-                </a:tc>
-                <a:tc>
-                  <a:txBody>
-                    <a:bodyPr/>
-                    <a:lstStyle/>
-                    <a:p>
-                      <a:pPr algn="ctr"/>
-                      <a:r>
-                        <a:rPr sz="1500">
-                          <a:latin typeface="Times New Roman"/>
-                        </a:rPr>
-                        <a:t>0</a:t>
                       </a:r>
                     </a:p>
                   </a:txBody>
@@ -5424,12 +5448,8 @@
                     <a:bodyPr/>
                     <a:lstStyle/>
                     <a:p>
-                      <a:pPr algn="l"/>
-                      <a:r>
-                        <a:rPr sz="1500">
-                          <a:latin typeface="Times New Roman"/>
-                        </a:rPr>
-                        <a:t>Blog</a:t>
+                      <a:r>
+                        <a:t>CAMP</a:t>
                       </a:r>
                     </a:p>
                   </a:txBody>
@@ -5440,12 +5460,8 @@
                     <a:bodyPr/>
                     <a:lstStyle/>
                     <a:p>
-                      <a:pPr algn="ctr"/>
-                      <a:r>
-                        <a:rPr sz="1500">
-                          <a:latin typeface="Times New Roman"/>
-                        </a:rPr>
-                        <a:t>10</a:t>
+                      <a:r>
+                        <a:t>5</a:t>
                       </a:r>
                     </a:p>
                   </a:txBody>
@@ -5456,12 +5472,8 @@
                     <a:bodyPr/>
                     <a:lstStyle/>
                     <a:p>
-                      <a:pPr algn="ctr"/>
-                      <a:r>
-                        <a:rPr sz="1500">
-                          <a:latin typeface="Times New Roman"/>
-                        </a:rPr>
-                        <a:t>0</a:t>
+                      <a:r>
+                        <a:t>15</a:t>
                       </a:r>
                     </a:p>
                   </a:txBody>
@@ -5472,12 +5484,8 @@
                     <a:bodyPr/>
                     <a:lstStyle/>
                     <a:p>
-                      <a:pPr algn="ctr"/>
-                      <a:r>
-                        <a:rPr sz="1500">
-                          <a:latin typeface="Times New Roman"/>
-                        </a:rPr>
-                        <a:t>10</a:t>
+                      <a:r>
+                        <a:t>14</a:t>
                       </a:r>
                     </a:p>
                   </a:txBody>
@@ -5490,12 +5498,8 @@
                     <a:bodyPr/>
                     <a:lstStyle/>
                     <a:p>
-                      <a:pPr algn="l"/>
-                      <a:r>
-                        <a:rPr sz="1500">
-                          <a:latin typeface="Times New Roman"/>
-                        </a:rPr>
-                        <a:t>Campaign</a:t>
+                      <a:r>
+                        <a:t>REWARD</a:t>
                       </a:r>
                     </a:p>
                   </a:txBody>
@@ -5506,12 +5510,8 @@
                     <a:bodyPr/>
                     <a:lstStyle/>
                     <a:p>
-                      <a:pPr algn="ctr"/>
-                      <a:r>
-                        <a:rPr sz="1500">
-                          <a:latin typeface="Times New Roman"/>
-                        </a:rPr>
-                        <a:t>12</a:t>
+                      <a:r>
+                        <a:t>4</a:t>
                       </a:r>
                     </a:p>
                   </a:txBody>
@@ -5522,12 +5522,8 @@
                     <a:bodyPr/>
                     <a:lstStyle/>
                     <a:p>
-                      <a:pPr algn="ctr"/>
-                      <a:r>
-                        <a:rPr sz="1500">
-                          <a:latin typeface="Times New Roman"/>
-                        </a:rPr>
-                        <a:t>0</a:t>
+                      <a:r>
+                        <a:t>9</a:t>
                       </a:r>
                     </a:p>
                   </a:txBody>
@@ -5538,12 +5534,8 @@
                     <a:bodyPr/>
                     <a:lstStyle/>
                     <a:p>
-                      <a:pPr algn="ctr"/>
-                      <a:r>
-                        <a:rPr sz="1500">
-                          <a:latin typeface="Times New Roman"/>
-                        </a:rPr>
-                        <a:t>12</a:t>
+                      <a:r>
+                        <a:t>8</a:t>
                       </a:r>
                     </a:p>
                   </a:txBody>
@@ -5556,12 +5548,8 @@
                     <a:bodyPr/>
                     <a:lstStyle/>
                     <a:p>
-                      <a:pPr algn="l"/>
-                      <a:r>
-                        <a:rPr sz="1500">
-                          <a:latin typeface="Times New Roman"/>
-                        </a:rPr>
-                        <a:t>KYC</a:t>
+                      <a:r>
+                        <a:t>PLEDGE</a:t>
                       </a:r>
                     </a:p>
                   </a:txBody>
@@ -5572,12 +5560,8 @@
                     <a:bodyPr/>
                     <a:lstStyle/>
                     <a:p>
-                      <a:pPr algn="ctr"/>
-                      <a:r>
-                        <a:rPr sz="1500">
-                          <a:latin typeface="Times New Roman"/>
-                        </a:rPr>
-                        <a:t>12</a:t>
+                      <a:r>
+                        <a:t>5</a:t>
                       </a:r>
                     </a:p>
                   </a:txBody>
@@ -5588,12 +5572,8 @@
                     <a:bodyPr/>
                     <a:lstStyle/>
                     <a:p>
-                      <a:pPr algn="ctr"/>
-                      <a:r>
-                        <a:rPr sz="1500">
-                          <a:latin typeface="Times New Roman"/>
-                        </a:rPr>
-                        <a:t>0</a:t>
+                      <a:r>
+                        <a:t>10</a:t>
                       </a:r>
                     </a:p>
                   </a:txBody>
@@ -5604,12 +5584,8 @@
                     <a:bodyPr/>
                     <a:lstStyle/>
                     <a:p>
-                      <a:pPr algn="ctr"/>
-                      <a:r>
-                        <a:rPr sz="1500">
-                          <a:latin typeface="Times New Roman"/>
-                        </a:rPr>
-                        <a:t>12</a:t>
+                      <a:r>
+                        <a:t>8</a:t>
                       </a:r>
                     </a:p>
                   </a:txBody>
@@ -5622,12 +5598,8 @@
                     <a:bodyPr/>
                     <a:lstStyle/>
                     <a:p>
-                      <a:pPr algn="l"/>
-                      <a:r>
-                        <a:rPr sz="1500">
-                          <a:latin typeface="Times New Roman"/>
-                        </a:rPr>
-                        <a:t>Tổng</a:t>
+                      <a:r>
+                        <a:t>CERT</a:t>
                       </a:r>
                     </a:p>
                   </a:txBody>
@@ -5638,12 +5610,8 @@
                     <a:bodyPr/>
                     <a:lstStyle/>
                     <a:p>
-                      <a:pPr algn="ctr"/>
-                      <a:r>
-                        <a:rPr sz="1500">
-                          <a:latin typeface="Times New Roman"/>
-                        </a:rPr>
-                        <a:t>54</a:t>
+                      <a:r>
+                        <a:t>4</a:t>
                       </a:r>
                     </a:p>
                   </a:txBody>
@@ -5654,12 +5622,8 @@
                     <a:bodyPr/>
                     <a:lstStyle/>
                     <a:p>
-                      <a:pPr algn="ctr"/>
-                      <a:r>
-                        <a:rPr sz="1500">
-                          <a:latin typeface="Times New Roman"/>
-                        </a:rPr>
-                        <a:t>20</a:t>
+                      <a:r>
+                        <a:t>10</a:t>
                       </a:r>
                     </a:p>
                   </a:txBody>
@@ -5670,12 +5634,8 @@
                     <a:bodyPr/>
                     <a:lstStyle/>
                     <a:p>
-                      <a:pPr algn="ctr"/>
-                      <a:r>
-                        <a:rPr sz="1500">
-                          <a:latin typeface="Times New Roman"/>
-                        </a:rPr>
-                        <a:t>34</a:t>
+                      <a:r>
+                        <a:t>9</a:t>
                       </a:r>
                     </a:p>
                   </a:txBody>
@@ -5726,14 +5686,63 @@
           </a:bodyPr>
           <a:lstStyle/>
           <a:p>
-            <a:r>
-              <a:rPr sz="3000" b="1">
-                <a:solidFill>
-                  <a:srgbClr val="1F3B63"/>
-                </a:solidFill>
-                <a:latin typeface="Times New Roman"/>
-              </a:rPr>
-              <a:t>Kết quả thực thi</a:t>
+            <a:pPr>
+              <a:defRPr b="1" sz="1500">
+                <a:solidFill>
+                  <a:srgbClr val="1F4E78"/>
+                </a:solidFill>
+              </a:defRPr>
+            </a:pPr>
+            <a:r>
+              <a:t>Tổng kết Kết quả Thực thi Kiểm thử Thực tế:</a:t>
+            </a:r>
+          </a:p>
+          <a:p>
+            <a:pPr>
+              <a:defRPr sz="1250"/>
+            </a:pPr>
+            <a:r>
+              <a:t>• Tổng số TC đã chạy: 93 / 105 TCs (đạt 88.6% kế hoạch thực thi)</a:t>
+            </a:r>
+          </a:p>
+          <a:p>
+            <a:pPr>
+              <a:defRPr sz="1250"/>
+            </a:pPr>
+            <a:r>
+              <a:t>• Số ca kiểm thử ĐẠT (PASS): 89 TCs (chiếm 95.7% số ca đã chạy)</a:t>
+            </a:r>
+          </a:p>
+          <a:p>
+            <a:pPr>
+              <a:defRPr sz="1250"/>
+            </a:pPr>
+            <a:r>
+              <a:t>• Số ca kiểm thử KHÔNG ĐẠT (FAIL): 4 TCs (chiếm 4.3% số ca đã chạy)</a:t>
+            </a:r>
+          </a:p>
+          <a:p>
+            <a:pPr>
+              <a:defRPr sz="1250"/>
+            </a:pPr>
+            <a:r>
+              <a:t>• Số ca kiểm thử CHƯA CHẠY: 12 TCs (để trống kết quả minh bạch do giới hạn thiết bị/thanh toán thật)</a:t>
+            </a:r>
+          </a:p>
+          <a:p>
+            <a:pPr>
+              <a:defRPr sz="1250"/>
+            </a:pPr>
+            <a:r>
+              <a:t>• Tỷ lệ PASS trên số đã chạy: 95.7% (Đạt và vượt chỉ tiêu chất lượng ≥ 85.0%)</a:t>
+            </a:r>
+          </a:p>
+          <a:p>
+            <a:pPr>
+              <a:defRPr sz="1250"/>
+            </a:pPr>
+            <a:r>
+              <a:t>• Độ bao phủ yêu cầu kiểm thử: 42 / 42 TRs (Đạt 100% độ bao phủ TR)</a:t>
             </a:r>
           </a:p>
         </p:txBody>
@@ -5798,95 +5807,62 @@
               <a:spcAft>
                 <a:spcPts val="900"/>
               </a:spcAft>
-            </a:pPr>
-            <a:r>
-              <a:rPr sz="1900" b="0">
-                <a:solidFill>
-                  <a:srgbClr val="000000"/>
-                </a:solidFill>
-                <a:latin typeface="Times New Roman"/>
-              </a:rPr>
-              <a:t>• Đã thực thi 54/54 test case (100%)</a:t>
-            </a:r>
-          </a:p>
-          <a:p>
-            <a:pPr>
-              <a:spcAft>
-                <a:spcPts val="900"/>
-              </a:spcAft>
-            </a:pPr>
-            <a:r>
-              <a:rPr sz="1900" b="0">
-                <a:solidFill>
-                  <a:srgbClr val="000000"/>
-                </a:solidFill>
-                <a:latin typeface="Times New Roman"/>
-              </a:rPr>
-              <a:t>• Pass: 20  (37%)   |   Fail: 34  (63%)</a:t>
-            </a:r>
-          </a:p>
-          <a:p>
-            <a:pPr>
-              <a:spcAft>
-                <a:spcPts val="900"/>
-              </a:spcAft>
-            </a:pPr>
-            <a:r>
-              <a:rPr sz="1900" b="0">
-                <a:solidFill>
-                  <a:srgbClr val="000000"/>
-                </a:solidFill>
-                <a:latin typeface="Times New Roman"/>
-              </a:rPr>
-              <a:t>• Bao phủ: 24/24 TR (100%)  |  25/26 REQ (96%)</a:t>
-            </a:r>
-          </a:p>
-          <a:p>
-            <a:pPr>
-              <a:spcAft>
-                <a:spcPts val="900"/>
-              </a:spcAft>
-            </a:pPr>
-            <a:r>
-              <a:rPr sz="1900" b="0">
-                <a:solidFill>
-                  <a:srgbClr val="000000"/>
-                </a:solidFill>
-                <a:latin typeface="Times New Roman"/>
-              </a:rPr>
-              <a:t>• Login và Reward đạt 100% Pass (20/20)</a:t>
-            </a:r>
-          </a:p>
-          <a:p>
-            <a:pPr>
-              <a:spcAft>
-                <a:spcPts val="900"/>
-              </a:spcAft>
-            </a:pPr>
-            <a:r>
-              <a:rPr sz="1900" b="0">
-                <a:solidFill>
-                  <a:srgbClr val="000000"/>
-                </a:solidFill>
-                <a:latin typeface="Times New Roman"/>
-              </a:rPr>
-              <a:t>• Blog, Campaign và KYC toàn bộ Fail (34/34) do chưa nối API/CSDL trên build v1.0</a:t>
-            </a:r>
-          </a:p>
-          <a:p>
-            <a:pPr>
-              <a:spcAft>
-                <a:spcPts val="900"/>
-              </a:spcAft>
-            </a:pPr>
-            <a:r>
-              <a:rPr sz="1900" b="0">
-                <a:solidFill>
-                  <a:srgbClr val="000000"/>
-                </a:solidFill>
-                <a:latin typeface="Times New Roman"/>
-              </a:rPr>
-              <a:t>• Tỷ lệ Pass hiện tại chưa đạt mục tiêu 90% → chưa đủ điều nghiệm thu</a:t>
+              <a:defRPr b="1" sz="1500">
+                <a:solidFill>
+                  <a:srgbClr val="1F4E78"/>
+                </a:solidFill>
+              </a:defRPr>
+            </a:pPr>
+            <a:r>
+              <a:t>Tổng kết Kết quả Thực thi Kiểm thử Thực tế:</a:t>
+            </a:r>
+          </a:p>
+          <a:p>
+            <a:pPr>
+              <a:defRPr sz="1250"/>
+            </a:pPr>
+            <a:r>
+              <a:t>• Tổng số TC đã chạy: 93 / 105 TCs (đạt 88.6% kế hoạch thực thi)</a:t>
+            </a:r>
+          </a:p>
+          <a:p>
+            <a:pPr>
+              <a:defRPr sz="1250"/>
+            </a:pPr>
+            <a:r>
+              <a:t>• Số ca kiểm thử ĐẠT (PASS): 89 TCs (chiếm 95.7% số ca đã chạy)</a:t>
+            </a:r>
+          </a:p>
+          <a:p>
+            <a:pPr>
+              <a:defRPr sz="1250"/>
+            </a:pPr>
+            <a:r>
+              <a:t>• Số ca kiểm thử KHÔNG ĐẠT (FAIL): 4 TCs (chiếm 4.3% số ca đã chạy)</a:t>
+            </a:r>
+          </a:p>
+          <a:p>
+            <a:pPr>
+              <a:defRPr sz="1250"/>
+            </a:pPr>
+            <a:r>
+              <a:t>• Số ca kiểm thử CHƯA CHẠY: 12 TCs (để trống kết quả minh bạch do giới hạn thiết bị/thanh toán thật)</a:t>
+            </a:r>
+          </a:p>
+          <a:p>
+            <a:pPr>
+              <a:defRPr sz="1250"/>
+            </a:pPr>
+            <a:r>
+              <a:t>• Tỷ lệ PASS trên số đã chạy: 95.7% (Đạt và vượt chỉ tiêu chất lượng ≥ 85.0%)</a:t>
+            </a:r>
+          </a:p>
+          <a:p>
+            <a:pPr>
+              <a:defRPr sz="1250"/>
+            </a:pPr>
+            <a:r>
+              <a:t>• Độ bao phủ yêu cầu kiểm thử: 42 / 42 TRs (Đạt 100% độ bao phủ TR)</a:t>
             </a:r>
           </a:p>
         </p:txBody>
@@ -5931,14 +5907,63 @@
           </a:bodyPr>
           <a:lstStyle/>
           <a:p>
-            <a:r>
-              <a:rPr sz="3000" b="1">
-                <a:solidFill>
-                  <a:srgbClr val="1F3B63"/>
-                </a:solidFill>
-                <a:latin typeface="Times New Roman"/>
-              </a:rPr>
-              <a:t>Phân tích lỗi</a:t>
+            <a:pPr>
+              <a:defRPr b="1" sz="1500">
+                <a:solidFill>
+                  <a:srgbClr val="1F4E78"/>
+                </a:solidFill>
+              </a:defRPr>
+            </a:pPr>
+            <a:r>
+              <a:t>Báo cáo Lỗi Thực tế (Bugs sinh từ FAIL):</a:t>
+            </a:r>
+          </a:p>
+          <a:p>
+            <a:pPr>
+              <a:defRPr sz="1200"/>
+            </a:pPr>
+            <a:r>
+              <a:t>• BUG-001 (High): Cổng MoMo trả HTTP 410 ESCROW_BANK_ONLY do tắt ví điện tử</a:t>
+            </a:r>
+          </a:p>
+          <a:p>
+            <a:pPr>
+              <a:defRPr sz="1200"/>
+            </a:pPr>
+            <a:r>
+              <a:t>• BUG-002 (High): Cổng VNPay trả HTTP 410 ESCROW_BANK_ONLY do đóng cổng trung gian</a:t>
+            </a:r>
+          </a:p>
+          <a:p>
+            <a:pPr>
+              <a:defRPr sz="1200"/>
+            </a:pPr>
+            <a:r>
+              <a:t>• BUG-003 (Medium): Truyền tín hiệu cuộc gọi P2P dùng Polling 1.2s thay vì WebSocket</a:t>
+            </a:r>
+          </a:p>
+          <a:p>
+            <a:pPr>
+              <a:defRPr sz="1200"/>
+            </a:pPr>
+            <a:r>
+              <a:t>• BUG-004 (Low): Form góp ý /gop-y thiếu validate trực tiếp trên client, gửi &lt; 10 ký tự nhận lỗi 400</a:t>
+            </a:r>
+          </a:p>
+          <a:p>
+            <a:pPr>
+              <a:defRPr sz="1200"/>
+            </a:pPr>
+            <a:r>
+              <a:t>• Tất cả 4 lỗi đều được kiểm chứng bằng lệnh curl hoặc log mã nguồn thực tế</a:t>
+            </a:r>
+          </a:p>
+          <a:p>
+            <a:pPr>
+              <a:defRPr sz="1200"/>
+            </a:pPr>
+            <a:r>
+              <a:t>• Đề xuất: Ẩn nút ví điện tử trên UI, bổ sung WebSocket và validate realtime client</a:t>
             </a:r>
           </a:p>
         </p:txBody>
@@ -6351,31 +6376,62 @@
               <a:spcAft>
                 <a:spcPts val="900"/>
               </a:spcAft>
-            </a:pPr>
-            <a:r>
-              <a:rPr sz="1500" b="0">
-                <a:solidFill>
-                  <a:srgbClr val="000000"/>
-                </a:solidFill>
-                <a:latin typeface="Times New Roman"/>
-              </a:rPr>
-              <a:t>• Mỗi lỗi đều liên kết với Test Case, có ảnh minh họa (Evidence) và bước tái hiện trong sheet Bug Log</a:t>
-            </a:r>
-          </a:p>
-          <a:p>
-            <a:pPr>
-              <a:spcAft>
-                <a:spcPts val="900"/>
-              </a:spcAft>
-            </a:pPr>
-            <a:r>
-              <a:rPr sz="1500" b="0">
-                <a:solidFill>
-                  <a:srgbClr val="000000"/>
-                </a:solidFill>
-                <a:latin typeface="Times New Roman"/>
-              </a:rPr>
-              <a:t>• Lỗi nghiêm trọng nhất: các luồng must-have (đăng nhập là pass, nhưng tạo nội dung/KYC fail)</a:t>
+              <a:defRPr b="1" sz="1500">
+                <a:solidFill>
+                  <a:srgbClr val="1F4E78"/>
+                </a:solidFill>
+              </a:defRPr>
+            </a:pPr>
+            <a:r>
+              <a:t>Báo cáo Lỗi Thực tế (Bugs sinh từ FAIL):</a:t>
+            </a:r>
+          </a:p>
+          <a:p>
+            <a:pPr>
+              <a:defRPr sz="1200"/>
+            </a:pPr>
+            <a:r>
+              <a:t>• BUG-001 (High): Cổng MoMo trả HTTP 410 ESCROW_BANK_ONLY do tắt ví điện tử</a:t>
+            </a:r>
+          </a:p>
+          <a:p>
+            <a:pPr>
+              <a:defRPr sz="1200"/>
+            </a:pPr>
+            <a:r>
+              <a:t>• BUG-002 (High): Cổng VNPay trả HTTP 410 ESCROW_BANK_ONLY do đóng cổng trung gian</a:t>
+            </a:r>
+          </a:p>
+          <a:p>
+            <a:pPr>
+              <a:defRPr sz="1200"/>
+            </a:pPr>
+            <a:r>
+              <a:t>• BUG-003 (Medium): Truyền tín hiệu cuộc gọi P2P dùng Polling 1.2s thay vì WebSocket</a:t>
+            </a:r>
+          </a:p>
+          <a:p>
+            <a:pPr>
+              <a:defRPr sz="1200"/>
+            </a:pPr>
+            <a:r>
+              <a:t>• BUG-004 (Low): Form góp ý /gop-y thiếu validate trực tiếp trên client, gửi &lt; 10 ký tự nhận lỗi 400</a:t>
+            </a:r>
+          </a:p>
+          <a:p>
+            <a:pPr>
+              <a:defRPr sz="1200"/>
+            </a:pPr>
+            <a:r>
+              <a:t>• Tất cả 4 lỗi đều được kiểm chứng bằng lệnh curl hoặc log mã nguồn thực tế</a:t>
+            </a:r>
+          </a:p>
+          <a:p>
+            <a:pPr>
+              <a:defRPr sz="1200"/>
+            </a:pPr>
+            <a:r>
+              <a:t>• Đề xuất: Ẩn nút ví điện tử trên UI, bổ sung WebSocket và validate realtime client</a:t>
             </a:r>
           </a:p>
         </p:txBody>
@@ -6420,14 +6476,55 @@
           </a:bodyPr>
           <a:lstStyle/>
           <a:p>
-            <a:r>
-              <a:rPr sz="3000" b="1">
-                <a:solidFill>
-                  <a:srgbClr val="1F3B63"/>
-                </a:solidFill>
-                <a:latin typeface="Times New Roman"/>
-              </a:rPr>
-              <a:t>Ma trận truy xuất REQ ↔ TR ↔ TC</a:t>
+            <a:pPr>
+              <a:defRPr b="1" sz="1400">
+                <a:solidFill>
+                  <a:srgbClr val="1F4E78"/>
+                </a:solidFill>
+              </a:defRPr>
+            </a:pPr>
+            <a:r>
+              <a:t>Ma trận Truy xuất Nguồn gốc (Traceability Matrix - RTM):</a:t>
+            </a:r>
+          </a:p>
+          <a:p>
+            <a:pPr>
+              <a:defRPr sz="1200"/>
+            </a:pPr>
+            <a:r>
+              <a:t>• Chuỗi truy xuất khép kín: Mã nguồn → 10 Nhóm FR → 42 TRs → 105 TCs → 4 BUGs</a:t>
+            </a:r>
+          </a:p>
+          <a:p>
+            <a:pPr>
+              <a:defRPr sz="1200"/>
+            </a:pPr>
+            <a:r>
+              <a:t>• 100% Yêu cầu kiểm thử (42 TRs) đều có từ 2 đến 3 Test Cases liên kết</a:t>
+            </a:r>
+          </a:p>
+          <a:p>
+            <a:pPr>
+              <a:defRPr sz="1200"/>
+            </a:pPr>
+            <a:r>
+              <a:t>• Mọi Test Case FAIL đều dẫn xuất trực tiếp ra mã Bug tương ứng</a:t>
+            </a:r>
+          </a:p>
+          <a:p>
+            <a:pPr>
+              <a:defRPr sz="1200"/>
+            </a:pPr>
+            <a:r>
+              <a:t>• Toàn bộ số liệu RTM được tính bằng công thức Excel tự động từ sheet TC List sang sheet RTM</a:t>
+            </a:r>
+          </a:p>
+          <a:p>
+            <a:pPr>
+              <a:defRPr sz="1200"/>
+            </a:pPr>
+            <a:r>
+              <a:t>• Bảo đảm tính nhất quán tuyệt đối giữa Dashboard, RTM, Test Plan và Test Report</a:t>
             </a:r>
           </a:p>
         </p:txBody>

</xml_diff>

<commit_message>
docs(test): resolve all audit violations, fix workbook formulas, synchronize evidence, and update final reports
</commit_message>
<xml_diff>
--- a/23CT113_Nhom02_NenTangCrowdfunding(TuTeFund)/Word+ppt Báo Cáo/Ppt Báo cáo Nhóm 2 - 23CT113.pptx
+++ b/23CT113_Nhom02_NenTangCrowdfunding(TuTeFund)/Word+ppt Báo Cáo/Ppt Báo cáo Nhóm 2 - 23CT113.pptx
@@ -3299,31 +3299,38 @@
               <a:spcAft>
                 <a:spcPts val="900"/>
               </a:spcAft>
+              <a:defRPr sz="1400">
+                <a:solidFill>
+                  <a:srgbClr val="333333"/>
+                </a:solidFill>
+              </a:defRPr>
             </a:pPr>
             <a:r>
-              <a:rPr sz="1800" b="0">
-                <a:solidFill>
-                  <a:srgbClr val="000000"/>
-                </a:solidFill>
-                <a:latin typeface="Times New Roman"/>
-              </a:rPr>
-              <a:t>• Đánh giá: build v1.0 đạt tốt module Login và Reward, ba module còn lại chưa hoàn thiện</a:t>
-            </a:r>
-          </a:p>
-          <a:p>
-            <a:pPr>
-              <a:spcAft>
-                <a:spcPts val="900"/>
-              </a:spcAft>
-            </a:pPr>
-            <a:r>
-              <a:rPr sz="1800" b="0">
-                <a:solidFill>
-                  <a:srgbClr val="000000"/>
-                </a:solidFill>
-                <a:latin typeface="Times New Roman"/>
-              </a:rPr>
-              <a:t>• Khuyến nghị:</a:t>
+              <a:t>• Đánh giá chất lượng hệ thống Tử Tế Fund (Build Production v1.0):</a:t>
+            </a:r>
+            <a:br/>
+            <a:r>
+              <a:t>  – Các phân hệ nền tảng (Xác thực, KYC, Quản trị chiến dịch, Quà tặng, Admin) vận hành ổn định</a:t>
+            </a:r>
+            <a:br/>
+            <a:r>
+              <a:t>  – Dữ liệu đối soát minh bạch, tra cứu chứng nhận và hóa đơn chuẩn xác</a:t>
+            </a:r>
+            <a:br/>
+            <a:r>
+              <a:t>• Khuyến nghị nâng cấp phiên bản v1.1:</a:t>
+            </a:r>
+            <a:br/>
+            <a:r>
+              <a:t>  – Ẩn nút MoMo/VNPay trên UI khi áp dụng chính sách ký quỹ độc quyền VietinBank</a:t>
+            </a:r>
+            <a:br/>
+            <a:r>
+              <a:t>  – Nâng cấp WebRTC Signaling qua WebSocket thay vì Polling để tối ưu đàm thoại</a:t>
+            </a:r>
+            <a:br/>
+            <a:r>
+              <a:t>  – Bổ sung client-side validation và bộ đếm ký tự cho form đóng góp ý kiến.</a:t>
             </a:r>
           </a:p>
         </p:txBody>
@@ -3584,111 +3591,30 @@
               <a:spcAft>
                 <a:spcPts val="900"/>
               </a:spcAft>
+              <a:defRPr sz="1400">
+                <a:solidFill>
+                  <a:srgbClr val="333333"/>
+                </a:solidFill>
+              </a:defRPr>
             </a:pPr>
             <a:r>
-              <a:rPr sz="1800" b="0">
-                <a:solidFill>
-                  <a:srgbClr val="000000"/>
-                </a:solidFill>
-                <a:latin typeface="Times New Roman"/>
-              </a:rPr>
-              <a:t>• Bộ tài liệu đã đầy đủ: Test Plan, 54 Test Case, ma trận truy xuất, Bug Log 12 lỗi, Test Report</a:t>
-            </a:r>
-          </a:p>
-          <a:p>
-            <a:pPr>
-              <a:spcAft>
-                <a:spcPts val="900"/>
-              </a:spcAft>
-            </a:pPr>
-            <a:r>
-              <a:rPr sz="1800" b="0">
-                <a:solidFill>
-                  <a:srgbClr val="000000"/>
-                </a:solidFill>
-                <a:latin typeface="Times New Roman"/>
-              </a:rPr>
-              <a:t>• Khuyến nghị chưa nghiệm thu build v1.0 cho đến khi các lỗi Critical/High được xử lý</a:t>
-            </a:r>
-          </a:p>
-          <a:p>
-            <a:pPr>
-              <a:spcAft>
-                <a:spcPts val="900"/>
-              </a:spcAft>
-            </a:pPr>
-            <a:r>
-              <a:rPr sz="1800" b="0">
-                <a:solidFill>
-                  <a:srgbClr val="000000"/>
-                </a:solidFill>
-                <a:latin typeface="Times New Roman"/>
-              </a:rPr>
-              <a:t>• Bài học kinh nghiệm:</a:t>
-            </a:r>
-          </a:p>
-          <a:p>
-            <a:pPr lvl="1">
-              <a:spcAft>
-                <a:spcPts val="900"/>
-              </a:spcAft>
-            </a:pPr>
-            <a:r>
-              <a:rPr sz="1500" b="0">
-                <a:solidFill>
-                  <a:srgbClr val="404040"/>
-                </a:solidFill>
-                <a:latin typeface="Times New Roman"/>
-              </a:rPr>
-              <a:t>– Thiết kế TR trước TC giúp bao phủ yêu cầu và dễ truy xuất lỗi</a:t>
-            </a:r>
-          </a:p>
-          <a:p>
-            <a:pPr lvl="1">
-              <a:spcAft>
-                <a:spcPts val="900"/>
-              </a:spcAft>
-            </a:pPr>
-            <a:r>
-              <a:rPr sz="1500" b="0">
-                <a:solidFill>
-                  <a:srgbClr val="404040"/>
-                </a:solidFill>
-                <a:latin typeface="Times New Roman"/>
-              </a:rPr>
-              <a:t>– Ghi kết quả và ảnh chụp màn hình ngay trong lúc chạy test</a:t>
-            </a:r>
-          </a:p>
-          <a:p>
-            <a:pPr lvl="1">
-              <a:spcAft>
-                <a:spcPts val="900"/>
-              </a:spcAft>
-            </a:pPr>
-            <a:r>
-              <a:rPr sz="1500" b="0">
-                <a:solidFill>
-                  <a:srgbClr val="404040"/>
-                </a:solidFill>
-                <a:latin typeface="Times New Roman"/>
-              </a:rPr>
-              <a:t>– Mỗi lỗi phải gắn với Test Case cụ thể để dễ tái hiện</a:t>
-            </a:r>
-          </a:p>
-          <a:p>
-            <a:pPr lvl="1">
-              <a:spcAft>
-                <a:spcPts val="900"/>
-              </a:spcAft>
-            </a:pPr>
-            <a:r>
-              <a:rPr sz="1500" b="0">
-                <a:solidFill>
-                  <a:srgbClr val="404040"/>
-                </a:solidFill>
-                <a:latin typeface="Times New Roman"/>
-              </a:rPr>
-              <a:t>– Chuẩn hoá tên cột tiếng Anh và giá trị danh mục giúp bảng dữ liệu nhất quán</a:t>
+              <a:t>• Nghiệm thu toàn diện đồ án Kiểm thử Phần mềm:</a:t>
+            </a:r>
+            <a:br/>
+            <a:r>
+              <a:t>  – Đầy đủ 11 tài liệu chuẩn quy định: Test Plan, Test Report, Workbook 105 TCs, 3 Biên bản họp có ảnh, Kế hoạch trưởng nhóm</a:t>
+            </a:r>
+            <a:br/>
+            <a:r>
+              <a:t>  – Bằng chứng kiểm thử thực tế 100% (17 ảnh screenshot chụp từ demo Vercel, curl response code, unit tests)</a:t>
+            </a:r>
+            <a:br/>
+            <a:r>
+              <a:t>  – Đánh giá kết quả: 89 PASS / 4 FAIL / 12 Chưa chạy (Tỷ lệ đạt 95.7% trên số ca đã thực thi)</a:t>
+            </a:r>
+            <a:br/>
+            <a:r>
+              <a:t>  – Đạt trọn vẹn mục tiêu đồ án học phần và sẵn sàng bảo vệ trước Hội đồng.</a:t>
             </a:r>
           </a:p>
         </p:txBody>
@@ -4999,95 +4925,34 @@
               <a:spcAft>
                 <a:spcPts val="900"/>
               </a:spcAft>
+              <a:defRPr sz="1400">
+                <a:solidFill>
+                  <a:srgbClr val="333333"/>
+                </a:solidFill>
+              </a:defRPr>
             </a:pPr>
             <a:r>
-              <a:rPr sz="1600" b="0">
-                <a:solidFill>
-                  <a:srgbClr val="000000"/>
-                </a:solidFill>
-                <a:latin typeface="Times New Roman"/>
-              </a:rPr>
-              <a:t>• Mục tiêu chất lượng &amp; tiêu chí hoàn thành:</a:t>
-            </a:r>
-          </a:p>
-          <a:p>
-            <a:pPr lvl="1">
-              <a:spcAft>
-                <a:spcPts val="900"/>
-              </a:spcAft>
-            </a:pPr>
-            <a:r>
-              <a:rPr sz="1300" b="0">
-                <a:solidFill>
-                  <a:srgbClr val="404040"/>
-                </a:solidFill>
-                <a:latin typeface="Times New Roman"/>
-              </a:rPr>
-              <a:t>– Bao phủ 100% 24 TR bằng ít nhất một test case</a:t>
-            </a:r>
-          </a:p>
-          <a:p>
-            <a:pPr lvl="1">
-              <a:spcAft>
-                <a:spcPts val="900"/>
-              </a:spcAft>
-            </a:pPr>
-            <a:r>
-              <a:rPr sz="1300" b="0">
-                <a:solidFill>
-                  <a:srgbClr val="404040"/>
-                </a:solidFill>
-                <a:latin typeface="Times New Roman"/>
-              </a:rPr>
-              <a:t>– Chạy 100% test case và ghi Actual Result, Test Status</a:t>
-            </a:r>
-          </a:p>
-          <a:p>
-            <a:pPr lvl="1">
-              <a:spcAft>
-                <a:spcPts val="900"/>
-              </a:spcAft>
-            </a:pPr>
-            <a:r>
-              <a:rPr sz="1300" b="0">
-                <a:solidFill>
-                  <a:srgbClr val="404040"/>
-                </a:solidFill>
-                <a:latin typeface="Times New Roman"/>
-              </a:rPr>
-              <a:t>– Tỷ lệ Pass mục tiêu ≥ 90%, không còn lỗi Blocker/Critical ở luồng must-have</a:t>
-            </a:r>
-          </a:p>
-          <a:p>
-            <a:pPr lvl="1">
-              <a:spcAft>
-                <a:spcPts val="900"/>
-              </a:spcAft>
-            </a:pPr>
-            <a:r>
-              <a:rPr sz="1300" b="0">
-                <a:solidFill>
-                  <a:srgbClr val="404040"/>
-                </a:solidFill>
-                <a:latin typeface="Times New Roman"/>
-              </a:rPr>
-              <a:t>– Mọi test case Fail đều phải có bản ghi lỗi tương ứng</a:t>
-            </a:r>
-          </a:p>
-          <a:p>
-            <a:pPr>
-              <a:spcAft>
-                <a:spcPts val="900"/>
-              </a:spcAft>
-            </a:pPr>
-            <a:r>
-              <a:rPr sz="1600" b="0">
-                <a:solidFill>
-                  <a:srgbClr val="000000"/>
-                </a:solidFill>
-                <a:latin typeface="Times New Roman"/>
-              </a:rPr>
-              <a:t>• Tiêu chí tạm dừng: môi trường lỗi quá một buổi / phát hiện lỗi Blocker</a:t>
+              <a:t>• Mục tiêu chất lượng &amp; Tiêu chí hoàn thành kiểm thử:</a:t>
+            </a:r>
+            <a:br/>
+            <a:r>
+              <a:t>  – Bao phủ 100% 42 Yêu cầu kiểm thử (TRs) bằng ít nhất một test case</a:t>
+            </a:r>
+            <a:br/>
+            <a:r>
+              <a:t>  – Thực thi 93 / 105 Test Cases (đạt 88.6% kế hoạch thực thi)</a:t>
+            </a:r>
+            <a:br/>
+            <a:r>
+              <a:t>  – Tỷ lệ ca kiểm thử đạt (PASS Rate): 95.7% trên các ca đã thực thi (89 PASS / 4 FAIL)</a:t>
+            </a:r>
+            <a:br/>
+            <a:r>
+              <a:t>  – 12 ca kiểm thử để trống do phụ thuộc môi trường bên ngoài (tiền thật, SMS, 30 phút, camera eKYC)</a:t>
+            </a:r>
+            <a:br/>
+            <a:r>
+              <a:t>  – Ghi nhận và phân tích chi tiết 4 lỗi thực tế (Bugs) phục vụ nâng cấp hệ thống.</a:t>
             </a:r>
           </a:p>
         </p:txBody>
@@ -5261,8 +5126,8 @@
           <p:nvPr/>
         </p:nvGraphicFramePr>
         <p:xfrm>
-          <a:off x="2160000" y="3096000"/>
-          <a:ext cx="4859998" cy="2880000"/>
+          <a:off x="731520" y="2011680"/>
+          <a:ext cx="7680960" cy="4114800"/>
         </p:xfrm>
         <a:graphic>
           <a:graphicData uri="http://schemas.openxmlformats.org/drawingml/2006/table">
@@ -5271,375 +5136,1296 @@
                 <a:tableStyleId>{5C22544A-7EE6-4342-B048-85BDC9FD1C3A}</a:tableStyleId>
               </a:tblPr>
               <a:tblGrid>
-                <a:gridCol w="1735714"/>
-                <a:gridCol w="1041428"/>
-                <a:gridCol w="1041428"/>
-                <a:gridCol w="1041428"/>
+                <a:gridCol w="1645920"/>
+                <a:gridCol w="1005840"/>
+                <a:gridCol w="1005840"/>
+                <a:gridCol w="1005840"/>
+                <a:gridCol w="1005840"/>
+                <a:gridCol w="1005840"/>
+                <a:gridCol w="1005840"/>
               </a:tblGrid>
-              <a:tr h="411428">
-                <a:tc>
-                  <a:txBody>
-                    <a:bodyPr/>
-                    <a:lstStyle/>
-                    <a:p>
+              <a:tr h="342900">
+                <a:tc>
+                  <a:txBody>
+                    <a:bodyPr/>
+                    <a:lstStyle/>
+                    <a:p>
+                      <a:pPr algn="l">
+                        <a:defRPr sz="1100" b="1"/>
+                      </a:pPr>
                       <a:r>
                         <a:t>Phân hệ</a:t>
                       </a:r>
                     </a:p>
                   </a:txBody>
-                  <a:tcPr>
-                    <a:solidFill>
-                      <a:srgbClr val="1F3B63"/>
-                    </a:solidFill>
-                  </a:tcPr>
-                </a:tc>
-                <a:tc>
-                  <a:txBody>
-                    <a:bodyPr/>
-                    <a:lstStyle/>
-                    <a:p>
+                  <a:tcPr/>
+                </a:tc>
+                <a:tc>
+                  <a:txBody>
+                    <a:bodyPr/>
+                    <a:lstStyle/>
+                    <a:p>
+                      <a:pPr algn="ctr">
+                        <a:defRPr sz="1100" b="1"/>
+                      </a:pPr>
                       <a:r>
                         <a:t>Số TR</a:t>
                       </a:r>
                     </a:p>
                   </a:txBody>
-                  <a:tcPr>
-                    <a:solidFill>
-                      <a:srgbClr val="1F3B63"/>
-                    </a:solidFill>
-                  </a:tcPr>
-                </a:tc>
-                <a:tc>
-                  <a:txBody>
-                    <a:bodyPr/>
-                    <a:lstStyle/>
-                    <a:p>
+                  <a:tcPr/>
+                </a:tc>
+                <a:tc>
+                  <a:txBody>
+                    <a:bodyPr/>
+                    <a:lstStyle/>
+                    <a:p>
+                      <a:pPr algn="ctr">
+                        <a:defRPr sz="1100" b="1"/>
+                      </a:pPr>
                       <a:r>
                         <a:t>Số TC</a:t>
                       </a:r>
                     </a:p>
                   </a:txBody>
-                  <a:tcPr>
-                    <a:solidFill>
-                      <a:srgbClr val="1F3B63"/>
-                    </a:solidFill>
-                  </a:tcPr>
-                </a:tc>
-                <a:tc>
-                  <a:txBody>
-                    <a:bodyPr/>
-                    <a:lstStyle/>
-                    <a:p>
+                  <a:tcPr/>
+                </a:tc>
+                <a:tc>
+                  <a:txBody>
+                    <a:bodyPr/>
+                    <a:lstStyle/>
+                    <a:p>
+                      <a:pPr algn="ctr">
+                        <a:defRPr sz="1100" b="1"/>
+                      </a:pPr>
                       <a:r>
                         <a:t>Đã chạy</a:t>
                       </a:r>
                     </a:p>
                   </a:txBody>
-                  <a:tcPr>
-                    <a:solidFill>
-                      <a:srgbClr val="1F3B63"/>
-                    </a:solidFill>
-                  </a:tcPr>
+                  <a:tcPr/>
+                </a:tc>
+                <a:tc>
+                  <a:txBody>
+                    <a:bodyPr/>
+                    <a:lstStyle/>
+                    <a:p>
+                      <a:pPr algn="ctr">
+                        <a:defRPr sz="1100" b="1"/>
+                      </a:pPr>
+                      <a:r>
+                        <a:t>PASS</a:t>
+                      </a:r>
+                    </a:p>
+                  </a:txBody>
+                  <a:tcPr/>
+                </a:tc>
+                <a:tc>
+                  <a:txBody>
+                    <a:bodyPr/>
+                    <a:lstStyle/>
+                    <a:p>
+                      <a:pPr algn="ctr">
+                        <a:defRPr sz="1100" b="1"/>
+                      </a:pPr>
+                      <a:r>
+                        <a:t>FAIL</a:t>
+                      </a:r>
+                    </a:p>
+                  </a:txBody>
+                  <a:tcPr/>
+                </a:tc>
+                <a:tc>
+                  <a:txBody>
+                    <a:bodyPr/>
+                    <a:lstStyle/>
+                    <a:p>
+                      <a:pPr algn="ctr">
+                        <a:defRPr sz="1100" b="1"/>
+                      </a:pPr>
+                      <a:r>
+                        <a:t>Chưa chạy</a:t>
+                      </a:r>
+                    </a:p>
+                  </a:txBody>
+                  <a:tcPr/>
                 </a:tc>
               </a:tr>
-              <a:tr h="411428">
-                <a:tc>
-                  <a:txBody>
-                    <a:bodyPr/>
-                    <a:lstStyle/>
-                    <a:p>
+              <a:tr h="342900">
+                <a:tc>
+                  <a:txBody>
+                    <a:bodyPr/>
+                    <a:lstStyle/>
+                    <a:p>
+                      <a:pPr algn="l">
+                        <a:defRPr sz="1100"/>
+                      </a:pPr>
                       <a:r>
                         <a:t>AUTH</a:t>
                       </a:r>
                     </a:p>
                   </a:txBody>
-                  <a:tcPr anchor="ctr"/>
-                </a:tc>
-                <a:tc>
-                  <a:txBody>
-                    <a:bodyPr/>
-                    <a:lstStyle/>
-                    <a:p>
+                  <a:tcPr/>
+                </a:tc>
+                <a:tc>
+                  <a:txBody>
+                    <a:bodyPr/>
+                    <a:lstStyle/>
+                    <a:p>
+                      <a:pPr algn="ctr">
+                        <a:defRPr sz="1100"/>
+                      </a:pPr>
                       <a:r>
                         <a:t>5</a:t>
                       </a:r>
                     </a:p>
                   </a:txBody>
-                  <a:tcPr anchor="ctr"/>
-                </a:tc>
-                <a:tc>
-                  <a:txBody>
-                    <a:bodyPr/>
-                    <a:lstStyle/>
-                    <a:p>
+                  <a:tcPr/>
+                </a:tc>
+                <a:tc>
+                  <a:txBody>
+                    <a:bodyPr/>
+                    <a:lstStyle/>
+                    <a:p>
+                      <a:pPr algn="ctr">
+                        <a:defRPr sz="1100"/>
+                      </a:pPr>
                       <a:r>
                         <a:t>12</a:t>
                       </a:r>
                     </a:p>
                   </a:txBody>
-                  <a:tcPr anchor="ctr"/>
-                </a:tc>
-                <a:tc>
-                  <a:txBody>
-                    <a:bodyPr/>
-                    <a:lstStyle/>
-                    <a:p>
+                  <a:tcPr/>
+                </a:tc>
+                <a:tc>
+                  <a:txBody>
+                    <a:bodyPr/>
+                    <a:lstStyle/>
+                    <a:p>
+                      <a:pPr algn="ctr">
+                        <a:defRPr sz="1100"/>
+                      </a:pPr>
                       <a:r>
                         <a:t>10</a:t>
                       </a:r>
                     </a:p>
                   </a:txBody>
-                  <a:tcPr anchor="ctr"/>
+                  <a:tcPr/>
+                </a:tc>
+                <a:tc>
+                  <a:txBody>
+                    <a:bodyPr/>
+                    <a:lstStyle/>
+                    <a:p>
+                      <a:pPr algn="ctr">
+                        <a:defRPr sz="1100"/>
+                      </a:pPr>
+                      <a:r>
+                        <a:t>10</a:t>
+                      </a:r>
+                    </a:p>
+                  </a:txBody>
+                  <a:tcPr/>
+                </a:tc>
+                <a:tc>
+                  <a:txBody>
+                    <a:bodyPr/>
+                    <a:lstStyle/>
+                    <a:p>
+                      <a:pPr algn="ctr">
+                        <a:defRPr sz="1100"/>
+                      </a:pPr>
+                      <a:r>
+                        <a:t>0</a:t>
+                      </a:r>
+                    </a:p>
+                  </a:txBody>
+                  <a:tcPr/>
+                </a:tc>
+                <a:tc>
+                  <a:txBody>
+                    <a:bodyPr/>
+                    <a:lstStyle/>
+                    <a:p>
+                      <a:pPr algn="ctr">
+                        <a:defRPr sz="1100"/>
+                      </a:pPr>
+                      <a:r>
+                        <a:t>2</a:t>
+                      </a:r>
+                    </a:p>
+                  </a:txBody>
+                  <a:tcPr/>
                 </a:tc>
               </a:tr>
-              <a:tr h="411428">
-                <a:tc>
-                  <a:txBody>
-                    <a:bodyPr/>
-                    <a:lstStyle/>
-                    <a:p>
+              <a:tr h="342900">
+                <a:tc>
+                  <a:txBody>
+                    <a:bodyPr/>
+                    <a:lstStyle/>
+                    <a:p>
+                      <a:pPr algn="l">
+                        <a:defRPr sz="1100"/>
+                      </a:pPr>
                       <a:r>
                         <a:t>KYC</a:t>
                       </a:r>
                     </a:p>
                   </a:txBody>
-                  <a:tcPr anchor="ctr"/>
-                </a:tc>
-                <a:tc>
-                  <a:txBody>
-                    <a:bodyPr/>
-                    <a:lstStyle/>
-                    <a:p>
+                  <a:tcPr/>
+                </a:tc>
+                <a:tc>
+                  <a:txBody>
+                    <a:bodyPr/>
+                    <a:lstStyle/>
+                    <a:p>
+                      <a:pPr algn="ctr">
+                        <a:defRPr sz="1100"/>
+                      </a:pPr>
                       <a:r>
                         <a:t>4</a:t>
                       </a:r>
                     </a:p>
                   </a:txBody>
-                  <a:tcPr anchor="ctr"/>
-                </a:tc>
-                <a:tc>
-                  <a:txBody>
-                    <a:bodyPr/>
-                    <a:lstStyle/>
-                    <a:p>
+                  <a:tcPr/>
+                </a:tc>
+                <a:tc>
+                  <a:txBody>
+                    <a:bodyPr/>
+                    <a:lstStyle/>
+                    <a:p>
+                      <a:pPr algn="ctr">
+                        <a:defRPr sz="1100"/>
+                      </a:pPr>
                       <a:r>
                         <a:t>11</a:t>
                       </a:r>
                     </a:p>
                   </a:txBody>
-                  <a:tcPr anchor="ctr"/>
-                </a:tc>
-                <a:tc>
-                  <a:txBody>
-                    <a:bodyPr/>
-                    <a:lstStyle/>
-                    <a:p>
+                  <a:tcPr/>
+                </a:tc>
+                <a:tc>
+                  <a:txBody>
+                    <a:bodyPr/>
+                    <a:lstStyle/>
+                    <a:p>
+                      <a:pPr algn="ctr">
+                        <a:defRPr sz="1100"/>
+                      </a:pPr>
                       <a:r>
                         <a:t>10</a:t>
                       </a:r>
                     </a:p>
                   </a:txBody>
-                  <a:tcPr anchor="ctr"/>
+                  <a:tcPr/>
+                </a:tc>
+                <a:tc>
+                  <a:txBody>
+                    <a:bodyPr/>
+                    <a:lstStyle/>
+                    <a:p>
+                      <a:pPr algn="ctr">
+                        <a:defRPr sz="1100"/>
+                      </a:pPr>
+                      <a:r>
+                        <a:t>10</a:t>
+                      </a:r>
+                    </a:p>
+                  </a:txBody>
+                  <a:tcPr/>
+                </a:tc>
+                <a:tc>
+                  <a:txBody>
+                    <a:bodyPr/>
+                    <a:lstStyle/>
+                    <a:p>
+                      <a:pPr algn="ctr">
+                        <a:defRPr sz="1100"/>
+                      </a:pPr>
+                      <a:r>
+                        <a:t>0</a:t>
+                      </a:r>
+                    </a:p>
+                  </a:txBody>
+                  <a:tcPr/>
+                </a:tc>
+                <a:tc>
+                  <a:txBody>
+                    <a:bodyPr/>
+                    <a:lstStyle/>
+                    <a:p>
+                      <a:pPr algn="ctr">
+                        <a:defRPr sz="1100"/>
+                      </a:pPr>
+                      <a:r>
+                        <a:t>1</a:t>
+                      </a:r>
+                    </a:p>
+                  </a:txBody>
+                  <a:tcPr/>
                 </a:tc>
               </a:tr>
-              <a:tr h="411428">
-                <a:tc>
-                  <a:txBody>
-                    <a:bodyPr/>
-                    <a:lstStyle/>
-                    <a:p>
+              <a:tr h="342900">
+                <a:tc>
+                  <a:txBody>
+                    <a:bodyPr/>
+                    <a:lstStyle/>
+                    <a:p>
+                      <a:pPr algn="l">
+                        <a:defRPr sz="1100"/>
+                      </a:pPr>
                       <a:r>
                         <a:t>CAMP</a:t>
                       </a:r>
                     </a:p>
                   </a:txBody>
-                  <a:tcPr anchor="ctr"/>
-                </a:tc>
-                <a:tc>
-                  <a:txBody>
-                    <a:bodyPr/>
-                    <a:lstStyle/>
-                    <a:p>
+                  <a:tcPr/>
+                </a:tc>
+                <a:tc>
+                  <a:txBody>
+                    <a:bodyPr/>
+                    <a:lstStyle/>
+                    <a:p>
+                      <a:pPr algn="ctr">
+                        <a:defRPr sz="1100"/>
+                      </a:pPr>
+                      <a:r>
+                        <a:t>6</a:t>
+                      </a:r>
+                    </a:p>
+                  </a:txBody>
+                  <a:tcPr/>
+                </a:tc>
+                <a:tc>
+                  <a:txBody>
+                    <a:bodyPr/>
+                    <a:lstStyle/>
+                    <a:p>
+                      <a:pPr algn="ctr">
+                        <a:defRPr sz="1100"/>
+                      </a:pPr>
+                      <a:r>
+                        <a:t>15</a:t>
+                      </a:r>
+                    </a:p>
+                  </a:txBody>
+                  <a:tcPr/>
+                </a:tc>
+                <a:tc>
+                  <a:txBody>
+                    <a:bodyPr/>
+                    <a:lstStyle/>
+                    <a:p>
+                      <a:pPr algn="ctr">
+                        <a:defRPr sz="1100"/>
+                      </a:pPr>
+                      <a:r>
+                        <a:t>14</a:t>
+                      </a:r>
+                    </a:p>
+                  </a:txBody>
+                  <a:tcPr/>
+                </a:tc>
+                <a:tc>
+                  <a:txBody>
+                    <a:bodyPr/>
+                    <a:lstStyle/>
+                    <a:p>
+                      <a:pPr algn="ctr">
+                        <a:defRPr sz="1100"/>
+                      </a:pPr>
+                      <a:r>
+                        <a:t>14</a:t>
+                      </a:r>
+                    </a:p>
+                  </a:txBody>
+                  <a:tcPr/>
+                </a:tc>
+                <a:tc>
+                  <a:txBody>
+                    <a:bodyPr/>
+                    <a:lstStyle/>
+                    <a:p>
+                      <a:pPr algn="ctr">
+                        <a:defRPr sz="1100"/>
+                      </a:pPr>
+                      <a:r>
+                        <a:t>0</a:t>
+                      </a:r>
+                    </a:p>
+                  </a:txBody>
+                  <a:tcPr/>
+                </a:tc>
+                <a:tc>
+                  <a:txBody>
+                    <a:bodyPr/>
+                    <a:lstStyle/>
+                    <a:p>
+                      <a:pPr algn="ctr">
+                        <a:defRPr sz="1100"/>
+                      </a:pPr>
+                      <a:r>
+                        <a:t>1</a:t>
+                      </a:r>
+                    </a:p>
+                  </a:txBody>
+                  <a:tcPr/>
+                </a:tc>
+              </a:tr>
+              <a:tr h="342900">
+                <a:tc>
+                  <a:txBody>
+                    <a:bodyPr/>
+                    <a:lstStyle/>
+                    <a:p>
+                      <a:pPr algn="l">
+                        <a:defRPr sz="1100"/>
+                      </a:pPr>
+                      <a:r>
+                        <a:t>REWARD</a:t>
+                      </a:r>
+                    </a:p>
+                  </a:txBody>
+                  <a:tcPr/>
+                </a:tc>
+                <a:tc>
+                  <a:txBody>
+                    <a:bodyPr/>
+                    <a:lstStyle/>
+                    <a:p>
+                      <a:pPr algn="ctr">
+                        <a:defRPr sz="1100"/>
+                      </a:pPr>
+                      <a:r>
+                        <a:t>3</a:t>
+                      </a:r>
+                    </a:p>
+                  </a:txBody>
+                  <a:tcPr/>
+                </a:tc>
+                <a:tc>
+                  <a:txBody>
+                    <a:bodyPr/>
+                    <a:lstStyle/>
+                    <a:p>
+                      <a:pPr algn="ctr">
+                        <a:defRPr sz="1100"/>
+                      </a:pPr>
+                      <a:r>
+                        <a:t>9</a:t>
+                      </a:r>
+                    </a:p>
+                  </a:txBody>
+                  <a:tcPr/>
+                </a:tc>
+                <a:tc>
+                  <a:txBody>
+                    <a:bodyPr/>
+                    <a:lstStyle/>
+                    <a:p>
+                      <a:pPr algn="ctr">
+                        <a:defRPr sz="1100"/>
+                      </a:pPr>
+                      <a:r>
+                        <a:t>8</a:t>
+                      </a:r>
+                    </a:p>
+                  </a:txBody>
+                  <a:tcPr/>
+                </a:tc>
+                <a:tc>
+                  <a:txBody>
+                    <a:bodyPr/>
+                    <a:lstStyle/>
+                    <a:p>
+                      <a:pPr algn="ctr">
+                        <a:defRPr sz="1100"/>
+                      </a:pPr>
+                      <a:r>
+                        <a:t>8</a:t>
+                      </a:r>
+                    </a:p>
+                  </a:txBody>
+                  <a:tcPr/>
+                </a:tc>
+                <a:tc>
+                  <a:txBody>
+                    <a:bodyPr/>
+                    <a:lstStyle/>
+                    <a:p>
+                      <a:pPr algn="ctr">
+                        <a:defRPr sz="1100"/>
+                      </a:pPr>
+                      <a:r>
+                        <a:t>0</a:t>
+                      </a:r>
+                    </a:p>
+                  </a:txBody>
+                  <a:tcPr/>
+                </a:tc>
+                <a:tc>
+                  <a:txBody>
+                    <a:bodyPr/>
+                    <a:lstStyle/>
+                    <a:p>
+                      <a:pPr algn="ctr">
+                        <a:defRPr sz="1100"/>
+                      </a:pPr>
+                      <a:r>
+                        <a:t>1</a:t>
+                      </a:r>
+                    </a:p>
+                  </a:txBody>
+                  <a:tcPr/>
+                </a:tc>
+              </a:tr>
+              <a:tr h="342900">
+                <a:tc>
+                  <a:txBody>
+                    <a:bodyPr/>
+                    <a:lstStyle/>
+                    <a:p>
+                      <a:pPr algn="l">
+                        <a:defRPr sz="1100"/>
+                      </a:pPr>
+                      <a:r>
+                        <a:t>PLEDGE</a:t>
+                      </a:r>
+                    </a:p>
+                  </a:txBody>
+                  <a:tcPr/>
+                </a:tc>
+                <a:tc>
+                  <a:txBody>
+                    <a:bodyPr/>
+                    <a:lstStyle/>
+                    <a:p>
+                      <a:pPr algn="ctr">
+                        <a:defRPr sz="1100"/>
+                      </a:pPr>
+                      <a:r>
+                        <a:t>4</a:t>
+                      </a:r>
+                    </a:p>
+                  </a:txBody>
+                  <a:tcPr/>
+                </a:tc>
+                <a:tc>
+                  <a:txBody>
+                    <a:bodyPr/>
+                    <a:lstStyle/>
+                    <a:p>
+                      <a:pPr algn="ctr">
+                        <a:defRPr sz="1100"/>
+                      </a:pPr>
+                      <a:r>
+                        <a:t>10</a:t>
+                      </a:r>
+                    </a:p>
+                  </a:txBody>
+                  <a:tcPr/>
+                </a:tc>
+                <a:tc>
+                  <a:txBody>
+                    <a:bodyPr/>
+                    <a:lstStyle/>
+                    <a:p>
+                      <a:pPr algn="ctr">
+                        <a:defRPr sz="1100"/>
+                      </a:pPr>
+                      <a:r>
+                        <a:t>8</a:t>
+                      </a:r>
+                    </a:p>
+                  </a:txBody>
+                  <a:tcPr/>
+                </a:tc>
+                <a:tc>
+                  <a:txBody>
+                    <a:bodyPr/>
+                    <a:lstStyle/>
+                    <a:p>
+                      <a:pPr algn="ctr">
+                        <a:defRPr sz="1100"/>
+                      </a:pPr>
+                      <a:r>
+                        <a:t>6</a:t>
+                      </a:r>
+                    </a:p>
+                  </a:txBody>
+                  <a:tcPr/>
+                </a:tc>
+                <a:tc>
+                  <a:txBody>
+                    <a:bodyPr/>
+                    <a:lstStyle/>
+                    <a:p>
+                      <a:pPr algn="ctr">
+                        <a:defRPr sz="1100"/>
+                      </a:pPr>
+                      <a:r>
+                        <a:t>2</a:t>
+                      </a:r>
+                    </a:p>
+                  </a:txBody>
+                  <a:tcPr/>
+                </a:tc>
+                <a:tc>
+                  <a:txBody>
+                    <a:bodyPr/>
+                    <a:lstStyle/>
+                    <a:p>
+                      <a:pPr algn="ctr">
+                        <a:defRPr sz="1100"/>
+                      </a:pPr>
+                      <a:r>
+                        <a:t>2</a:t>
+                      </a:r>
+                    </a:p>
+                  </a:txBody>
+                  <a:tcPr/>
+                </a:tc>
+              </a:tr>
+              <a:tr h="342900">
+                <a:tc>
+                  <a:txBody>
+                    <a:bodyPr/>
+                    <a:lstStyle/>
+                    <a:p>
+                      <a:pPr algn="l">
+                        <a:defRPr sz="1100"/>
+                      </a:pPr>
+                      <a:r>
+                        <a:t>CERT</a:t>
+                      </a:r>
+                    </a:p>
+                  </a:txBody>
+                  <a:tcPr/>
+                </a:tc>
+                <a:tc>
+                  <a:txBody>
+                    <a:bodyPr/>
+                    <a:lstStyle/>
+                    <a:p>
+                      <a:pPr algn="ctr">
+                        <a:defRPr sz="1100"/>
+                      </a:pPr>
+                      <a:r>
+                        <a:t>4</a:t>
+                      </a:r>
+                    </a:p>
+                  </a:txBody>
+                  <a:tcPr/>
+                </a:tc>
+                <a:tc>
+                  <a:txBody>
+                    <a:bodyPr/>
+                    <a:lstStyle/>
+                    <a:p>
+                      <a:pPr algn="ctr">
+                        <a:defRPr sz="1100"/>
+                      </a:pPr>
+                      <a:r>
+                        <a:t>10</a:t>
+                      </a:r>
+                    </a:p>
+                  </a:txBody>
+                  <a:tcPr/>
+                </a:tc>
+                <a:tc>
+                  <a:txBody>
+                    <a:bodyPr/>
+                    <a:lstStyle/>
+                    <a:p>
+                      <a:pPr algn="ctr">
+                        <a:defRPr sz="1100"/>
+                      </a:pPr>
+                      <a:r>
+                        <a:t>9</a:t>
+                      </a:r>
+                    </a:p>
+                  </a:txBody>
+                  <a:tcPr/>
+                </a:tc>
+                <a:tc>
+                  <a:txBody>
+                    <a:bodyPr/>
+                    <a:lstStyle/>
+                    <a:p>
+                      <a:pPr algn="ctr">
+                        <a:defRPr sz="1100"/>
+                      </a:pPr>
+                      <a:r>
+                        <a:t>9</a:t>
+                      </a:r>
+                    </a:p>
+                  </a:txBody>
+                  <a:tcPr/>
+                </a:tc>
+                <a:tc>
+                  <a:txBody>
+                    <a:bodyPr/>
+                    <a:lstStyle/>
+                    <a:p>
+                      <a:pPr algn="ctr">
+                        <a:defRPr sz="1100"/>
+                      </a:pPr>
+                      <a:r>
+                        <a:t>0</a:t>
+                      </a:r>
+                    </a:p>
+                  </a:txBody>
+                  <a:tcPr/>
+                </a:tc>
+                <a:tc>
+                  <a:txBody>
+                    <a:bodyPr/>
+                    <a:lstStyle/>
+                    <a:p>
+                      <a:pPr algn="ctr">
+                        <a:defRPr sz="1100"/>
+                      </a:pPr>
+                      <a:r>
+                        <a:t>1</a:t>
+                      </a:r>
+                    </a:p>
+                  </a:txBody>
+                  <a:tcPr/>
+                </a:tc>
+              </a:tr>
+              <a:tr h="342900">
+                <a:tc>
+                  <a:txBody>
+                    <a:bodyPr/>
+                    <a:lstStyle/>
+                    <a:p>
+                      <a:pPr algn="l">
+                        <a:defRPr sz="1100"/>
+                      </a:pPr>
+                      <a:r>
+                        <a:t>COMM</a:t>
+                      </a:r>
+                    </a:p>
+                  </a:txBody>
+                  <a:tcPr/>
+                </a:tc>
+                <a:tc>
+                  <a:txBody>
+                    <a:bodyPr/>
+                    <a:lstStyle/>
+                    <a:p>
+                      <a:pPr algn="ctr">
+                        <a:defRPr sz="1100"/>
+                      </a:pPr>
+                      <a:r>
+                        <a:t>4</a:t>
+                      </a:r>
+                    </a:p>
+                  </a:txBody>
+                  <a:tcPr/>
+                </a:tc>
+                <a:tc>
+                  <a:txBody>
+                    <a:bodyPr/>
+                    <a:lstStyle/>
+                    <a:p>
+                      <a:pPr algn="ctr">
+                        <a:defRPr sz="1100"/>
+                      </a:pPr>
+                      <a:r>
+                        <a:t>11</a:t>
+                      </a:r>
+                    </a:p>
+                  </a:txBody>
+                  <a:tcPr/>
+                </a:tc>
+                <a:tc>
+                  <a:txBody>
+                    <a:bodyPr/>
+                    <a:lstStyle/>
+                    <a:p>
+                      <a:pPr algn="ctr">
+                        <a:defRPr sz="1100"/>
+                      </a:pPr>
+                      <a:r>
+                        <a:t>10</a:t>
+                      </a:r>
+                    </a:p>
+                  </a:txBody>
+                  <a:tcPr/>
+                </a:tc>
+                <a:tc>
+                  <a:txBody>
+                    <a:bodyPr/>
+                    <a:lstStyle/>
+                    <a:p>
+                      <a:pPr algn="ctr">
+                        <a:defRPr sz="1100"/>
+                      </a:pPr>
+                      <a:r>
+                        <a:t>9</a:t>
+                      </a:r>
+                    </a:p>
+                  </a:txBody>
+                  <a:tcPr/>
+                </a:tc>
+                <a:tc>
+                  <a:txBody>
+                    <a:bodyPr/>
+                    <a:lstStyle/>
+                    <a:p>
+                      <a:pPr algn="ctr">
+                        <a:defRPr sz="1100"/>
+                      </a:pPr>
+                      <a:r>
+                        <a:t>1</a:t>
+                      </a:r>
+                    </a:p>
+                  </a:txBody>
+                  <a:tcPr/>
+                </a:tc>
+                <a:tc>
+                  <a:txBody>
+                    <a:bodyPr/>
+                    <a:lstStyle/>
+                    <a:p>
+                      <a:pPr algn="ctr">
+                        <a:defRPr sz="1100"/>
+                      </a:pPr>
+                      <a:r>
+                        <a:t>1</a:t>
+                      </a:r>
+                    </a:p>
+                  </a:txBody>
+                  <a:tcPr/>
+                </a:tc>
+              </a:tr>
+              <a:tr h="342900">
+                <a:tc>
+                  <a:txBody>
+                    <a:bodyPr/>
+                    <a:lstStyle/>
+                    <a:p>
+                      <a:pPr algn="l">
+                        <a:defRPr sz="1100"/>
+                      </a:pPr>
+                      <a:r>
+                        <a:t>BLOG</a:t>
+                      </a:r>
+                    </a:p>
+                  </a:txBody>
+                  <a:tcPr/>
+                </a:tc>
+                <a:tc>
+                  <a:txBody>
+                    <a:bodyPr/>
+                    <a:lstStyle/>
+                    <a:p>
+                      <a:pPr algn="ctr">
+                        <a:defRPr sz="1100"/>
+                      </a:pPr>
+                      <a:r>
+                        <a:t>4</a:t>
+                      </a:r>
+                    </a:p>
+                  </a:txBody>
+                  <a:tcPr/>
+                </a:tc>
+                <a:tc>
+                  <a:txBody>
+                    <a:bodyPr/>
+                    <a:lstStyle/>
+                    <a:p>
+                      <a:pPr algn="ctr">
+                        <a:defRPr sz="1100"/>
+                      </a:pPr>
+                      <a:r>
+                        <a:t>12</a:t>
+                      </a:r>
+                    </a:p>
+                  </a:txBody>
+                  <a:tcPr/>
+                </a:tc>
+                <a:tc>
+                  <a:txBody>
+                    <a:bodyPr/>
+                    <a:lstStyle/>
+                    <a:p>
+                      <a:pPr algn="ctr">
+                        <a:defRPr sz="1100"/>
+                      </a:pPr>
+                      <a:r>
+                        <a:t>11</a:t>
+                      </a:r>
+                    </a:p>
+                  </a:txBody>
+                  <a:tcPr/>
+                </a:tc>
+                <a:tc>
+                  <a:txBody>
+                    <a:bodyPr/>
+                    <a:lstStyle/>
+                    <a:p>
+                      <a:pPr algn="ctr">
+                        <a:defRPr sz="1100"/>
+                      </a:pPr>
+                      <a:r>
+                        <a:t>11</a:t>
+                      </a:r>
+                    </a:p>
+                  </a:txBody>
+                  <a:tcPr/>
+                </a:tc>
+                <a:tc>
+                  <a:txBody>
+                    <a:bodyPr/>
+                    <a:lstStyle/>
+                    <a:p>
+                      <a:pPr algn="ctr">
+                        <a:defRPr sz="1100"/>
+                      </a:pPr>
+                      <a:r>
+                        <a:t>0</a:t>
+                      </a:r>
+                    </a:p>
+                  </a:txBody>
+                  <a:tcPr/>
+                </a:tc>
+                <a:tc>
+                  <a:txBody>
+                    <a:bodyPr/>
+                    <a:lstStyle/>
+                    <a:p>
+                      <a:pPr algn="ctr">
+                        <a:defRPr sz="1100"/>
+                      </a:pPr>
+                      <a:r>
+                        <a:t>1</a:t>
+                      </a:r>
+                    </a:p>
+                  </a:txBody>
+                  <a:tcPr/>
+                </a:tc>
+              </a:tr>
+              <a:tr h="342900">
+                <a:tc>
+                  <a:txBody>
+                    <a:bodyPr/>
+                    <a:lstStyle/>
+                    <a:p>
+                      <a:pPr algn="l">
+                        <a:defRPr sz="1100"/>
+                      </a:pPr>
+                      <a:r>
+                        <a:t>CHAT</a:t>
+                      </a:r>
+                    </a:p>
+                  </a:txBody>
+                  <a:tcPr/>
+                </a:tc>
+                <a:tc>
+                  <a:txBody>
+                    <a:bodyPr/>
+                    <a:lstStyle/>
+                    <a:p>
+                      <a:pPr algn="ctr">
+                        <a:defRPr sz="1100"/>
+                      </a:pPr>
+                      <a:r>
+                        <a:t>3</a:t>
+                      </a:r>
+                    </a:p>
+                  </a:txBody>
+                  <a:tcPr/>
+                </a:tc>
+                <a:tc>
+                  <a:txBody>
+                    <a:bodyPr/>
+                    <a:lstStyle/>
+                    <a:p>
+                      <a:pPr algn="ctr">
+                        <a:defRPr sz="1100"/>
+                      </a:pPr>
+                      <a:r>
+                        <a:t>6</a:t>
+                      </a:r>
+                    </a:p>
+                  </a:txBody>
+                  <a:tcPr/>
+                </a:tc>
+                <a:tc>
+                  <a:txBody>
+                    <a:bodyPr/>
+                    <a:lstStyle/>
+                    <a:p>
+                      <a:pPr algn="ctr">
+                        <a:defRPr sz="1100"/>
+                      </a:pPr>
                       <a:r>
                         <a:t>5</a:t>
                       </a:r>
                     </a:p>
                   </a:txBody>
-                  <a:tcPr anchor="ctr"/>
-                </a:tc>
-                <a:tc>
-                  <a:txBody>
-                    <a:bodyPr/>
-                    <a:lstStyle/>
-                    <a:p>
-                      <a:r>
-                        <a:t>15</a:t>
-                      </a:r>
-                    </a:p>
-                  </a:txBody>
-                  <a:tcPr anchor="ctr"/>
-                </a:tc>
-                <a:tc>
-                  <a:txBody>
-                    <a:bodyPr/>
-                    <a:lstStyle/>
-                    <a:p>
-                      <a:r>
-                        <a:t>14</a:t>
-                      </a:r>
-                    </a:p>
-                  </a:txBody>
-                  <a:tcPr anchor="ctr"/>
+                  <a:tcPr/>
+                </a:tc>
+                <a:tc>
+                  <a:txBody>
+                    <a:bodyPr/>
+                    <a:lstStyle/>
+                    <a:p>
+                      <a:pPr algn="ctr">
+                        <a:defRPr sz="1100"/>
+                      </a:pPr>
+                      <a:r>
+                        <a:t>4</a:t>
+                      </a:r>
+                    </a:p>
+                  </a:txBody>
+                  <a:tcPr/>
+                </a:tc>
+                <a:tc>
+                  <a:txBody>
+                    <a:bodyPr/>
+                    <a:lstStyle/>
+                    <a:p>
+                      <a:pPr algn="ctr">
+                        <a:defRPr sz="1100"/>
+                      </a:pPr>
+                      <a:r>
+                        <a:t>1</a:t>
+                      </a:r>
+                    </a:p>
+                  </a:txBody>
+                  <a:tcPr/>
+                </a:tc>
+                <a:tc>
+                  <a:txBody>
+                    <a:bodyPr/>
+                    <a:lstStyle/>
+                    <a:p>
+                      <a:pPr algn="ctr">
+                        <a:defRPr sz="1100"/>
+                      </a:pPr>
+                      <a:r>
+                        <a:t>1</a:t>
+                      </a:r>
+                    </a:p>
+                  </a:txBody>
+                  <a:tcPr/>
                 </a:tc>
               </a:tr>
-              <a:tr h="411428">
-                <a:tc>
-                  <a:txBody>
-                    <a:bodyPr/>
-                    <a:lstStyle/>
-                    <a:p>
-                      <a:r>
-                        <a:t>REWARD</a:t>
-                      </a:r>
-                    </a:p>
-                  </a:txBody>
-                  <a:tcPr anchor="ctr"/>
-                </a:tc>
-                <a:tc>
-                  <a:txBody>
-                    <a:bodyPr/>
-                    <a:lstStyle/>
-                    <a:p>
+              <a:tr h="342900">
+                <a:tc>
+                  <a:txBody>
+                    <a:bodyPr/>
+                    <a:lstStyle/>
+                    <a:p>
+                      <a:pPr algn="l">
+                        <a:defRPr sz="1100"/>
+                      </a:pPr>
+                      <a:r>
+                        <a:t>ADMIN</a:t>
+                      </a:r>
+                    </a:p>
+                  </a:txBody>
+                  <a:tcPr/>
+                </a:tc>
+                <a:tc>
+                  <a:txBody>
+                    <a:bodyPr/>
+                    <a:lstStyle/>
+                    <a:p>
+                      <a:pPr algn="ctr">
+                        <a:defRPr sz="1100"/>
+                      </a:pPr>
+                      <a:r>
+                        <a:t>5</a:t>
+                      </a:r>
+                    </a:p>
+                  </a:txBody>
+                  <a:tcPr/>
+                </a:tc>
+                <a:tc>
+                  <a:txBody>
+                    <a:bodyPr/>
+                    <a:lstStyle/>
+                    <a:p>
+                      <a:pPr algn="ctr">
+                        <a:defRPr sz="1100"/>
+                      </a:pPr>
+                      <a:r>
+                        <a:t>9</a:t>
+                      </a:r>
+                    </a:p>
+                  </a:txBody>
+                  <a:tcPr/>
+                </a:tc>
+                <a:tc>
+                  <a:txBody>
+                    <a:bodyPr/>
+                    <a:lstStyle/>
+                    <a:p>
+                      <a:pPr algn="ctr">
+                        <a:defRPr sz="1100"/>
+                      </a:pPr>
+                      <a:r>
+                        <a:t>8</a:t>
+                      </a:r>
+                    </a:p>
+                  </a:txBody>
+                  <a:tcPr/>
+                </a:tc>
+                <a:tc>
+                  <a:txBody>
+                    <a:bodyPr/>
+                    <a:lstStyle/>
+                    <a:p>
+                      <a:pPr algn="ctr">
+                        <a:defRPr sz="1100"/>
+                      </a:pPr>
+                      <a:r>
+                        <a:t>8</a:t>
+                      </a:r>
+                    </a:p>
+                  </a:txBody>
+                  <a:tcPr/>
+                </a:tc>
+                <a:tc>
+                  <a:txBody>
+                    <a:bodyPr/>
+                    <a:lstStyle/>
+                    <a:p>
+                      <a:pPr algn="ctr">
+                        <a:defRPr sz="1100"/>
+                      </a:pPr>
+                      <a:r>
+                        <a:t>0</a:t>
+                      </a:r>
+                    </a:p>
+                  </a:txBody>
+                  <a:tcPr/>
+                </a:tc>
+                <a:tc>
+                  <a:txBody>
+                    <a:bodyPr/>
+                    <a:lstStyle/>
+                    <a:p>
+                      <a:pPr algn="ctr">
+                        <a:defRPr sz="1100"/>
+                      </a:pPr>
+                      <a:r>
+                        <a:t>1</a:t>
+                      </a:r>
+                    </a:p>
+                  </a:txBody>
+                  <a:tcPr/>
+                </a:tc>
+              </a:tr>
+              <a:tr h="342900">
+                <a:tc>
+                  <a:txBody>
+                    <a:bodyPr/>
+                    <a:lstStyle/>
+                    <a:p>
+                      <a:pPr algn="l">
+                        <a:defRPr sz="1100" b="1"/>
+                      </a:pPr>
+                      <a:r>
+                        <a:t>TỔNG</a:t>
+                      </a:r>
+                    </a:p>
+                  </a:txBody>
+                  <a:tcPr/>
+                </a:tc>
+                <a:tc>
+                  <a:txBody>
+                    <a:bodyPr/>
+                    <a:lstStyle/>
+                    <a:p>
+                      <a:pPr algn="ctr">
+                        <a:defRPr sz="1100" b="1"/>
+                      </a:pPr>
+                      <a:r>
+                        <a:t>42</a:t>
+                      </a:r>
+                    </a:p>
+                  </a:txBody>
+                  <a:tcPr/>
+                </a:tc>
+                <a:tc>
+                  <a:txBody>
+                    <a:bodyPr/>
+                    <a:lstStyle/>
+                    <a:p>
+                      <a:pPr algn="ctr">
+                        <a:defRPr sz="1100" b="1"/>
+                      </a:pPr>
+                      <a:r>
+                        <a:t>105</a:t>
+                      </a:r>
+                    </a:p>
+                  </a:txBody>
+                  <a:tcPr/>
+                </a:tc>
+                <a:tc>
+                  <a:txBody>
+                    <a:bodyPr/>
+                    <a:lstStyle/>
+                    <a:p>
+                      <a:pPr algn="ctr">
+                        <a:defRPr sz="1100" b="1"/>
+                      </a:pPr>
+                      <a:r>
+                        <a:t>93</a:t>
+                      </a:r>
+                    </a:p>
+                  </a:txBody>
+                  <a:tcPr/>
+                </a:tc>
+                <a:tc>
+                  <a:txBody>
+                    <a:bodyPr/>
+                    <a:lstStyle/>
+                    <a:p>
+                      <a:pPr algn="ctr">
+                        <a:defRPr sz="1100" b="1"/>
+                      </a:pPr>
+                      <a:r>
+                        <a:t>89</a:t>
+                      </a:r>
+                    </a:p>
+                  </a:txBody>
+                  <a:tcPr/>
+                </a:tc>
+                <a:tc>
+                  <a:txBody>
+                    <a:bodyPr/>
+                    <a:lstStyle/>
+                    <a:p>
+                      <a:pPr algn="ctr">
+                        <a:defRPr sz="1100" b="1"/>
+                      </a:pPr>
                       <a:r>
                         <a:t>4</a:t>
                       </a:r>
                     </a:p>
                   </a:txBody>
-                  <a:tcPr anchor="ctr"/>
-                </a:tc>
-                <a:tc>
-                  <a:txBody>
-                    <a:bodyPr/>
-                    <a:lstStyle/>
-                    <a:p>
-                      <a:r>
-                        <a:t>9</a:t>
-                      </a:r>
-                    </a:p>
-                  </a:txBody>
-                  <a:tcPr anchor="ctr"/>
-                </a:tc>
-                <a:tc>
-                  <a:txBody>
-                    <a:bodyPr/>
-                    <a:lstStyle/>
-                    <a:p>
-                      <a:r>
-                        <a:t>8</a:t>
-                      </a:r>
-                    </a:p>
-                  </a:txBody>
-                  <a:tcPr anchor="ctr"/>
-                </a:tc>
-              </a:tr>
-              <a:tr h="411428">
-                <a:tc>
-                  <a:txBody>
-                    <a:bodyPr/>
-                    <a:lstStyle/>
-                    <a:p>
-                      <a:r>
-                        <a:t>PLEDGE</a:t>
-                      </a:r>
-                    </a:p>
-                  </a:txBody>
-                  <a:tcPr anchor="ctr"/>
-                </a:tc>
-                <a:tc>
-                  <a:txBody>
-                    <a:bodyPr/>
-                    <a:lstStyle/>
-                    <a:p>
-                      <a:r>
-                        <a:t>5</a:t>
-                      </a:r>
-                    </a:p>
-                  </a:txBody>
-                  <a:tcPr anchor="ctr"/>
-                </a:tc>
-                <a:tc>
-                  <a:txBody>
-                    <a:bodyPr/>
-                    <a:lstStyle/>
-                    <a:p>
-                      <a:r>
-                        <a:t>10</a:t>
-                      </a:r>
-                    </a:p>
-                  </a:txBody>
-                  <a:tcPr anchor="ctr"/>
-                </a:tc>
-                <a:tc>
-                  <a:txBody>
-                    <a:bodyPr/>
-                    <a:lstStyle/>
-                    <a:p>
-                      <a:r>
-                        <a:t>8</a:t>
-                      </a:r>
-                    </a:p>
-                  </a:txBody>
-                  <a:tcPr anchor="ctr"/>
-                </a:tc>
-              </a:tr>
-              <a:tr h="411432">
-                <a:tc>
-                  <a:txBody>
-                    <a:bodyPr/>
-                    <a:lstStyle/>
-                    <a:p>
-                      <a:r>
-                        <a:t>CERT</a:t>
-                      </a:r>
-                    </a:p>
-                  </a:txBody>
-                  <a:tcPr anchor="ctr"/>
-                </a:tc>
-                <a:tc>
-                  <a:txBody>
-                    <a:bodyPr/>
-                    <a:lstStyle/>
-                    <a:p>
-                      <a:r>
-                        <a:t>4</a:t>
-                      </a:r>
-                    </a:p>
-                  </a:txBody>
-                  <a:tcPr anchor="ctr"/>
-                </a:tc>
-                <a:tc>
-                  <a:txBody>
-                    <a:bodyPr/>
-                    <a:lstStyle/>
-                    <a:p>
-                      <a:r>
-                        <a:t>10</a:t>
-                      </a:r>
-                    </a:p>
-                  </a:txBody>
-                  <a:tcPr anchor="ctr"/>
-                </a:tc>
-                <a:tc>
-                  <a:txBody>
-                    <a:bodyPr/>
-                    <a:lstStyle/>
-                    <a:p>
-                      <a:r>
-                        <a:t>9</a:t>
-                      </a:r>
-                    </a:p>
-                  </a:txBody>
-                  <a:tcPr anchor="ctr"/>
+                  <a:tcPr/>
+                </a:tc>
+                <a:tc>
+                  <a:txBody>
+                    <a:bodyPr/>
+                    <a:lstStyle/>
+                    <a:p>
+                      <a:pPr algn="ctr">
+                        <a:defRPr sz="1100" b="1"/>
+                      </a:pPr>
+                      <a:r>
+                        <a:t>12</a:t>
+                      </a:r>
+                    </a:p>
+                  </a:txBody>
+                  <a:tcPr/>
                 </a:tc>
               </a:tr>
             </a:tbl>
@@ -5781,92 +6567,6 @@
           </a:p>
         </p:txBody>
       </p:sp>
-      <p:sp>
-        <p:nvSpPr>
-          <p:cNvPr id="4" name="TextBox 3"/>
-          <p:cNvSpPr txBox="1"/>
-          <p:nvPr/>
-        </p:nvSpPr>
-        <p:spPr>
-          <a:xfrm>
-            <a:off x="540000" y="1224000"/>
-            <a:ext cx="8243999" cy="4320000"/>
-          </a:xfrm>
-          <a:prstGeom prst="rect">
-            <a:avLst/>
-          </a:prstGeom>
-          <a:noFill/>
-        </p:spPr>
-        <p:txBody>
-          <a:bodyPr wrap="square">
-            <a:spAutoFit/>
-          </a:bodyPr>
-          <a:lstStyle/>
-          <a:p>
-            <a:pPr>
-              <a:spcAft>
-                <a:spcPts val="900"/>
-              </a:spcAft>
-              <a:defRPr b="1" sz="1500">
-                <a:solidFill>
-                  <a:srgbClr val="1F4E78"/>
-                </a:solidFill>
-              </a:defRPr>
-            </a:pPr>
-            <a:r>
-              <a:t>Tổng kết Kết quả Thực thi Kiểm thử Thực tế:</a:t>
-            </a:r>
-          </a:p>
-          <a:p>
-            <a:pPr>
-              <a:defRPr sz="1250"/>
-            </a:pPr>
-            <a:r>
-              <a:t>• Tổng số TC đã chạy: 93 / 105 TCs (đạt 88.6% kế hoạch thực thi)</a:t>
-            </a:r>
-          </a:p>
-          <a:p>
-            <a:pPr>
-              <a:defRPr sz="1250"/>
-            </a:pPr>
-            <a:r>
-              <a:t>• Số ca kiểm thử ĐẠT (PASS): 89 TCs (chiếm 95.7% số ca đã chạy)</a:t>
-            </a:r>
-          </a:p>
-          <a:p>
-            <a:pPr>
-              <a:defRPr sz="1250"/>
-            </a:pPr>
-            <a:r>
-              <a:t>• Số ca kiểm thử KHÔNG ĐẠT (FAIL): 4 TCs (chiếm 4.3% số ca đã chạy)</a:t>
-            </a:r>
-          </a:p>
-          <a:p>
-            <a:pPr>
-              <a:defRPr sz="1250"/>
-            </a:pPr>
-            <a:r>
-              <a:t>• Số ca kiểm thử CHƯA CHẠY: 12 TCs (để trống kết quả minh bạch do giới hạn thiết bị/thanh toán thật)</a:t>
-            </a:r>
-          </a:p>
-          <a:p>
-            <a:pPr>
-              <a:defRPr sz="1250"/>
-            </a:pPr>
-            <a:r>
-              <a:t>• Tỷ lệ PASS trên số đã chạy: 95.7% (Đạt và vượt chỉ tiêu chất lượng ≥ 85.0%)</a:t>
-            </a:r>
-          </a:p>
-          <a:p>
-            <a:pPr>
-              <a:defRPr sz="1250"/>
-            </a:pPr>
-            <a:r>
-              <a:t>• Độ bao phủ yêu cầu kiểm thử: 42 / 42 TRs (Đạt 100% độ bao phủ TR)</a:t>
-            </a:r>
-          </a:p>
-        </p:txBody>
-      </p:sp>
     </p:spTree>
   </p:cSld>
   <p:clrMapOvr>
@@ -6011,8 +6711,8 @@
           <p:nvPr/>
         </p:nvGraphicFramePr>
         <p:xfrm>
-          <a:off x="540000" y="1152000"/>
-          <a:ext cx="8243998" cy="2880000"/>
+          <a:off x="731520" y="3840480"/>
+          <a:ext cx="7680960" cy="2011680"/>
         </p:xfrm>
         <a:graphic>
           <a:graphicData uri="http://schemas.openxmlformats.org/drawingml/2006/table">
@@ -6021,421 +6721,325 @@
                 <a:tableStyleId>{5C22544A-7EE6-4342-B048-85BDC9FD1C3A}</a:tableStyleId>
               </a:tblPr>
               <a:tblGrid>
-                <a:gridCol w="1533767"/>
-                <a:gridCol w="1342046"/>
-                <a:gridCol w="5368185"/>
+                <a:gridCol w="1097280"/>
+                <a:gridCol w="1005840"/>
+                <a:gridCol w="1188720"/>
+                <a:gridCol w="4389120"/>
               </a:tblGrid>
-              <a:tr h="480000">
-                <a:tc>
-                  <a:txBody>
-                    <a:bodyPr/>
-                    <a:lstStyle/>
-                    <a:p>
-                      <a:pPr algn="ctr"/>
-                      <a:r>
-                        <a:rPr sz="1500" b="1">
-                          <a:solidFill>
-                            <a:srgbClr val="FFFFFF"/>
-                          </a:solidFill>
-                          <a:latin typeface="Times New Roman"/>
-                        </a:rPr>
+              <a:tr h="402336">
+                <a:tc>
+                  <a:txBody>
+                    <a:bodyPr/>
+                    <a:lstStyle/>
+                    <a:p>
+                      <a:pPr algn="ctr">
+                        <a:defRPr sz="1100" b="1"/>
+                      </a:pPr>
+                      <a:r>
+                        <a:t>Mã Bug</a:t>
+                      </a:r>
+                    </a:p>
+                  </a:txBody>
+                  <a:tcPr/>
+                </a:tc>
+                <a:tc>
+                  <a:txBody>
+                    <a:bodyPr/>
+                    <a:lstStyle/>
+                    <a:p>
+                      <a:pPr algn="ctr">
+                        <a:defRPr sz="1100" b="1"/>
+                      </a:pPr>
+                      <a:r>
                         <a:t>Mức độ</a:t>
                       </a:r>
                     </a:p>
                   </a:txBody>
-                  <a:tcPr>
-                    <a:solidFill>
-                      <a:srgbClr val="1F3B63"/>
-                    </a:solidFill>
-                  </a:tcPr>
-                </a:tc>
-                <a:tc>
-                  <a:txBody>
-                    <a:bodyPr/>
-                    <a:lstStyle/>
-                    <a:p>
-                      <a:pPr algn="ctr"/>
-                      <a:r>
-                        <a:rPr sz="1500" b="1">
-                          <a:solidFill>
-                            <a:srgbClr val="FFFFFF"/>
-                          </a:solidFill>
-                          <a:latin typeface="Times New Roman"/>
-                        </a:rPr>
-                        <a:t>Số lượng</a:t>
-                      </a:r>
-                    </a:p>
-                  </a:txBody>
-                  <a:tcPr>
-                    <a:solidFill>
-                      <a:srgbClr val="1F3B63"/>
-                    </a:solidFill>
-                  </a:tcPr>
-                </a:tc>
-                <a:tc>
-                  <a:txBody>
-                    <a:bodyPr/>
-                    <a:lstStyle/>
-                    <a:p>
-                      <a:pPr algn="ctr"/>
-                      <a:r>
-                        <a:rPr sz="1500" b="1">
-                          <a:solidFill>
-                            <a:srgbClr val="FFFFFF"/>
-                          </a:solidFill>
-                          <a:latin typeface="Times New Roman"/>
-                        </a:rPr>
-                        <a:t>Ghi chú</a:t>
-                      </a:r>
-                    </a:p>
-                  </a:txBody>
-                  <a:tcPr>
-                    <a:solidFill>
-                      <a:srgbClr val="1F3B63"/>
-                    </a:solidFill>
-                  </a:tcPr>
+                  <a:tcPr/>
+                </a:tc>
+                <a:tc>
+                  <a:txBody>
+                    <a:bodyPr/>
+                    <a:lstStyle/>
+                    <a:p>
+                      <a:pPr algn="ctr">
+                        <a:defRPr sz="1100" b="1"/>
+                      </a:pPr>
+                      <a:r>
+                        <a:t>Phân hệ</a:t>
+                      </a:r>
+                    </a:p>
+                  </a:txBody>
+                  <a:tcPr/>
+                </a:tc>
+                <a:tc>
+                  <a:txBody>
+                    <a:bodyPr/>
+                    <a:lstStyle/>
+                    <a:p>
+                      <a:pPr algn="ctr">
+                        <a:defRPr sz="1100" b="1"/>
+                      </a:pPr>
+                      <a:r>
+                        <a:t>Mô tả lỗi phát hiện</a:t>
+                      </a:r>
+                    </a:p>
+                  </a:txBody>
+                  <a:tcPr/>
                 </a:tc>
               </a:tr>
-              <a:tr h="480000">
-                <a:tc>
-                  <a:txBody>
-                    <a:bodyPr/>
-                    <a:lstStyle/>
-                    <a:p>
-                      <a:pPr algn="l"/>
-                      <a:r>
-                        <a:rPr sz="1400">
-                          <a:latin typeface="Times New Roman"/>
-                        </a:rPr>
-                        <a:t>Critical</a:t>
-                      </a:r>
-                    </a:p>
-                  </a:txBody>
-                  <a:tcPr anchor="ctr"/>
-                </a:tc>
-                <a:tc>
-                  <a:txBody>
-                    <a:bodyPr/>
-                    <a:lstStyle/>
-                    <a:p>
-                      <a:pPr algn="ctr"/>
-                      <a:r>
-                        <a:rPr sz="1400">
-                          <a:latin typeface="Times New Roman"/>
-                        </a:rPr>
-                        <a:t>3</a:t>
-                      </a:r>
-                    </a:p>
-                  </a:txBody>
-                  <a:tcPr anchor="ctr"/>
-                </a:tc>
-                <a:tc>
-                  <a:txBody>
-                    <a:bodyPr/>
-                    <a:lstStyle/>
-                    <a:p>
-                      <a:pPr algn="ctr"/>
-                      <a:r>
-                        <a:rPr sz="1400">
-                          <a:latin typeface="Times New Roman"/>
-                        </a:rPr>
-                        <a:t>Tạo bài, tạo campaign, upload KYC</a:t>
-                      </a:r>
-                    </a:p>
-                  </a:txBody>
-                  <a:tcPr anchor="ctr"/>
+              <a:tr h="402336">
+                <a:tc>
+                  <a:txBody>
+                    <a:bodyPr/>
+                    <a:lstStyle/>
+                    <a:p>
+                      <a:pPr>
+                        <a:defRPr sz="1100"/>
+                      </a:pPr>
+                      <a:r>
+                        <a:t>BUG-001</a:t>
+                      </a:r>
+                    </a:p>
+                  </a:txBody>
+                  <a:tcPr/>
+                </a:tc>
+                <a:tc>
+                  <a:txBody>
+                    <a:bodyPr/>
+                    <a:lstStyle/>
+                    <a:p>
+                      <a:pPr>
+                        <a:defRPr sz="1100"/>
+                      </a:pPr>
+                      <a:r>
+                        <a:t>High</a:t>
+                      </a:r>
+                    </a:p>
+                  </a:txBody>
+                  <a:tcPr/>
+                </a:tc>
+                <a:tc>
+                  <a:txBody>
+                    <a:bodyPr/>
+                    <a:lstStyle/>
+                    <a:p>
+                      <a:pPr>
+                        <a:defRPr sz="1100"/>
+                      </a:pPr>
+                      <a:r>
+                        <a:t>PLEDGE</a:t>
+                      </a:r>
+                    </a:p>
+                  </a:txBody>
+                  <a:tcPr/>
+                </a:tc>
+                <a:tc>
+                  <a:txBody>
+                    <a:bodyPr/>
+                    <a:lstStyle/>
+                    <a:p>
+                      <a:pPr>
+                        <a:defRPr sz="1100"/>
+                      </a:pPr>
+                      <a:r>
+                        <a:t>API MoMo trả HTTP 410 ESCROW_BANK_ONLY nhưng Form thanh toán chưa ẩn nút</a:t>
+                      </a:r>
+                    </a:p>
+                  </a:txBody>
+                  <a:tcPr/>
                 </a:tc>
               </a:tr>
-              <a:tr h="480000">
-                <a:tc>
-                  <a:txBody>
-                    <a:bodyPr/>
-                    <a:lstStyle/>
-                    <a:p>
-                      <a:pPr algn="l"/>
-                      <a:r>
-                        <a:rPr sz="1400">
-                          <a:latin typeface="Times New Roman"/>
-                        </a:rPr>
+              <a:tr h="402336">
+                <a:tc>
+                  <a:txBody>
+                    <a:bodyPr/>
+                    <a:lstStyle/>
+                    <a:p>
+                      <a:pPr>
+                        <a:defRPr sz="1100"/>
+                      </a:pPr>
+                      <a:r>
+                        <a:t>BUG-002</a:t>
+                      </a:r>
+                    </a:p>
+                  </a:txBody>
+                  <a:tcPr/>
+                </a:tc>
+                <a:tc>
+                  <a:txBody>
+                    <a:bodyPr/>
+                    <a:lstStyle/>
+                    <a:p>
+                      <a:pPr>
+                        <a:defRPr sz="1100"/>
+                      </a:pPr>
+                      <a:r>
                         <a:t>High</a:t>
                       </a:r>
                     </a:p>
                   </a:txBody>
-                  <a:tcPr anchor="ctr"/>
-                </a:tc>
-                <a:tc>
-                  <a:txBody>
-                    <a:bodyPr/>
-                    <a:lstStyle/>
-                    <a:p>
-                      <a:pPr algn="ctr"/>
-                      <a:r>
-                        <a:rPr sz="1400">
-                          <a:latin typeface="Times New Roman"/>
-                        </a:rPr>
-                        <a:t>4</a:t>
-                      </a:r>
-                    </a:p>
-                  </a:txBody>
-                  <a:tcPr anchor="ctr"/>
-                </a:tc>
-                <a:tc>
-                  <a:txBody>
-                    <a:bodyPr/>
-                    <a:lstStyle/>
-                    <a:p>
-                      <a:pPr algn="ctr"/>
-                      <a:r>
-                        <a:rPr sz="1400">
-                          <a:latin typeface="Times New Roman"/>
-                        </a:rPr>
-                        <a:t>Sửa/xóa không có hiệu lực, thiếu validation</a:t>
-                      </a:r>
-                    </a:p>
-                  </a:txBody>
-                  <a:tcPr anchor="ctr"/>
+                  <a:tcPr/>
+                </a:tc>
+                <a:tc>
+                  <a:txBody>
+                    <a:bodyPr/>
+                    <a:lstStyle/>
+                    <a:p>
+                      <a:pPr>
+                        <a:defRPr sz="1100"/>
+                      </a:pPr>
+                      <a:r>
+                        <a:t>PLEDGE</a:t>
+                      </a:r>
+                    </a:p>
+                  </a:txBody>
+                  <a:tcPr/>
+                </a:tc>
+                <a:tc>
+                  <a:txBody>
+                    <a:bodyPr/>
+                    <a:lstStyle/>
+                    <a:p>
+                      <a:pPr>
+                        <a:defRPr sz="1100"/>
+                      </a:pPr>
+                      <a:r>
+                        <a:t>API VNPAY trả HTTP 410 ESCROW_BANK_ONLY nhưng Form thanh toán chưa ẩn nút</a:t>
+                      </a:r>
+                    </a:p>
+                  </a:txBody>
+                  <a:tcPr/>
                 </a:tc>
               </a:tr>
-              <a:tr h="480000">
-                <a:tc>
-                  <a:txBody>
-                    <a:bodyPr/>
-                    <a:lstStyle/>
-                    <a:p>
-                      <a:pPr algn="l"/>
-                      <a:r>
-                        <a:rPr sz="1400">
-                          <a:latin typeface="Times New Roman"/>
-                        </a:rPr>
+              <a:tr h="402336">
+                <a:tc>
+                  <a:txBody>
+                    <a:bodyPr/>
+                    <a:lstStyle/>
+                    <a:p>
+                      <a:pPr>
+                        <a:defRPr sz="1100"/>
+                      </a:pPr>
+                      <a:r>
+                        <a:t>BUG-003</a:t>
+                      </a:r>
+                    </a:p>
+                  </a:txBody>
+                  <a:tcPr/>
+                </a:tc>
+                <a:tc>
+                  <a:txBody>
+                    <a:bodyPr/>
+                    <a:lstStyle/>
+                    <a:p>
+                      <a:pPr>
+                        <a:defRPr sz="1100"/>
+                      </a:pPr>
+                      <a:r>
                         <a:t>Medium</a:t>
                       </a:r>
                     </a:p>
                   </a:txBody>
-                  <a:tcPr anchor="ctr"/>
-                </a:tc>
-                <a:tc>
-                  <a:txBody>
-                    <a:bodyPr/>
-                    <a:lstStyle/>
-                    <a:p>
-                      <a:pPr algn="ctr"/>
-                      <a:r>
-                        <a:rPr sz="1400">
-                          <a:latin typeface="Times New Roman"/>
-                        </a:rPr>
-                        <a:t>3</a:t>
-                      </a:r>
-                    </a:p>
-                  </a:txBody>
-                  <a:tcPr anchor="ctr"/>
-                </a:tc>
-                <a:tc>
-                  <a:txBody>
-                    <a:bodyPr/>
-                    <a:lstStyle/>
-                    <a:p>
-                      <a:pPr algn="ctr"/>
-                      <a:r>
-                        <a:rPr sz="1400">
-                          <a:latin typeface="Times New Roman"/>
-                        </a:rPr>
-                        <a:t>Thiếu kiểm tra dữ liệu, hiển thị sai trạng thái</a:t>
-                      </a:r>
-                    </a:p>
-                  </a:txBody>
-                  <a:tcPr anchor="ctr"/>
+                  <a:tcPr/>
+                </a:tc>
+                <a:tc>
+                  <a:txBody>
+                    <a:bodyPr/>
+                    <a:lstStyle/>
+                    <a:p>
+                      <a:pPr>
+                        <a:defRPr sz="1100"/>
+                      </a:pPr>
+                      <a:r>
+                        <a:t>CHAT</a:t>
+                      </a:r>
+                    </a:p>
+                  </a:txBody>
+                  <a:tcPr/>
+                </a:tc>
+                <a:tc>
+                  <a:txBody>
+                    <a:bodyPr/>
+                    <a:lstStyle/>
+                    <a:p>
+                      <a:pPr>
+                        <a:defRPr sz="1100"/>
+                      </a:pPr>
+                      <a:r>
+                        <a:t>WebRTC Video Call dùng polling 1200ms thay vì WebSocket / Realtime SSE</a:t>
+                      </a:r>
+                    </a:p>
+                  </a:txBody>
+                  <a:tcPr/>
                 </a:tc>
               </a:tr>
-              <a:tr h="480000">
-                <a:tc>
-                  <a:txBody>
-                    <a:bodyPr/>
-                    <a:lstStyle/>
-                    <a:p>
-                      <a:pPr algn="l"/>
-                      <a:r>
-                        <a:rPr sz="1400">
-                          <a:latin typeface="Times New Roman"/>
-                        </a:rPr>
+              <a:tr h="402336">
+                <a:tc>
+                  <a:txBody>
+                    <a:bodyPr/>
+                    <a:lstStyle/>
+                    <a:p>
+                      <a:pPr>
+                        <a:defRPr sz="1100"/>
+                      </a:pPr>
+                      <a:r>
+                        <a:t>BUG-004</a:t>
+                      </a:r>
+                    </a:p>
+                  </a:txBody>
+                  <a:tcPr/>
+                </a:tc>
+                <a:tc>
+                  <a:txBody>
+                    <a:bodyPr/>
+                    <a:lstStyle/>
+                    <a:p>
+                      <a:pPr>
+                        <a:defRPr sz="1100"/>
+                      </a:pPr>
+                      <a:r>
                         <a:t>Low</a:t>
                       </a:r>
                     </a:p>
                   </a:txBody>
-                  <a:tcPr anchor="ctr"/>
-                </a:tc>
-                <a:tc>
-                  <a:txBody>
-                    <a:bodyPr/>
-                    <a:lstStyle/>
-                    <a:p>
-                      <a:pPr algn="ctr"/>
-                      <a:r>
-                        <a:rPr sz="1400">
-                          <a:latin typeface="Times New Roman"/>
-                        </a:rPr>
-                        <a:t>2</a:t>
-                      </a:r>
-                    </a:p>
-                  </a:txBody>
-                  <a:tcPr anchor="ctr"/>
-                </a:tc>
-                <a:tc>
-                  <a:txBody>
-                    <a:bodyPr/>
-                    <a:lstStyle/>
-                    <a:p>
-                      <a:pPr algn="ctr"/>
-                      <a:r>
-                        <a:rPr sz="1400">
-                          <a:latin typeface="Times New Roman"/>
-                        </a:rPr>
-                        <a:t>Thứ tự hiển thị, thiếu thông báo</a:t>
-                      </a:r>
-                    </a:p>
-                  </a:txBody>
-                  <a:tcPr anchor="ctr"/>
-                </a:tc>
-              </a:tr>
-              <a:tr h="480000">
-                <a:tc>
-                  <a:txBody>
-                    <a:bodyPr/>
-                    <a:lstStyle/>
-                    <a:p>
-                      <a:pPr algn="l"/>
-                      <a:r>
-                        <a:rPr sz="1400">
-                          <a:latin typeface="Times New Roman"/>
-                        </a:rPr>
-                        <a:t>Tổng</a:t>
-                      </a:r>
-                    </a:p>
-                  </a:txBody>
-                  <a:tcPr anchor="ctr"/>
-                </a:tc>
-                <a:tc>
-                  <a:txBody>
-                    <a:bodyPr/>
-                    <a:lstStyle/>
-                    <a:p>
-                      <a:pPr algn="ctr"/>
-                      <a:r>
-                        <a:rPr sz="1400">
-                          <a:latin typeface="Times New Roman"/>
-                        </a:rPr>
-                        <a:t>12</a:t>
-                      </a:r>
-                    </a:p>
-                  </a:txBody>
-                  <a:tcPr anchor="ctr"/>
-                </a:tc>
-                <a:tc>
-                  <a:txBody>
-                    <a:bodyPr/>
-                    <a:lstStyle/>
-                    <a:p>
-                      <a:pPr algn="ctr"/>
-                      <a:r>
-                        <a:rPr sz="1400">
-                          <a:latin typeface="Times New Roman"/>
-                        </a:rPr>
-                        <a:t>12 lỗi – tất cả đang Open, chờ fix build v1.1</a:t>
-                      </a:r>
-                    </a:p>
-                  </a:txBody>
-                  <a:tcPr anchor="ctr"/>
+                  <a:tcPr/>
+                </a:tc>
+                <a:tc>
+                  <a:txBody>
+                    <a:bodyPr/>
+                    <a:lstStyle/>
+                    <a:p>
+                      <a:pPr>
+                        <a:defRPr sz="1100"/>
+                      </a:pPr>
+                      <a:r>
+                        <a:t>COMM</a:t>
+                      </a:r>
+                    </a:p>
+                  </a:txBody>
+                  <a:tcPr/>
+                </a:tc>
+                <a:tc>
+                  <a:txBody>
+                    <a:bodyPr/>
+                    <a:lstStyle/>
+                    <a:p>
+                      <a:pPr>
+                        <a:defRPr sz="1100"/>
+                      </a:pPr>
+                      <a:r>
+                        <a:t>API Feedback yêu cầu min 10 ký tự nhưng Form UI thiếu bộ đếm và validation</a:t>
+                      </a:r>
+                    </a:p>
+                  </a:txBody>
+                  <a:tcPr/>
                 </a:tc>
               </a:tr>
             </a:tbl>
           </a:graphicData>
         </a:graphic>
       </p:graphicFrame>
-      <p:sp>
-        <p:nvSpPr>
-          <p:cNvPr id="5" name="TextBox 4"/>
-          <p:cNvSpPr txBox="1"/>
-          <p:nvPr/>
-        </p:nvSpPr>
-        <p:spPr>
-          <a:xfrm>
-            <a:off x="540000" y="4320000"/>
-            <a:ext cx="8243999" cy="1620000"/>
-          </a:xfrm>
-          <a:prstGeom prst="rect">
-            <a:avLst/>
-          </a:prstGeom>
-          <a:noFill/>
-        </p:spPr>
-        <p:txBody>
-          <a:bodyPr wrap="square">
-            <a:spAutoFit/>
-          </a:bodyPr>
-          <a:lstStyle/>
-          <a:p>
-            <a:pPr>
-              <a:spcAft>
-                <a:spcPts val="900"/>
-              </a:spcAft>
-              <a:defRPr b="1" sz="1500">
-                <a:solidFill>
-                  <a:srgbClr val="1F4E78"/>
-                </a:solidFill>
-              </a:defRPr>
-            </a:pPr>
-            <a:r>
-              <a:t>Báo cáo Lỗi Thực tế (Bugs sinh từ FAIL):</a:t>
-            </a:r>
-          </a:p>
-          <a:p>
-            <a:pPr>
-              <a:defRPr sz="1200"/>
-            </a:pPr>
-            <a:r>
-              <a:t>• BUG-001 (High): Cổng MoMo trả HTTP 410 ESCROW_BANK_ONLY do tắt ví điện tử</a:t>
-            </a:r>
-          </a:p>
-          <a:p>
-            <a:pPr>
-              <a:defRPr sz="1200"/>
-            </a:pPr>
-            <a:r>
-              <a:t>• BUG-002 (High): Cổng VNPay trả HTTP 410 ESCROW_BANK_ONLY do đóng cổng trung gian</a:t>
-            </a:r>
-          </a:p>
-          <a:p>
-            <a:pPr>
-              <a:defRPr sz="1200"/>
-            </a:pPr>
-            <a:r>
-              <a:t>• BUG-003 (Medium): Truyền tín hiệu cuộc gọi P2P dùng Polling 1.2s thay vì WebSocket</a:t>
-            </a:r>
-          </a:p>
-          <a:p>
-            <a:pPr>
-              <a:defRPr sz="1200"/>
-            </a:pPr>
-            <a:r>
-              <a:t>• BUG-004 (Low): Form góp ý /gop-y thiếu validate trực tiếp trên client, gửi &lt; 10 ký tự nhận lỗi 400</a:t>
-            </a:r>
-          </a:p>
-          <a:p>
-            <a:pPr>
-              <a:defRPr sz="1200"/>
-            </a:pPr>
-            <a:r>
-              <a:t>• Tất cả 4 lỗi đều được kiểm chứng bằng lệnh curl hoặc log mã nguồn thực tế</a:t>
-            </a:r>
-          </a:p>
-          <a:p>
-            <a:pPr>
-              <a:defRPr sz="1200"/>
-            </a:pPr>
-            <a:r>
-              <a:t>• Đề xuất: Ẩn nút ví điện tử trên UI, bổ sung WebSocket và validate realtime client</a:t>
-            </a:r>
-          </a:p>
-        </p:txBody>
-      </p:sp>
     </p:spTree>
   </p:cSld>
   <p:clrMapOvr>
@@ -6589,79 +7193,30 @@
               <a:spcAft>
                 <a:spcPts val="900"/>
               </a:spcAft>
+              <a:defRPr sz="1400">
+                <a:solidFill>
+                  <a:srgbClr val="333333"/>
+                </a:solidFill>
+              </a:defRPr>
             </a:pPr>
             <a:r>
-              <a:rPr sz="1900" b="0">
-                <a:solidFill>
-                  <a:srgbClr val="000000"/>
-                </a:solidFill>
-                <a:latin typeface="Times New Roman"/>
-              </a:rPr>
-              <a:t>• 26 REQ (25 chức năng + 1 validation) → 24 TR → 54 TC</a:t>
-            </a:r>
-          </a:p>
-          <a:p>
-            <a:pPr>
-              <a:spcAft>
-                <a:spcPts val="900"/>
-              </a:spcAft>
-            </a:pPr>
-            <a:r>
-              <a:rPr sz="1900" b="0">
-                <a:solidFill>
-                  <a:srgbClr val="000000"/>
-                </a:solidFill>
-                <a:latin typeface="Times New Roman"/>
-              </a:rPr>
-              <a:t>• Mỗi TC đều truy xuất được về TR và REQ gốc</a:t>
-            </a:r>
-          </a:p>
-          <a:p>
-            <a:pPr>
-              <a:spcAft>
-                <a:spcPts val="900"/>
-              </a:spcAft>
-            </a:pPr>
-            <a:r>
-              <a:rPr sz="1900" b="0">
-                <a:solidFill>
-                  <a:srgbClr val="000000"/>
-                </a:solidFill>
-                <a:latin typeface="Times New Roman"/>
-              </a:rPr>
-              <a:t>• 25/26 REQ có test case (96%): REQ-CAMP-006 ngoài phạm vi Phase 1</a:t>
-            </a:r>
-          </a:p>
-          <a:p>
-            <a:pPr>
-              <a:spcAft>
-                <a:spcPts val="900"/>
-              </a:spcAft>
-            </a:pPr>
-            <a:r>
-              <a:rPr sz="1900" b="0">
-                <a:solidFill>
-                  <a:srgbClr val="000000"/>
-                </a:solidFill>
-                <a:latin typeface="Times New Roman"/>
-              </a:rPr>
-              <a:t>• Lưu tại sheet “Traceability Matrix” (64 dòng) trong file Test Case và trong Test Report</a:t>
-            </a:r>
-          </a:p>
-          <a:p>
-            <a:pPr>
-              <a:spcAft>
-                <a:spcPts val="900"/>
-              </a:spcAft>
-            </a:pPr>
-            <a:r>
-              <a:rPr sz="1900" b="0">
-                <a:solidFill>
-                  <a:srgbClr val="000000"/>
-                </a:solidFill>
-                <a:latin typeface="Times New Roman"/>
-              </a:rPr>
-              <a:t>• Giúp xác định ngay TC nào phải chạy lại khi sửa một lỗi</a:t>
+              <a:t>• Ma trận Truy xuất Nguồn gốc (Traceability Matrix - RTM):</a:t>
+            </a:r>
+            <a:br/>
+            <a:r>
+              <a:t>  – Chuỗi truy xuất khép kín: Mã nguồn → 10 Nhóm FR → 42 TRs → 105 TCs</a:t>
+            </a:r>
+            <a:br/>
+            <a:r>
+              <a:t>  – 100% 42 Yêu cầu kiểm thử (TRs) có từ 2–3 Test Cases bao phủ</a:t>
+            </a:r>
+            <a:br/>
+            <a:r>
+              <a:t>  – 100% ca kiểm thử truy xuất được điểm vào (route/API) và ràng buộc mã nguồn cụ thể</a:t>
+            </a:r>
+            <a:br/>
+            <a:r>
+              <a:t>  – Độ bao phủ yêu cầu kiểm thử: 42 / 42 TRs đạt ít nhất 1 TC đã thực thi (Độ bao phủ: 100%).</a:t>
             </a:r>
           </a:p>
         </p:txBody>

</xml_diff>